<commit_message>
Formato Assurance ITO v1.3: foco de solo HBP exige 3 o más HBP del mismo tema
Co-Authored-By: Claude Opus 5.5 <noreply@anthropic.com>
Claude-Session: https://claude.ai/code/session_017MaLNPnWzNhW9Tdfmjv67V
</commit_message>
<xml_diff>
--- a/FORMATO_ASSURANCE_ITO_v1.3.pptx
+++ b/FORMATO_ASSURANCE_ITO_v1.3.pptx
@@ -6504,7 +6504,7 @@
                 <a:ea typeface="Arial" pitchFamily="34" charset="-122"/>
                 <a:cs typeface="Arial" pitchFamily="34" charset="-120"/>
               </a:rPr>
-              <a:t>- N3: desviaciones de menor criticidad (HBP), que se resuelven con corrección inmediata o gestión directa en terreno. Los HBP no definen el nivel de un foco. Acompañan a los focos como evidencia complementaria, se usan en la franja RECURRENTE y, solo para completar filas vacías, un tema de HBP reiterado puede ser foco N2 (ver punto 3).</a:t>
+              <a:t>- N3: desviaciones de menor criticidad (HBP), que se resuelven con corrección inmediata o gestión directa en terreno. Los HBP no definen el nivel de un foco. Acompañan a los focos como evidencia complementaria, se usan en la franja RECURRENTE y un tema con 3 o más HBP puede ser foco N2 si queda una fila libre (ver punto 3). Con 1 o 2 HBP de un tema nunca se arma un foco.</a:t>
             </a:r>
             <a:endParaRPr lang="en-US" sz="600" dirty="0"/>
           </a:p>
@@ -6861,7 +6861,7 @@
                 <a:ea typeface="Arial" pitchFamily="34" charset="-122"/>
                 <a:cs typeface="Arial" pitchFamily="34" charset="-120"/>
               </a:rPr>
-              <a:t>- COMPLETAR FILAS CON HBP: si con los eventos N1/N2 quedan menos de 4 focos, completa las filas vacías con temas de HBP reiterados (2 o más HBP de la misma brecha) que no estén ya en un foco, priorizando los asociados a controles críticos o a emergencias (extintores, vías de evacuación, energía). Son siempre N2 y van después de todos los focos con eventos N1/N2. Ej.: gerencia 08-09, foco 4 "equipos de emergencia" con HBP 548906 y 549552.</a:t>
+              <a:t>- FOCO DE SOLO HBP: solo si hay 3 o más HBP del período relacionados con la misma brecha y que no estén ya en otro foco. Con 1 o 2 HBP de un tema NUNCA se arma un foco (van como evidencia complementaria o en Recurrente). Estos focos son siempre N2, van después de todos los focos con eventos N1/N2 y solo entran si queda una fila libre (máx. 4 focos). Si hay varios temas HBP que califican, entra primero el de más HBP y, si empatan, el asociado a control crítico o emergencia. OJO: la gerencia al 08-09 puso un foco con solo 2 HBP (extintores); según esta regla ese foco NO va.</a:t>
             </a:r>
             <a:endParaRPr lang="en-US" sz="600" dirty="0"/>
           </a:p>
@@ -6963,7 +6963,7 @@
                 <a:ea typeface="Arial" pitchFamily="34" charset="-122"/>
                 <a:cs typeface="Arial" pitchFamily="34" charset="-120"/>
               </a:rPr>
-              <a:t>  - N2 · CRITICIDAD INTERMEDIA (celda naranja E67E22) si el foco tiene un solo evento N1/N2 (HAP o CBP), con o sin HBP complementarios, o si es un foco de solo HBP (punto 3).</a:t>
+              <a:t>  - N2 · CRITICIDAD INTERMEDIA (celda naranja E67E22) si el foco tiene un solo evento N1/N2 (HAP o CBP), con o sin HBP complementarios, o si es un foco de solo HBP (3 o más HBP del mismo tema, punto 3).</a:t>
             </a:r>
             <a:endParaRPr lang="en-US" sz="600" dirty="0"/>
           </a:p>
@@ -7116,7 +7116,7 @@
                 <a:ea typeface="Arial" pitchFamily="34" charset="-122"/>
                 <a:cs typeface="Arial" pitchFamily="34" charset="-120"/>
               </a:rPr>
-              <a:t>  - Cierre 08-09: 1° Izaje – certificación y línea de fuego (HAP + CBP, N1) · 2° Andamios (HAP + HAP + 2 HBP, N1: su evento más grave es HAP, menos grave que el CBP del 1°) · 3° Tableros eléctricos (HAP + 3 HBP, N2) · 4° Equipos de emergencia (solo 2 HBP, N2).</a:t>
+              <a:t>  - Cierre 08-09: 1° Izaje – certificación y línea de fuego (HAP + CBP, N1) · 2° Andamios (HAP + HAP + 2 HBP, N1: su evento más grave es HAP, menos grave que el CBP del 1°) · 3° Tableros eléctricos (HAP + 3 HBP, N2). La gerencia agregó un 4° foco de equipos de emergencia con solo 2 HBP: con nuestra regla NO va, porque se necesitan 3 o más HBP del mismo tema. En su lugar entra, si califica, el tema HBP con 3 o más eventos (ver ejemplo 2).</a:t>
             </a:r>
             <a:endParaRPr lang="en-US" sz="600" dirty="0"/>
           </a:p>
@@ -8085,7 +8085,7 @@
                 <a:ea typeface="Arial" pitchFamily="34" charset="-122"/>
                 <a:cs typeface="Arial" pitchFamily="34" charset="-120"/>
               </a:rPr>
-              <a:t>Antes de entregar, confirma que: el título dice "ASSURANCE TURNO 1-3" o "ASSURANCE TURNO 2-4" (sin corchetes); cada ID existe en el Excel; el nivel de cada foco sigue el punto 4 (2 o más eventos N1/N2 = N1); las áreas son nombres exactos de AREA_GEO; revisaste los eventos abiertos a la fecha de cierre; cada foco nace de al menos un evento N1/N2, salvo los focos de solo HBP que completan filas; todos los focos N1 van antes que los N2; dentro de cada nivel, los focos con reiteración/evidencia van antes que los aislados y se ordenan como indica el punto 4; ningún tema se llama "Otro"; los eventos con riesgo "Otro" fueron asignados a un tema leyendo su descripción; cada foco contiene al menos un dato concreto de sus eventos; el NIVEL (color) de cada foco corresponde a su evento más grave y la PRIORIDAD (orden) sigue el punto 4; ningún HBP definió un nivel; los conteos de indicadores y Recurrente cuadran; y no quedan textos guía.</a:t>
+              <a:t>Antes de entregar, confirma que: el título dice "ASSURANCE TURNO 1-3" o "ASSURANCE TURNO 2-4" (sin corchetes); cada ID existe en el Excel; el nivel de cada foco sigue el punto 4 (2 o más eventos N1/N2 = N1); las áreas son nombres exactos de AREA_GEO; revisaste los eventos abiertos a la fecha de cierre; cada foco nace de al menos un evento N1/N2, salvo los focos de solo HBP, que tienen 3 o más HBP del mismo tema; todos los focos N1 van antes que los N2; dentro de cada nivel, los focos con reiteración/evidencia van antes que los aislados y se ordenan como indica el punto 4; ningún tema se llama "Otro"; los eventos con riesgo "Otro" fueron asignados a un tema leyendo su descripción; cada foco contiene al menos un dato concreto de sus eventos; el NIVEL (color) de cada foco corresponde a su evento más grave y la PRIORIDAD (orden) sigue el punto 4; ningún HBP definió un nivel; los conteos de indicadores y Recurrente cuadran; y no quedan textos guía.</a:t>
             </a:r>
             <a:endParaRPr lang="en-US" sz="600" dirty="0"/>
           </a:p>
@@ -9156,7 +9156,7 @@
                 <a:ea typeface="Arial" pitchFamily="34" charset="-122"/>
                 <a:cs typeface="Arial" pitchFamily="34" charset="-120"/>
               </a:rPr>
-              <a:t>FOCO 4 · N2 · CRITICIDAD INTERMEDIA (foco de solo HBP para completar filas; tema de emergencia)</a:t>
+              <a:t>FOCO 4 DE LA GERENCIA – NO SE REPLICA (solo 2 HBP; nuestra regla exige 3 o más HBP del mismo tema). Se deja solo como referencia de redacción:</a:t>
             </a:r>
             <a:endParaRPr lang="en-US" sz="600" dirty="0"/>
           </a:p>
@@ -9275,7 +9275,7 @@
                 <a:ea typeface="Arial" pitchFamily="34" charset="-122"/>
                 <a:cs typeface="Arial" pitchFamily="34" charset="-120"/>
               </a:rPr>
-              <a:t>Por qué ese orden: focos 1 y 2 son N1 por reiteración; el 1 va primero porque su evento más grave es un CBP (el del 2 es HAP). Foco 3 es N2 con un evento N1/N2; foco 4 es solo HBP y va al final.</a:t>
+              <a:t>Por qué ese orden: focos 1 y 2 son N1 por reiteración; el 1 va primero porque su evento más grave es un CBP (el del 2 es HAP). Foco 3 es N2 con un evento N1/N2. Con nuestra regla, la fila 4 la ocupa el tema de HBP con 3 o más eventos que no esté en otro foco (en este período: materiales sin segregar y piezas/herramientas de andamio a nivel de piso, 8 HBP), como foco N2; el Recurrente pasa a mostrar el siguiente tema HBP repetido. Si no hubiera ningún tema con 3 o más HBP, se elimina la fila 4.</a:t>
             </a:r>
             <a:endParaRPr lang="en-US" sz="600" dirty="0"/>
           </a:p>
@@ -10129,7 +10129,7 @@
                 <a:ea typeface="Arial" pitchFamily="34" charset="-122"/>
                 <a:cs typeface="Arial" pitchFamily="34" charset="-120"/>
               </a:rPr>
-              <a:t>Foco = brecha específica con eventos N1/N2; HBP del mismo tema = evidencia. Si faltan filas, un tema HBP reiterado puede ser foco N2. Orden: todo N1 → todo N2. En N1: reiterados, luego más grave. En N2: con evento N1/N2, luego más eventos. Máx. 4.</a:t>
+              <a:t>Foco = brecha específica con eventos N1/N2; HBP del mismo tema = evidencia. 3+ HBP del mismo tema = foco N2 si queda fila. Orden: todo N1 → todo N2. En N1: reiterados, luego más grave. En N2: con evento N1/N2, luego más eventos. Máx. 4.</a:t>
             </a:r>
             <a:endParaRPr lang="en-US" sz="930" dirty="0"/>
           </a:p>
@@ -10312,7 +10312,7 @@
                 <a:ea typeface="Arial" pitchFamily="34" charset="-122"/>
                 <a:cs typeface="Arial" pitchFamily="34" charset="-120"/>
               </a:rPr>
-              <a:t>Define el color. N1 · alta (roja): ACC con lesión o daño material, CAAP, o 2 o más HAP/CBP del mismo tema (reiteración). N2 · intermedia (naranja): un solo HAP o CBP, o foco de solo HBP. Los HBP no cuentan para el nivel.</a:t>
+              <a:t>Define el color. N1 · alta (roja): ACC con lesión o daño material, CAAP, o 2 o más HAP/CBP del mismo tema (reiteración). N2 · intermedia (naranja): un solo HAP o CBP, o foco de 3+ HBP. Los HBP no cuentan para el nivel.</a:t>
             </a:r>
             <a:endParaRPr lang="en-US" sz="930" dirty="0"/>
           </a:p>
@@ -12201,7 +12201,7 @@
                 <a:ea typeface="Arial" pitchFamily="34" charset="-122"/>
                 <a:cs typeface="Arial" pitchFamily="34" charset="-120"/>
               </a:rPr>
-              <a:t>corrección inmediata; no define nivel. Va como evidencia complementaria y en Recurrente; un tema HBP reiterado solo es foco (N2) para completar filas.</a:t>
+              <a:t>corrección inmediata; no define nivel. Va como evidencia complementaria y en Recurrente; un tema con 3 o más HBP puede ser foco N2 si queda fila libre.</a:t>
             </a:r>
             <a:endParaRPr lang="en-US" sz="930" dirty="0"/>
           </a:p>

</xml_diff>

<commit_message>
Formato Assurance ITO v1.3: revalorización de CBP a CA (criterio de la gerencia)
Co-Authored-By: Claude Opus 5.5 <noreply@anthropic.com>
Claude-Session: https://claude.ai/code/session_017MaLNPnWzNhW9Tdfmjv67V
</commit_message>
<xml_diff>
--- a/FORMATO_ASSURANCE_ITO_v1.3.pptx
+++ b/FORMATO_ASSURANCE_ITO_v1.3.pptx
@@ -6946,7 +6946,7 @@
                 <a:ea typeface="Arial" pitchFamily="34" charset="-122"/>
                 <a:cs typeface="Arial" pitchFamily="34" charset="-120"/>
               </a:rPr>
-              <a:t>  - N1 · CRITICIDAD ALTA (celda roja C62828) si el foco tiene: un ACC (con lesión o daño material), o un CAAP, o 2 o más eventos N1/N2 del mismo tema (reiteración: p. ej., HAP + CBP, o HAP + HAP).</a:t>
+              <a:t>  - N1 · CRITICIDAD ALTA (celda roja C62828) si el foco tiene: un ACC (con lesión o daño material), o un CAAP, o un CBP revalorizado como CA, o 2 o más eventos N1/N2 del mismo tema (reiteración: p. ej., HAP + CBP, o HAP + HAP).</a:t>
             </a:r>
             <a:endParaRPr lang="en-US" sz="600" dirty="0"/>
           </a:p>
@@ -7014,6 +7014,91 @@
                 <a:ea typeface="Arial" pitchFamily="34" charset="-122"/>
                 <a:cs typeface="Arial" pitchFamily="34" charset="-120"/>
               </a:rPr>
+              <a:t>REVALORACIÓN DE POTENCIAL – CBP → CA (criterio de la gerencia)</a:t>
+            </a:r>
+            <a:endParaRPr lang="en-US" sz="600" dirty="0"/>
+          </a:p>
+          <a:p>
+            <a:pPr marL="0" indent="0">
+              <a:buNone/>
+            </a:pPr>
+            <a:r>
+              <a:rPr lang="en-US" sz="600" dirty="0">
+                <a:solidFill>
+                  <a:srgbClr val="222222"/>
+                </a:solidFill>
+                <a:latin typeface="Arial" pitchFamily="34" charset="0"/>
+                <a:ea typeface="Arial" pitchFamily="34" charset="-122"/>
+                <a:cs typeface="Arial" pitchFamily="34" charset="-120"/>
+              </a:rPr>
+              <a:t>  - Un CBP se trata como CA (cuasi accidente de alto potencial, equivalente a CAAP: N1) cuando su "Descripción" muestra a una persona efectivamente expuesta a: (1) línea de fuego de un equipo o vehículo en movimiento (p. ej., retroceso, aculatamiento, giro), (2) carga suspendida, o (3) energía peligrosa energizada (eléctrica, presión). Ej.: CBP 549924 – rigger a 2 m de un camión pluma en retroceso, sin radio → la gerencia lo registró como "CA ID 549924".</a:t>
+            </a:r>
+            <a:endParaRPr lang="en-US" sz="600" dirty="0"/>
+          </a:p>
+          <a:p>
+            <a:pPr marL="0" indent="0">
+              <a:buNone/>
+            </a:pPr>
+            <a:r>
+              <a:rPr lang="en-US" sz="600" dirty="0">
+                <a:solidFill>
+                  <a:srgbClr val="222222"/>
+                </a:solidFill>
+                <a:latin typeface="Arial" pitchFamily="34" charset="0"/>
+                <a:ea typeface="Arial" pitchFamily="34" charset="-122"/>
+                <a:cs typeface="Arial" pitchFamily="34" charset="-120"/>
+              </a:rPr>
+              <a:t>  - NO se revaloriza por riesgos solo potenciales o sin exposición concreta descrita (p. ej., CBP 554227, retiro de eslinga en borde de zanja sin altura indicada, se mantuvo como CBP).</a:t>
+            </a:r>
+            <a:endParaRPr lang="en-US" sz="600" dirty="0"/>
+          </a:p>
+          <a:p>
+            <a:pPr marL="0" indent="0">
+              <a:buNone/>
+            </a:pPr>
+            <a:r>
+              <a:rPr lang="en-US" sz="600" dirty="0">
+                <a:solidFill>
+                  <a:srgbClr val="222222"/>
+                </a:solidFill>
+                <a:latin typeface="Arial" pitchFamily="34" charset="0"/>
+                <a:ea typeface="Arial" pitchFamily="34" charset="-122"/>
+                <a:cs typeface="Arial" pitchFamily="34" charset="-120"/>
+              </a:rPr>
+              <a:t>  - En la columna Evento se escribe "CA ID [N°] – EMPRESA: …". Para el nivel y la prioridad cuenta como CAAP. En la franja de indicadores se mantiene la clasificación del Excel (sigue contándose como CBP).</a:t>
+            </a:r>
+            <a:endParaRPr lang="en-US" sz="600" dirty="0"/>
+          </a:p>
+          <a:p>
+            <a:pPr marL="0" indent="0">
+              <a:buNone/>
+            </a:pPr>
+            <a:r>
+              <a:rPr lang="en-US" sz="600" dirty="0">
+                <a:solidFill>
+                  <a:srgbClr val="222222"/>
+                </a:solidFill>
+                <a:latin typeface="Arial" pitchFamily="34" charset="0"/>
+                <a:ea typeface="Arial" pitchFamily="34" charset="-122"/>
+                <a:cs typeface="Arial" pitchFamily="34" charset="-120"/>
+              </a:rPr>
+              <a:t>  - Toda revalorización debe informarse al usuario en el control de calidad (ID, clasificación original y motivo). Ante la duda, no revalorices y menciónalo como posible CA.</a:t>
+            </a:r>
+            <a:endParaRPr lang="en-US" sz="600" dirty="0"/>
+          </a:p>
+          <a:p>
+            <a:pPr marL="0" indent="0">
+              <a:buNone/>
+            </a:pPr>
+            <a:r>
+              <a:rPr lang="en-US" sz="600" dirty="0">
+                <a:solidFill>
+                  <a:srgbClr val="222222"/>
+                </a:solidFill>
+                <a:latin typeface="Arial" pitchFamily="34" charset="0"/>
+                <a:ea typeface="Arial" pitchFamily="34" charset="-122"/>
+                <a:cs typeface="Arial" pitchFamily="34" charset="-120"/>
+              </a:rPr>
               <a:t>PRIORIDAD = orden del foco en la tabla (foco 1 = primera fila). Es el número que va en la celda.</a:t>
             </a:r>
             <a:endParaRPr lang="en-US" sz="600" dirty="0"/>
@@ -7116,7 +7201,7 @@
                 <a:ea typeface="Arial" pitchFamily="34" charset="-122"/>
                 <a:cs typeface="Arial" pitchFamily="34" charset="-120"/>
               </a:rPr>
-              <a:t>  - Cierre 08-09: 1° Izaje – certificación y línea de fuego (HAP + CBP, N1) · 2° Andamios (HAP + HAP + 2 HBP, N1: su evento más grave es HAP, menos grave que el CBP del 1°) · 3° Tableros eléctricos (HAP + 3 HBP, N2). La gerencia agregó un 4° foco de equipos de emergencia con solo 2 HBP: con nuestra regla NO va, porque se necesitan 3 o más HBP del mismo tema. En su lugar entra, si califica, el tema HBP con 3 o más eventos (ver ejemplo 2).</a:t>
+              <a:t>  - Cierre 08-09: 1° Izaje – certificación y línea de fuego (HAP + CA 549924, N1: el CBP se revaloriza a CA por línea de fuego) · 2° Andamios (HAP + HAP + 2 HBP, N1 por reiteración; su evento más grave es HAP, menos grave que el CA del 1°) · 3° Tableros eléctricos (HAP + 3 HBP, N2). La gerencia agregó un 4° foco de equipos de emergencia con solo 2 HBP: con nuestra regla NO va, porque se necesitan 3 o más HBP del mismo tema. En su lugar entra, si califica, el tema HBP con 3 o más eventos (ver ejemplo 2).</a:t>
             </a:r>
             <a:endParaRPr lang="en-US" sz="600" dirty="0"/>
           </a:p>
@@ -7388,7 +7473,7 @@
                 <a:ea typeface="Arial" pitchFamily="34" charset="-122"/>
                 <a:cs typeface="Arial" pitchFamily="34" charset="-120"/>
               </a:rPr>
-              <a:t>- Formato fijo por evento, igual que la gerencia: "TIPO ID 555505 – EMPRESA:" (en negrita) + qué ocurrió, en una frase concreta de hasta 120 caracteres con los datos del evento (equipo, carga, lugar, medida). TIPO = ACC, CAAP, HAP, CBP o HBP. Sin marca de turno.</a:t>
+              <a:t>- Formato fijo por evento, igual que la gerencia: "TIPO ID 555505 – EMPRESA:" (en negrita) + qué ocurrió, en una frase concreta de hasta 120 caracteres con los datos del evento (equipo, carga, lugar, medida). TIPO = ACC, CAAP, CA (CBP revalorizado, punto 4), HAP, CBP o HBP. Sin marca de turno.</a:t>
             </a:r>
             <a:endParaRPr lang="en-US" sz="600" dirty="0"/>
           </a:p>
@@ -8068,6 +8153,23 @@
                 <a:ea typeface="Arial" pitchFamily="34" charset="-122"/>
                 <a:cs typeface="Arial" pitchFamily="34" charset="-120"/>
               </a:rPr>
+              <a:t>- CBP revalorizados como CA (ID, clasificación original y motivo) y posibles CA que no revalorizaste;</a:t>
+            </a:r>
+            <a:endParaRPr lang="en-US" sz="600" dirty="0"/>
+          </a:p>
+          <a:p>
+            <a:pPr marL="0" indent="0">
+              <a:buNone/>
+            </a:pPr>
+            <a:r>
+              <a:rPr lang="en-US" sz="600" dirty="0">
+                <a:solidFill>
+                  <a:srgbClr val="222222"/>
+                </a:solidFill>
+                <a:latin typeface="Arial" pitchFamily="34" charset="0"/>
+                <a:ea typeface="Arial" pitchFamily="34" charset="-122"/>
+                <a:cs typeface="Arial" pitchFamily="34" charset="-120"/>
+              </a:rPr>
               <a:t>- datos faltantes o inconsistentes y supuestos realizados.</a:t>
             </a:r>
             <a:endParaRPr lang="en-US" sz="600" dirty="0"/>
@@ -8833,7 +8935,7 @@
                 <a:ea typeface="Arial" pitchFamily="34" charset="-122"/>
                 <a:cs typeface="Arial" pitchFamily="34" charset="-120"/>
               </a:rPr>
-              <a:t>FOCO 1 · N1 · CRITICIDAD ALTA (N1 por reiteración: HAP + CBP)</a:t>
+              <a:t>FOCO 1 · N1 · CRITICIDAD ALTA (N1: incluye un CA – CBP revalorizado por línea de fuego – y además hay reiteración)</a:t>
             </a:r>
             <a:endParaRPr lang="en-US" sz="600" dirty="0"/>
           </a:p>
@@ -8867,24 +8969,24 @@
                 <a:ea typeface="Arial" pitchFamily="34" charset="-122"/>
                 <a:cs typeface="Arial" pitchFamily="34" charset="-120"/>
               </a:rPr>
-              <a:t>- Evento: "HAP ID 547717 – PUMA: izaje de ducto Ø1.200 mm con grillete sin certificación. CBP ID 549924 – PUMA: rigger expuesto a línea de fuego en aculatamiento de camión pluma, sin radio."</a:t>
-            </a:r>
-            <a:endParaRPr lang="en-US" sz="600" dirty="0"/>
-          </a:p>
-          <a:p>
-            <a:pPr marL="0" indent="0">
-              <a:buNone/>
-            </a:pPr>
-            <a:r>
-              <a:rPr lang="en-US" sz="600" dirty="0">
-                <a:solidFill>
-                  <a:srgbClr val="222222"/>
-                </a:solidFill>
-                <a:latin typeface="Arial" pitchFamily="34" charset="0"/>
-                <a:ea typeface="Arial" pitchFamily="34" charset="-122"/>
-                <a:cs typeface="Arial" pitchFamily="34" charset="-120"/>
-              </a:rPr>
-              <a:t>  (Ojo: el CBP 549924 figura en el Excel con riesgo "Operación de vehículos livianos", pero por su descripción es de izaje.)</a:t>
+              <a:t>- Evento: "HAP ID 547717 – PUMA: izaje de ducto Ø1.200 mm con grillete sin certificación. CA ID 549924 – PUMA: rigger expuesto a línea de fuego en aculatamiento de camión pluma, sin radio."</a:t>
+            </a:r>
+            <a:endParaRPr lang="en-US" sz="600" dirty="0"/>
+          </a:p>
+          <a:p>
+            <a:pPr marL="0" indent="0">
+              <a:buNone/>
+            </a:pPr>
+            <a:r>
+              <a:rPr lang="en-US" sz="600" dirty="0">
+                <a:solidFill>
+                  <a:srgbClr val="222222"/>
+                </a:solidFill>
+                <a:latin typeface="Arial" pitchFamily="34" charset="0"/>
+                <a:ea typeface="Arial" pitchFamily="34" charset="-122"/>
+                <a:cs typeface="Arial" pitchFamily="34" charset="-120"/>
+              </a:rPr>
+              <a:t>  (Ojo: en el Excel el 549924 es CBP y su riesgo dice "Operación de vehículos livianos". La gerencia lo revalorizó a CA porque el rigger quedó expuesto a la línea de fuego de un equipo en retroceso, y por su descripción es de izaje.)</a:t>
             </a:r>
             <a:endParaRPr lang="en-US" sz="600" dirty="0"/>
           </a:p>
@@ -9275,7 +9377,7 @@
                 <a:ea typeface="Arial" pitchFamily="34" charset="-122"/>
                 <a:cs typeface="Arial" pitchFamily="34" charset="-120"/>
               </a:rPr>
-              <a:t>Por qué ese orden: focos 1 y 2 son N1 por reiteración; el 1 va primero porque su evento más grave es un CBP (el del 2 es HAP). Foco 3 es N2 con un evento N1/N2. Con nuestra regla, la fila 4 la ocupa el tema de HBP con 3 o más eventos que no esté en otro foco (en este período: materiales sin segregar y piezas/herramientas de andamio a nivel de piso, 8 HBP), como foco N2; el Recurrente pasa a mostrar el siguiente tema HBP repetido. Si no hubiera ningún tema con 3 o más HBP, se elimina la fila 4.</a:t>
+              <a:t>Por qué ese orden: focos 1 y 2 son N1; el 1 va primero porque contiene un CA (equivale a CAAP) y el 2 solo HAP. Foco 3 es N2 con un evento N1/N2. Con nuestra regla, la fila 4 la ocupa el tema de HBP con 3 o más eventos que no esté en otro foco (en este período: materiales sin segregar y piezas/herramientas de andamio a nivel de piso, 8 HBP), como foco N2; el Recurrente pasa a mostrar el siguiente tema HBP repetido. Si no hubiera ningún tema con 3 o más HBP, se elimina la fila 4.</a:t>
             </a:r>
             <a:endParaRPr lang="en-US" sz="600" dirty="0"/>
           </a:p>
@@ -10312,7 +10414,7 @@
                 <a:ea typeface="Arial" pitchFamily="34" charset="-122"/>
                 <a:cs typeface="Arial" pitchFamily="34" charset="-120"/>
               </a:rPr>
-              <a:t>Define el color. N1 · alta (roja): ACC con lesión o daño material, CAAP, o 2 o más HAP/CBP del mismo tema (reiteración). N2 · intermedia (naranja): un solo HAP o CBP, o foco de 3+ HBP. Los HBP no cuentan para el nivel.</a:t>
+              <a:t>Define el color. N1 · alta (roja): ACC, CAAP, CBP revalorizado a CA, o 2 o más HAP/CBP del mismo tema (reiteración). N2 · intermedia (naranja): un solo HAP o CBP, o foco de 3+ HBP. Los HBP no cuentan para el nivel.</a:t>
             </a:r>
             <a:endParaRPr lang="en-US" sz="930" dirty="0"/>
           </a:p>
@@ -12118,7 +12220,7 @@
               <a:buChar char="•"/>
             </a:pPr>
             <a:r>
-              <a:rPr lang="en-US" sz="740" dirty="0" b="1">
+              <a:rPr lang="en-US" sz="700" dirty="0" b="1">
                 <a:solidFill>
                   <a:srgbClr val="C62828"/>
                 </a:solidFill>
@@ -12129,15 +12231,15 @@
               <a:t>N1 · Criticidad alta: </a:t>
             </a:r>
             <a:r>
-              <a:rPr lang="en-US" sz="740" dirty="0" b="0">
-                <a:solidFill>
-                  <a:srgbClr val="222222"/>
-                </a:solidFill>
-                <a:latin typeface="Arial" pitchFamily="34" charset="0"/>
-                <a:ea typeface="Arial" pitchFamily="34" charset="-122"/>
-                <a:cs typeface="Arial" pitchFamily="34" charset="-120"/>
-              </a:rPr>
-              <a:t>consecuencias graves o fatales; gestión prioritaria. ACC con lesión o daño material, CAAP, o reiteración de 2 o más HAP/CBP del mismo tema.</a:t>
+              <a:rPr lang="en-US" sz="700" dirty="0" b="0">
+                <a:solidFill>
+                  <a:srgbClr val="222222"/>
+                </a:solidFill>
+                <a:latin typeface="Arial" pitchFamily="34" charset="0"/>
+                <a:ea typeface="Arial" pitchFamily="34" charset="-122"/>
+                <a:cs typeface="Arial" pitchFamily="34" charset="-120"/>
+              </a:rPr>
+              <a:t>consecuencias graves o fatales; gestión prioritaria. ACC con lesión o daño material, CAAP, CBP revalorizado como CA (persona expuesta a línea de fuego, carga suspendida o energía) o 2 o más HAP/CBP del mismo tema.</a:t>
             </a:r>
             <a:endParaRPr lang="en-US" sz="930" dirty="0"/>
           </a:p>
@@ -12150,7 +12252,7 @@
               <a:buChar char="•"/>
             </a:pPr>
             <a:r>
-              <a:rPr lang="en-US" sz="740" dirty="0" b="1">
+              <a:rPr lang="en-US" sz="700" dirty="0" b="1">
                 <a:solidFill>
                   <a:srgbClr val="B35C00"/>
                 </a:solidFill>
@@ -12161,7 +12263,7 @@
               <a:t>N2 · Criticidad intermedia: </a:t>
             </a:r>
             <a:r>
-              <a:rPr lang="en-US" sz="740" dirty="0" b="0">
+              <a:rPr lang="en-US" sz="700" dirty="0" b="0">
                 <a:solidFill>
                   <a:srgbClr val="222222"/>
                 </a:solidFill>
@@ -12182,7 +12284,7 @@
               <a:buChar char="•"/>
             </a:pPr>
             <a:r>
-              <a:rPr lang="en-US" sz="740" dirty="0" b="1">
+              <a:rPr lang="en-US" sz="700" dirty="0" b="1">
                 <a:solidFill>
                   <a:srgbClr val="222222"/>
                 </a:solidFill>
@@ -12193,7 +12295,7 @@
               <a:t>N3 · HBP: </a:t>
             </a:r>
             <a:r>
-              <a:rPr lang="en-US" sz="740" dirty="0" b="0">
+              <a:rPr lang="en-US" sz="700" dirty="0" b="0">
                 <a:solidFill>
                   <a:srgbClr val="222222"/>
                 </a:solidFill>
@@ -12214,7 +12316,7 @@
               <a:buChar char="•"/>
             </a:pPr>
             <a:r>
-              <a:rPr lang="en-US" sz="740" dirty="0" b="1">
+              <a:rPr lang="en-US" sz="700" dirty="0" b="1">
                 <a:solidFill>
                   <a:srgbClr val="1F3D6B"/>
                 </a:solidFill>
@@ -12225,7 +12327,7 @@
               <a:t>Nivel ≠ prioridad: </a:t>
             </a:r>
             <a:r>
-              <a:rPr lang="en-US" sz="740" dirty="0" b="0">
+              <a:rPr lang="en-US" sz="700" dirty="0" b="0">
                 <a:solidFill>
                   <a:srgbClr val="222222"/>
                 </a:solidFill>

</xml_diff>

<commit_message>
Assurance ITO v1.3: corregir inconsistencias y exportar instrucciones IA para validación
Co-Authored-By: Claude Opus 5.5 <noreply@anthropic.com>
Claude-Session: https://claude.ai/code/session_017MaLNPnWzNhW9Tdfmjv67V
</commit_message>
<xml_diff>
--- a/FORMATO_ASSURANCE_ITO_v1.3.pptx
+++ b/FORMATO_ASSURANCE_ITO_v1.3.pptx
@@ -7388,7 +7388,7 @@
                 <a:ea typeface="Arial" pitchFamily="34" charset="-122"/>
                 <a:cs typeface="Arial" pitchFamily="34" charset="-120"/>
               </a:rPr>
-              <a:t>- Ejemplos válidos: los del punto 16 (textos reales de la gerencia).</a:t>
+              <a:t>- Ejemplos válidos: los de los puntos 16 y 17 (textos reales de la gerencia).</a:t>
             </a:r>
             <a:endParaRPr lang="en-US" sz="600" dirty="0"/>
           </a:p>
@@ -7728,7 +7728,7 @@
                 <a:ea typeface="Arial" pitchFamily="34" charset="-122"/>
                 <a:cs typeface="Arial" pitchFamily="34" charset="-120"/>
               </a:rPr>
-              <a:t>- Bloque AM y Bloque Mediodía: nombres EXACTOS de "AREA_GEO" de los eventos de los focos asignados a cada bloque (como la gerencia: "Pila Oeste · Piscinas ILS–PLS · Izaje"; "Pilas de Lixiviación · Botadero de Ripios · Aglomerado"). Nunca inventes nombres de áreas + 3 controles cortos (máx. ~45 caracteres), cada uno con el N° de foco entre paréntesis, p. ej. "Plan de izaje específico por maniobra (1)". Asigna al AM los focos de inicio de jornada (izaje, pre-uso de vehículos y equipos) y al Mediodía los de intervención (plataformas, instalaciones eléctricas, excavaciones) más los temas de la franja Recurrente (p. ej., "Extensiones eléctricas con pasacable", "Acopio y housekeeping en zonas habilitadas").</a:t>
+              <a:t>- Bloque AM y Bloque Mediodía: nombres EXACTOS de "AREA_GEO" de los eventos de los focos asignados a cada bloque (como la gerencia: "Pila Oeste · Piscinas ILS–PLS · Izaje"; "Pilas de Lixiviación · Botadero de Ripios · Aglomerado"; nunca inventes nombres de áreas), más 3 controles cortos (máx. ~45 caracteres), cada uno con el N° de foco entre paréntesis, p. ej. "Plan de izaje específico por maniobra (1)". Asigna al AM los focos de inicio de jornada (izaje, pre-uso de vehículos y equipos) y al Mediodía los de intervención (plataformas, instalaciones eléctricas, excavaciones) más los temas de la franja Recurrente (p. ej., "Extensiones eléctricas con pasacable", "Acopio y housekeeping en zonas habilitadas").</a:t>
             </a:r>
             <a:endParaRPr lang="en-US" sz="600" dirty="0"/>
           </a:p>
@@ -8187,7 +8187,7 @@
                 <a:ea typeface="Arial" pitchFamily="34" charset="-122"/>
                 <a:cs typeface="Arial" pitchFamily="34" charset="-120"/>
               </a:rPr>
-              <a:t>Antes de entregar, confirma que: el título dice "ASSURANCE TURNO 1-3" o "ASSURANCE TURNO 2-4" (sin corchetes); cada ID existe en el Excel; el nivel de cada foco sigue el punto 4 (2 o más eventos N1/N2 = N1); las áreas son nombres exactos de AREA_GEO; revisaste los eventos abiertos a la fecha de cierre; cada foco nace de al menos un evento N1/N2, salvo los focos de solo HBP, que tienen 3 o más HBP del mismo tema; todos los focos N1 van antes que los N2; dentro de cada nivel, los focos con reiteración/evidencia van antes que los aislados y se ordenan como indica el punto 4; ningún tema se llama "Otro"; los eventos con riesgo "Otro" fueron asignados a un tema leyendo su descripción; cada foco contiene al menos un dato concreto de sus eventos; el NIVEL (color) de cada foco corresponde a su evento más grave y la PRIORIDAD (orden) sigue el punto 4; ningún HBP definió un nivel; los conteos de indicadores y Recurrente cuadran; y no quedan textos guía.</a:t>
+              <a:t>Antes de entregar, confirma que: el título dice "ASSURANCE TURNO 1-3" o "ASSURANCE TURNO 2-4" (sin corchetes); cada ID existe en el Excel; el nivel de cada foco sigue el punto 4 (2 o más eventos N1/N2 = N1); las áreas son nombres exactos de AREA_GEO; revisaste los eventos abiertos a la fecha de cierre; cada foco nace de al menos un evento N1/N2, salvo los focos de solo HBP, que tienen 3 o más HBP del mismo tema; todos los focos N1 van antes que los N2; dentro de cada nivel, los focos con reiteración/evidencia van antes que los aislados y se ordenan como indica el punto 4; ningún tema se llama "Otro"; los eventos con riesgo "Otro" fueron asignados a un tema leyendo su descripción; cada foco contiene al menos un dato concreto de sus eventos; el NIVEL (color) y la PRIORIDAD (orden) de cada foco siguen el punto 4; ningún HBP definió un nivel; los conteos de indicadores y Recurrente cuadran; y no quedan textos guía.</a:t>
             </a:r>
             <a:endParaRPr lang="en-US" sz="600" dirty="0"/>
           </a:p>

</xml_diff>

<commit_message>
Assurance ITO v1.3: leer la descripción de todos los eventos y revalorizar criticidad (a CA o HAP)
Co-Authored-By: Claude Opus 5.5 <noreply@anthropic.com>
Claude-Session: https://claude.ai/code/session_017MaLNPnWzNhW9Tdfmjv67V
</commit_message>
<xml_diff>
--- a/FORMATO_ASSURANCE_ITO_v1.3.pptx
+++ b/FORMATO_ASSURANCE_ITO_v1.3.pptx
@@ -6793,7 +6793,24 @@
                 <a:ea typeface="Arial" pitchFamily="34" charset="-122"/>
                 <a:cs typeface="Arial" pitchFamily="34" charset="-120"/>
               </a:rPr>
-              <a:t>- Los focos nacen de los eventos N1/N2 del período (ACC, CAAP, HAP, CBP).</a:t>
+              <a:t>- Antes de agrupar, lee la "Descripción" de todos los eventos y aplica la revaloración del punto 4: un HBP revalorizado a HAP o CA pasa a ser un evento N1/N2 y puede originar un foco o contar para la reiteración.</a:t>
+            </a:r>
+            <a:endParaRPr lang="en-US" sz="600" dirty="0"/>
+          </a:p>
+          <a:p>
+            <a:pPr marL="0" indent="0">
+              <a:buNone/>
+            </a:pPr>
+            <a:r>
+              <a:rPr lang="en-US" sz="600" dirty="0">
+                <a:solidFill>
+                  <a:srgbClr val="222222"/>
+                </a:solidFill>
+                <a:latin typeface="Arial" pitchFamily="34" charset="0"/>
+                <a:ea typeface="Arial" pitchFamily="34" charset="-122"/>
+                <a:cs typeface="Arial" pitchFamily="34" charset="-120"/>
+              </a:rPr>
+              <a:t>- Los focos nacen de los eventos N1/N2 del período (ACC, CAAP, HAP, CBP, incluidos los revalorizados).</a:t>
             </a:r>
             <a:endParaRPr lang="en-US" sz="600" dirty="0"/>
           </a:p>
@@ -6946,7 +6963,7 @@
                 <a:ea typeface="Arial" pitchFamily="34" charset="-122"/>
                 <a:cs typeface="Arial" pitchFamily="34" charset="-120"/>
               </a:rPr>
-              <a:t>  - N1 · CRITICIDAD ALTA (celda roja C62828) si el foco tiene: un ACC (con lesión o daño material), o un CAAP, o un CBP revalorizado como CA, o 2 o más eventos N1/N2 del mismo tema (reiteración: p. ej., HAP + CBP, o HAP + HAP).</a:t>
+              <a:t>  - N1 · CRITICIDAD ALTA (celda roja C62828) si el foco tiene: un ACC (con lesión o daño material), o un CAAP, o un evento revalorizado como CA, o 2 o más eventos N1/N2 del mismo tema (reiteración: p. ej., HAP + CBP, o HAP + HAP).</a:t>
             </a:r>
             <a:endParaRPr lang="en-US" sz="600" dirty="0"/>
           </a:p>
@@ -7014,75 +7031,109 @@
                 <a:ea typeface="Arial" pitchFamily="34" charset="-122"/>
                 <a:cs typeface="Arial" pitchFamily="34" charset="-120"/>
               </a:rPr>
-              <a:t>REVALORACIÓN DE POTENCIAL – CBP → CA (criterio de la gerencia)</a:t>
-            </a:r>
-            <a:endParaRPr lang="en-US" sz="600" dirty="0"/>
-          </a:p>
-          <a:p>
-            <a:pPr marL="0" indent="0">
-              <a:buNone/>
-            </a:pPr>
-            <a:r>
-              <a:rPr lang="en-US" sz="600" dirty="0">
-                <a:solidFill>
-                  <a:srgbClr val="222222"/>
-                </a:solidFill>
-                <a:latin typeface="Arial" pitchFamily="34" charset="0"/>
-                <a:ea typeface="Arial" pitchFamily="34" charset="-122"/>
-                <a:cs typeface="Arial" pitchFamily="34" charset="-120"/>
-              </a:rPr>
-              <a:t>  - Un CBP se trata como CA (cuasi accidente de alto potencial, equivalente a CAAP: N1) cuando su "Descripción" muestra a una persona efectivamente expuesta a: (1) línea de fuego de un equipo o vehículo en movimiento (p. ej., retroceso, aculatamiento, giro), (2) carga suspendida, o (3) energía peligrosa energizada (eléctrica, presión). Ej.: CBP 549924 – rigger a 2 m de un camión pluma en retroceso, sin radio → la gerencia lo registró como "CA ID 549924".</a:t>
-            </a:r>
-            <a:endParaRPr lang="en-US" sz="600" dirty="0"/>
-          </a:p>
-          <a:p>
-            <a:pPr marL="0" indent="0">
-              <a:buNone/>
-            </a:pPr>
-            <a:r>
-              <a:rPr lang="en-US" sz="600" dirty="0">
-                <a:solidFill>
-                  <a:srgbClr val="222222"/>
-                </a:solidFill>
-                <a:latin typeface="Arial" pitchFamily="34" charset="0"/>
-                <a:ea typeface="Arial" pitchFamily="34" charset="-122"/>
-                <a:cs typeface="Arial" pitchFamily="34" charset="-120"/>
-              </a:rPr>
-              <a:t>  - NO se revaloriza por riesgos solo potenciales o sin exposición concreta descrita (p. ej., CBP 554227, retiro de eslinga en borde de zanja sin altura indicada, se mantuvo como CBP).</a:t>
-            </a:r>
-            <a:endParaRPr lang="en-US" sz="600" dirty="0"/>
-          </a:p>
-          <a:p>
-            <a:pPr marL="0" indent="0">
-              <a:buNone/>
-            </a:pPr>
-            <a:r>
-              <a:rPr lang="en-US" sz="600" dirty="0">
-                <a:solidFill>
-                  <a:srgbClr val="222222"/>
-                </a:solidFill>
-                <a:latin typeface="Arial" pitchFamily="34" charset="0"/>
-                <a:ea typeface="Arial" pitchFamily="34" charset="-122"/>
-                <a:cs typeface="Arial" pitchFamily="34" charset="-120"/>
-              </a:rPr>
-              <a:t>  - En la columna Evento se escribe "CA ID [N°] – EMPRESA: …". Para el nivel y la prioridad cuenta como CAAP. En la franja de indicadores se mantiene la clasificación del Excel (sigue contándose como CBP).</a:t>
-            </a:r>
-            <a:endParaRPr lang="en-US" sz="600" dirty="0"/>
-          </a:p>
-          <a:p>
-            <a:pPr marL="0" indent="0">
-              <a:buNone/>
-            </a:pPr>
-            <a:r>
-              <a:rPr lang="en-US" sz="600" dirty="0">
-                <a:solidFill>
-                  <a:srgbClr val="222222"/>
-                </a:solidFill>
-                <a:latin typeface="Arial" pitchFamily="34" charset="0"/>
-                <a:ea typeface="Arial" pitchFamily="34" charset="-122"/>
-                <a:cs typeface="Arial" pitchFamily="34" charset="-120"/>
-              </a:rPr>
-              <a:t>  - Toda revalorización debe informarse al usuario en el control de calidad (ID, clasificación original y motivo). Ante la duda, no revalorices y menciónalo como posible CA.</a:t>
+              <a:t>LECTURA DE LA DESCRIPCIÓN Y REVALORACIÓN DE CRITICIDAD (obligatorio)</a:t>
+            </a:r>
+            <a:endParaRPr lang="en-US" sz="600" dirty="0"/>
+          </a:p>
+          <a:p>
+            <a:pPr marL="0" indent="0">
+              <a:buNone/>
+            </a:pPr>
+            <a:r>
+              <a:rPr lang="en-US" sz="600" dirty="0">
+                <a:solidFill>
+                  <a:srgbClr val="222222"/>
+                </a:solidFill>
+                <a:latin typeface="Arial" pitchFamily="34" charset="0"/>
+                <a:ea typeface="Arial" pitchFamily="34" charset="-122"/>
+                <a:cs typeface="Arial" pitchFamily="34" charset="-120"/>
+              </a:rPr>
+              <a:t>  - La clasificación del Excel es el punto de partida, no la palabra final. Lee la "Descripción" de TODOS los eventos del período (incluidos los HBP) y evalúa si lo descrito es más grave que su clasificación. Un evento solo puede SUBIR de criticidad, nunca bajar.</a:t>
+            </a:r>
+            <a:endParaRPr lang="en-US" sz="600" dirty="0"/>
+          </a:p>
+          <a:p>
+            <a:pPr marL="0" indent="0">
+              <a:buNone/>
+            </a:pPr>
+            <a:r>
+              <a:rPr lang="en-US" sz="600" dirty="0">
+                <a:solidFill>
+                  <a:srgbClr val="222222"/>
+                </a:solidFill>
+                <a:latin typeface="Arial" pitchFamily="34" charset="0"/>
+                <a:ea typeface="Arial" pitchFamily="34" charset="-122"/>
+                <a:cs typeface="Arial" pitchFamily="34" charset="-120"/>
+              </a:rPr>
+              <a:t>  - Sube a CA (cuasi accidente de alto potencial; cuenta como CAAP → N1) cualquier CBP, HAP o HBP cuya descripción muestre a una persona EFECTIVAMENTE EXPUESTA a un riesgo con potencial grave o fatal: (1) línea de fuego de un equipo o vehículo en movimiento (retroceso, aculatamiento, giro); (2) carga suspendida; (3) energía peligrosa energizada (eléctrica, presión, térmica); (4) trabajo en altura sin protección contra caídas; (5) ingreso o trabajo en zanja/excavación sin protección o sin autorización; (6) atmósfera peligrosa o espacio confinado sin control. Ej.: CBP 549924 – rigger a 2 m de un camión pluma en retroceso, sin radio → la gerencia lo registró como "CA ID 549924".</a:t>
+            </a:r>
+            <a:endParaRPr lang="en-US" sz="600" dirty="0"/>
+          </a:p>
+          <a:p>
+            <a:pPr marL="0" indent="0">
+              <a:buNone/>
+            </a:pPr>
+            <a:r>
+              <a:rPr lang="en-US" sz="600" dirty="0">
+                <a:solidFill>
+                  <a:srgbClr val="222222"/>
+                </a:solidFill>
+                <a:latin typeface="Arial" pitchFamily="34" charset="0"/>
+                <a:ea typeface="Arial" pitchFamily="34" charset="-122"/>
+                <a:cs typeface="Arial" pitchFamily="34" charset="-120"/>
+              </a:rPr>
+              <a:t>  - Sube a HAP (hallazgo de alto potencial → N2) un HBP cuya descripción muestre un CONTROL CRÍTICO no implementado o erosionado MIENTRAS se ejecutaba la tarea de riesgo crítico, aunque nadie haya quedado expuesto (p. ej., izaje en curso con accesorio sin certificar; trabajo en altura en curso con plataforma sin baranda; intervención eléctrica sin bloqueo). La columna "CONTROL CRITICO" con "(C.C.)" es un indicio, no una condición suficiente.</a:t>
+            </a:r>
+            <a:endParaRPr lang="en-US" sz="600" dirty="0"/>
+          </a:p>
+          <a:p>
+            <a:pPr marL="0" indent="0">
+              <a:buNone/>
+            </a:pPr>
+            <a:r>
+              <a:rPr lang="en-US" sz="600" dirty="0">
+                <a:solidFill>
+                  <a:srgbClr val="222222"/>
+                </a:solidFill>
+                <a:latin typeface="Arial" pitchFamily="34" charset="0"/>
+                <a:ea typeface="Arial" pitchFamily="34" charset="-122"/>
+                <a:cs typeface="Arial" pitchFamily="34" charset="-120"/>
+              </a:rPr>
+              <a:t>  - NO se revaloriza (mantener la clasificación del Excel): condiciones detectadas en inspección sin tarea de riesgo en curso y sin persona expuesta, riesgos solo potenciales o descripciones sin exposición concreta. Ejemplos en que la gerencia NO revalorizó: CBP 554227 (retiro de eslinga en borde de zanja, sin altura indicada) se mantuvo CBP; HBP 549965 (plataforma de acceso sin rodapiés) y HBP 549552 (extintores despresurizados) se mantuvieron HBP.</a:t>
+            </a:r>
+            <a:endParaRPr lang="en-US" sz="600" dirty="0"/>
+          </a:p>
+          <a:p>
+            <a:pPr marL="0" indent="0">
+              <a:buNone/>
+            </a:pPr>
+            <a:r>
+              <a:rPr lang="en-US" sz="600" dirty="0">
+                <a:solidFill>
+                  <a:srgbClr val="222222"/>
+                </a:solidFill>
+                <a:latin typeface="Arial" pitchFamily="34" charset="0"/>
+                <a:ea typeface="Arial" pitchFamily="34" charset="-122"/>
+                <a:cs typeface="Arial" pitchFamily="34" charset="-120"/>
+              </a:rPr>
+              <a:t>  - Cómo se escribe: en la columna Evento, el tipo revalorizado: "CA ID [N°] – EMPRESA: …" o "HAP ID [N°] (rev.) – EMPRESA: …". Para selección de focos, reiteración, nivel y prioridad se usa el tipo revalorizado. En la franja de indicadores se mantiene la clasificación del Excel, para que los totales cuadren con la data.</a:t>
+            </a:r>
+            <a:endParaRPr lang="en-US" sz="600" dirty="0"/>
+          </a:p>
+          <a:p>
+            <a:pPr marL="0" indent="0">
+              <a:buNone/>
+            </a:pPr>
+            <a:r>
+              <a:rPr lang="en-US" sz="600" dirty="0">
+                <a:solidFill>
+                  <a:srgbClr val="222222"/>
+                </a:solidFill>
+                <a:latin typeface="Arial" pitchFamily="34" charset="0"/>
+                <a:ea typeface="Arial" pitchFamily="34" charset="-122"/>
+                <a:cs typeface="Arial" pitchFamily="34" charset="-120"/>
+              </a:rPr>
+              <a:t>  - Toda revalorización debe informarse al usuario en el control de calidad (ID, clasificación original, nueva clasificación y la frase de la descripción que la justifica). Ante la duda, NO revalorices y menciónalo como "posible revalorización" para que el usuario decida.</a:t>
             </a:r>
             <a:endParaRPr lang="en-US" sz="600" dirty="0"/>
           </a:p>
@@ -7201,7 +7252,7 @@
                 <a:ea typeface="Arial" pitchFamily="34" charset="-122"/>
                 <a:cs typeface="Arial" pitchFamily="34" charset="-120"/>
               </a:rPr>
-              <a:t>  - Cierre 08-09: 1° Izaje – certificación y línea de fuego (HAP + CA 549924, N1: el CBP se revaloriza a CA por línea de fuego) · 2° Andamios (HAP + HAP + 2 HBP, N1 por reiteración; su evento más grave es HAP, menos grave que el CA del 1°) · 3° Tableros eléctricos (HAP + 3 HBP, N2). La gerencia agregó un 4° foco de equipos de emergencia con solo 2 HBP: con nuestra regla NO va, porque se necesitan 3 o más HBP del mismo tema. En su lugar entra, si califica, el tema HBP con 3 o más eventos (ver ejemplo 2).</a:t>
+              <a:t>  - Cierre 08-09: 1° Izaje – certificación y línea de fuego (HAP + CA 549924, N1: el CBP se revaloriza a CA por la descripción: rigger expuesto a línea de fuego) · 2° Andamios (HAP + HAP + 2 HBP, N1 por reiteración; su evento más grave es HAP, menos grave que el CA del 1°) · 3° Tableros eléctricos (HAP + 3 HBP, N2). La gerencia agregó un 4° foco de equipos de emergencia con solo 2 HBP: con nuestra regla NO va, porque se necesitan 3 o más HBP del mismo tema. En su lugar entra, si califica, el tema HBP con 3 o más eventos (ver ejemplo 2).</a:t>
             </a:r>
             <a:endParaRPr lang="en-US" sz="600" dirty="0"/>
           </a:p>
@@ -7473,7 +7524,7 @@
                 <a:ea typeface="Arial" pitchFamily="34" charset="-122"/>
                 <a:cs typeface="Arial" pitchFamily="34" charset="-120"/>
               </a:rPr>
-              <a:t>- Formato fijo por evento, igual que la gerencia: "TIPO ID 555505 – EMPRESA:" (en negrita) + qué ocurrió, en una frase concreta de hasta 120 caracteres con los datos del evento (equipo, carga, lugar, medida). TIPO = ACC, CAAP, CA (CBP revalorizado, punto 4), HAP, CBP o HBP. Sin marca de turno.</a:t>
+              <a:t>- Formato fijo por evento, igual que la gerencia: "TIPO ID 555505 – EMPRESA:" (en negrita) + qué ocurrió, en una frase concreta de hasta 120 caracteres con los datos del evento (equipo, carga, lugar, medida). TIPO = ACC, CAAP, CA (revalorizado, punto 4), HAP, HAP (rev.), CBP o HBP. Sin marca de turno.</a:t>
             </a:r>
             <a:endParaRPr lang="en-US" sz="600" dirty="0"/>
           </a:p>
@@ -8153,7 +8204,7 @@
                 <a:ea typeface="Arial" pitchFamily="34" charset="-122"/>
                 <a:cs typeface="Arial" pitchFamily="34" charset="-120"/>
               </a:rPr>
-              <a:t>- CBP revalorizados como CA (ID, clasificación original y motivo) y posibles CA que no revalorizaste;</a:t>
+              <a:t>- eventos revalorizados (ID, clasificación original → nueva, y la frase de la descripción que lo justifica) y posibles revalorizaciones que dejaste a decisión del usuario;</a:t>
             </a:r>
             <a:endParaRPr lang="en-US" sz="600" dirty="0"/>
           </a:p>
@@ -8187,7 +8238,7 @@
                 <a:ea typeface="Arial" pitchFamily="34" charset="-122"/>
                 <a:cs typeface="Arial" pitchFamily="34" charset="-120"/>
               </a:rPr>
-              <a:t>Antes de entregar, confirma que: el título dice "ASSURANCE TURNO 1-3" o "ASSURANCE TURNO 2-4" (sin corchetes); cada ID existe en el Excel; el nivel de cada foco sigue el punto 4 (2 o más eventos N1/N2 = N1); las áreas son nombres exactos de AREA_GEO; revisaste los eventos abiertos a la fecha de cierre; cada foco nace de al menos un evento N1/N2, salvo los focos de solo HBP, que tienen 3 o más HBP del mismo tema; todos los focos N1 van antes que los N2; dentro de cada nivel, los focos con reiteración/evidencia van antes que los aislados y se ordenan como indica el punto 4; ningún tema se llama "Otro"; los eventos con riesgo "Otro" fueron asignados a un tema leyendo su descripción; cada foco contiene al menos un dato concreto de sus eventos; el NIVEL (color) y la PRIORIDAD (orden) de cada foco siguen el punto 4; ningún HBP definió un nivel; los conteos de indicadores y Recurrente cuadran; y no quedan textos guía.</a:t>
+              <a:t>Antes de entregar, confirma que: el título dice "ASSURANCE TURNO 1-3" o "ASSURANCE TURNO 2-4" (sin corchetes); cada ID existe en el Excel; el nivel de cada foco sigue el punto 4 (2 o más eventos N1/N2 = N1); las áreas son nombres exactos de AREA_GEO; revisaste los eventos abiertos a la fecha de cierre; leíste la descripción de todos los eventos y aplicaste la revaloración del punto 4; cada foco nace de al menos un evento N1/N2, salvo los focos de solo HBP, que tienen 3 o más HBP del mismo tema; todos los focos N1 van antes que los N2; dentro de cada nivel, los focos con reiteración/evidencia van antes que los aislados y se ordenan como indica el punto 4; ningún tema se llama "Otro"; los eventos con riesgo "Otro" fueron asignados a un tema leyendo su descripción; cada foco contiene al menos un dato concreto de sus eventos; el NIVEL (color) y la PRIORIDAD (orden) de cada foco siguen el punto 4; ningún HBP definió un nivel; los conteos de indicadores y Recurrente cuadran; y no quedan textos guía.</a:t>
             </a:r>
             <a:endParaRPr lang="en-US" sz="600" dirty="0"/>
           </a:p>
@@ -10414,7 +10465,7 @@
                 <a:ea typeface="Arial" pitchFamily="34" charset="-122"/>
                 <a:cs typeface="Arial" pitchFamily="34" charset="-120"/>
               </a:rPr>
-              <a:t>Define el color. N1 · alta (roja): ACC, CAAP, CBP revalorizado a CA, o 2 o más HAP/CBP del mismo tema (reiteración). N2 · intermedia (naranja): un solo HAP o CBP, o foco de 3+ HBP. Los HBP no cuentan para el nivel.</a:t>
+              <a:t>Define el color. Leer la descripción: un evento puede subir a CA o HAP. N1 · alta (roja): ACC, CAAP, CA, o 2 o más HAP/CBP del mismo tema. N2 · intermedia (naranja): un solo HAP o CBP, o foco de 3+ HBP. Los HBP no cuentan para el nivel.</a:t>
             </a:r>
             <a:endParaRPr lang="en-US" sz="930" dirty="0"/>
           </a:p>
@@ -12239,7 +12290,7 @@
                 <a:ea typeface="Arial" pitchFamily="34" charset="-122"/>
                 <a:cs typeface="Arial" pitchFamily="34" charset="-120"/>
               </a:rPr>
-              <a:t>consecuencias graves o fatales; gestión prioritaria. ACC con lesión o daño material, CAAP, CBP revalorizado como CA (persona expuesta a línea de fuego, carga suspendida o energía) o 2 o más HAP/CBP del mismo tema.</a:t>
+              <a:t>consecuencias graves o fatales; gestión prioritaria. ACC con lesión o daño material, CAAP, evento revalorizado a CA por su descripción (persona expuesta a línea de fuego, carga suspendida, energía, altura) o 2 o más HAP/CBP del mismo tema.</a:t>
             </a:r>
             <a:endParaRPr lang="en-US" sz="930" dirty="0"/>
           </a:p>

</xml_diff>

<commit_message>
Assurance ITO v1.3: revalorización HBP → CBP y revisión explícita de CBP
Co-Authored-By: Claude Opus 5.5 <noreply@anthropic.com>
Claude-Session: https://claude.ai/code/session_017MaLNPnWzNhW9Tdfmjv67V
</commit_message>
<xml_diff>
--- a/FORMATO_ASSURANCE_ITO_v1.3.pptx
+++ b/FORMATO_ASSURANCE_ITO_v1.3.pptx
@@ -6793,7 +6793,7 @@
                 <a:ea typeface="Arial" pitchFamily="34" charset="-122"/>
                 <a:cs typeface="Arial" pitchFamily="34" charset="-120"/>
               </a:rPr>
-              <a:t>- Antes de agrupar, lee la "Descripción" de todos los eventos y aplica la revaloración del punto 4: un HBP revalorizado a HAP o CA pasa a ser un evento N1/N2 y puede originar un foco o contar para la reiteración.</a:t>
+              <a:t>- Antes de agrupar, lee la "Descripción" de todos los eventos y aplica la revaloración del punto 4: un HBP revalorizado a CBP, HAP o CA pasa a ser un evento N1/N2 y puede originar un foco o contar para la reiteración.</a:t>
             </a:r>
             <a:endParaRPr lang="en-US" sz="600" dirty="0"/>
           </a:p>
@@ -7048,7 +7048,7 @@
                 <a:ea typeface="Arial" pitchFamily="34" charset="-122"/>
                 <a:cs typeface="Arial" pitchFamily="34" charset="-120"/>
               </a:rPr>
-              <a:t>  - La clasificación del Excel es el punto de partida, no la palabra final. Lee la "Descripción" de TODOS los eventos del período (incluidos los HBP) y evalúa si lo descrito es más grave que su clasificación. Un evento solo puede SUBIR de criticidad, nunca bajar.</a:t>
+              <a:t>  - La clasificación del Excel es el punto de partida, no la palabra final. Lee la "Descripción" de TODOS los eventos del período (HBP, CBP y HAP) y evalúa si lo descrito es más grave que su clasificación. Un evento solo puede SUBIR de criticidad, nunca bajar.</a:t>
             </a:r>
             <a:endParaRPr lang="en-US" sz="600" dirty="0"/>
           </a:p>
@@ -7082,6 +7082,23 @@
                 <a:ea typeface="Arial" pitchFamily="34" charset="-122"/>
                 <a:cs typeface="Arial" pitchFamily="34" charset="-120"/>
               </a:rPr>
+              <a:t>  - Sube a CBP (cuasi accidente de bajo potencial → N2) un HBP cuya descripción muestre que una persona SÍ interactuó de cerca con la situación de riesgo (hubo exposición real, un casi-incidente), pero sin potencial grave o fatal (p. ej., trabajador pasa bajo material mal acopiado a baja altura, tropieza con herramientas en el piso). Si la exposición tenía potencial grave o fatal, sube directo a CA.</a:t>
+            </a:r>
+            <a:endParaRPr lang="en-US" sz="600" dirty="0"/>
+          </a:p>
+          <a:p>
+            <a:pPr marL="0" indent="0">
+              <a:buNone/>
+            </a:pPr>
+            <a:r>
+              <a:rPr lang="en-US" sz="600" dirty="0">
+                <a:solidFill>
+                  <a:srgbClr val="222222"/>
+                </a:solidFill>
+                <a:latin typeface="Arial" pitchFamily="34" charset="0"/>
+                <a:ea typeface="Arial" pitchFamily="34" charset="-122"/>
+                <a:cs typeface="Arial" pitchFamily="34" charset="-120"/>
+              </a:rPr>
               <a:t>  - Sube a HAP (hallazgo de alto potencial → N2) un HBP cuya descripción muestre un CONTROL CRÍTICO no implementado o erosionado MIENTRAS se ejecutaba la tarea de riesgo crítico, aunque nadie haya quedado expuesto (p. ej., izaje en curso con accesorio sin certificar; trabajo en altura en curso con plataforma sin baranda; intervención eléctrica sin bloqueo). La columna "CONTROL CRITICO" con "(C.C.)" es un indicio, no una condición suficiente.</a:t>
             </a:r>
             <a:endParaRPr lang="en-US" sz="600" dirty="0"/>
@@ -7116,7 +7133,24 @@
                 <a:ea typeface="Arial" pitchFamily="34" charset="-122"/>
                 <a:cs typeface="Arial" pitchFamily="34" charset="-120"/>
               </a:rPr>
-              <a:t>  - Cómo se escribe: en la columna Evento, el tipo revalorizado: "CA ID [N°] – EMPRESA: …" o "HAP ID [N°] (rev.) – EMPRESA: …". Para selección de focos, reiteración, nivel y prioridad se usa el tipo revalorizado. En la franja de indicadores se mantiene la clasificación del Excel, para que los totales cuadren con la data.</a:t>
+              <a:t>  - Revaloraciones posibles: HBP → CBP, HAP o CA; CBP → CA; HAP → CA. Un CBP no pasa a HAP (es el mismo nivel y el CBP ya es más grave).</a:t>
+            </a:r>
+            <a:endParaRPr lang="en-US" sz="600" dirty="0"/>
+          </a:p>
+          <a:p>
+            <a:pPr marL="0" indent="0">
+              <a:buNone/>
+            </a:pPr>
+            <a:r>
+              <a:rPr lang="en-US" sz="600" dirty="0">
+                <a:solidFill>
+                  <a:srgbClr val="222222"/>
+                </a:solidFill>
+                <a:latin typeface="Arial" pitchFamily="34" charset="0"/>
+                <a:ea typeface="Arial" pitchFamily="34" charset="-122"/>
+                <a:cs typeface="Arial" pitchFamily="34" charset="-120"/>
+              </a:rPr>
+              <a:t>  - Cómo se escribe: en la columna Evento, el tipo revalorizado: "CA ID [N°] – EMPRESA: …", "CBP ID [N°] (rev.) – EMPRESA: …" o "HAP ID [N°] (rev.) – EMPRESA: …". Para selección de focos, reiteración, nivel y prioridad se usa el tipo revalorizado. En la franja de indicadores se mantiene la clasificación del Excel, para que los totales cuadren con la data.</a:t>
             </a:r>
             <a:endParaRPr lang="en-US" sz="600" dirty="0"/>
           </a:p>
@@ -7524,7 +7558,7 @@
                 <a:ea typeface="Arial" pitchFamily="34" charset="-122"/>
                 <a:cs typeface="Arial" pitchFamily="34" charset="-120"/>
               </a:rPr>
-              <a:t>- Formato fijo por evento, igual que la gerencia: "TIPO ID 555505 – EMPRESA:" (en negrita) + qué ocurrió, en una frase concreta de hasta 120 caracteres con los datos del evento (equipo, carga, lugar, medida). TIPO = ACC, CAAP, CA (revalorizado, punto 4), HAP, HAP (rev.), CBP o HBP. Sin marca de turno.</a:t>
+              <a:t>- Formato fijo por evento, igual que la gerencia: "TIPO ID 555505 – EMPRESA:" (en negrita) + qué ocurrió, en una frase concreta de hasta 120 caracteres con los datos del evento (equipo, carga, lugar, medida). TIPO = ACC, CAAP, CA (revalorizado, punto 4), CBP, CBP (rev.), HAP, HAP (rev.) o HBP. Sin marca de turno.</a:t>
             </a:r>
             <a:endParaRPr lang="en-US" sz="600" dirty="0"/>
           </a:p>
@@ -10465,7 +10499,7 @@
                 <a:ea typeface="Arial" pitchFamily="34" charset="-122"/>
                 <a:cs typeface="Arial" pitchFamily="34" charset="-120"/>
               </a:rPr>
-              <a:t>Define el color. Leer la descripción: un evento puede subir a CA o HAP. N1 · alta (roja): ACC, CAAP, CA, o 2 o más HAP/CBP del mismo tema. N2 · intermedia (naranja): un solo HAP o CBP, o foco de 3+ HBP. Los HBP no cuentan para el nivel.</a:t>
+              <a:t>Define el color. Leer la descripción: un HBP o CBP puede subir de criticidad. N1 · alta (roja): ACC, CAAP, CA, o 2 o más HAP/CBP del mismo tema. N2 · intermedia (naranja): un solo HAP o CBP, o foco de 3+ HBP. Los HBP no cuentan para el nivel.</a:t>
             </a:r>
             <a:endParaRPr lang="en-US" sz="930" dirty="0"/>
           </a:p>

</xml_diff>

<commit_message>
Assurance ITO v1.3: criterio conservador para revalorizar HBP y CBP
Co-Authored-By: Claude Opus 5.5 <noreply@anthropic.com>
Claude-Session: https://claude.ai/code/session_017MaLNPnWzNhW9Tdfmjv67V
</commit_message>
<xml_diff>
--- a/FORMATO_ASSURANCE_ITO_v1.3.pptx
+++ b/FORMATO_ASSURANCE_ITO_v1.3.pptx
@@ -7133,6 +7133,125 @@
                 <a:ea typeface="Arial" pitchFamily="34" charset="-122"/>
                 <a:cs typeface="Arial" pitchFamily="34" charset="-120"/>
               </a:rPr>
+              <a:t>  - CRITERIO AL REVALORIZAR (especialmente HBP y CBP): la revalorización es una EXCEPCIÓN, no la regla. Quien clasificó el evento estuvo en terreno; respeta su clasificación salvo que la descripción sea claramente más grave.</a:t>
+            </a:r>
+            <a:endParaRPr lang="en-US" sz="600" dirty="0"/>
+          </a:p>
+          <a:p>
+            <a:pPr marL="0" indent="0">
+              <a:buNone/>
+            </a:pPr>
+            <a:r>
+              <a:rPr lang="en-US" sz="600" dirty="0">
+                <a:solidFill>
+                  <a:srgbClr val="222222"/>
+                </a:solidFill>
+                <a:latin typeface="Arial" pitchFamily="34" charset="0"/>
+                <a:ea typeface="Arial" pitchFamily="34" charset="-122"/>
+                <a:cs typeface="Arial" pitchFamily="34" charset="-120"/>
+              </a:rPr>
+              <a:t>      · Revaloriza solo con HECHOS escritos en la descripción (qué pasó, quién estuvo expuesto, a qué distancia, con qué equipo o energía). No supongas, no completes información que no está y no uses el "podría haber pasado".</a:t>
+            </a:r>
+            <a:endParaRPr lang="en-US" sz="600" dirty="0"/>
+          </a:p>
+          <a:p>
+            <a:pPr marL="0" indent="0">
+              <a:buNone/>
+            </a:pPr>
+            <a:r>
+              <a:rPr lang="en-US" sz="600" dirty="0">
+                <a:solidFill>
+                  <a:srgbClr val="222222"/>
+                </a:solidFill>
+                <a:latin typeface="Arial" pitchFamily="34" charset="0"/>
+                <a:ea typeface="Arial" pitchFamily="34" charset="-122"/>
+                <a:cs typeface="Arial" pitchFamily="34" charset="-120"/>
+              </a:rPr>
+              <a:t>      · La gravedad debe ser evidente para cualquier supervisor que lea la descripción. Si tienes que argumentar mucho para justificarla, no corresponde.</a:t>
+            </a:r>
+            <a:endParaRPr lang="en-US" sz="600" dirty="0"/>
+          </a:p>
+          <a:p>
+            <a:pPr marL="0" indent="0">
+              <a:buNone/>
+            </a:pPr>
+            <a:r>
+              <a:rPr lang="en-US" sz="600" dirty="0">
+                <a:solidFill>
+                  <a:srgbClr val="222222"/>
+                </a:solidFill>
+                <a:latin typeface="Arial" pitchFamily="34" charset="0"/>
+                <a:ea typeface="Arial" pitchFamily="34" charset="-122"/>
+                <a:cs typeface="Arial" pitchFamily="34" charset="-120"/>
+              </a:rPr>
+              <a:t>      · Nunca revalorices para completar filas, armar un foco o igualar un resultado esperado.</a:t>
+            </a:r>
+            <a:endParaRPr lang="en-US" sz="600" dirty="0"/>
+          </a:p>
+          <a:p>
+            <a:pPr marL="0" indent="0">
+              <a:buNone/>
+            </a:pPr>
+            <a:r>
+              <a:rPr lang="en-US" sz="600" dirty="0">
+                <a:solidFill>
+                  <a:srgbClr val="222222"/>
+                </a:solidFill>
+                <a:latin typeface="Arial" pitchFamily="34" charset="0"/>
+                <a:ea typeface="Arial" pitchFamily="34" charset="-122"/>
+                <a:cs typeface="Arial" pitchFamily="34" charset="-120"/>
+              </a:rPr>
+              <a:t>      · Un título alarmante no basta: manda lo que describe el texto.</a:t>
+            </a:r>
+            <a:endParaRPr lang="en-US" sz="600" dirty="0"/>
+          </a:p>
+          <a:p>
+            <a:pPr marL="0" indent="0">
+              <a:buNone/>
+            </a:pPr>
+            <a:r>
+              <a:rPr lang="en-US" sz="600" dirty="0">
+                <a:solidFill>
+                  <a:srgbClr val="222222"/>
+                </a:solidFill>
+                <a:latin typeface="Arial" pitchFamily="34" charset="0"/>
+                <a:ea typeface="Arial" pitchFamily="34" charset="-122"/>
+                <a:cs typeface="Arial" pitchFamily="34" charset="-120"/>
+              </a:rPr>
+              <a:t>      · Lo normal es que en un período haya 0, 1 o 2 revalorizaciones. Si te aparecen más, revisa tu criterio y deja como "posible revalorización" las que no sean evidentes.</a:t>
+            </a:r>
+            <a:endParaRPr lang="en-US" sz="600" dirty="0"/>
+          </a:p>
+          <a:p>
+            <a:pPr marL="0" indent="0">
+              <a:buNone/>
+            </a:pPr>
+            <a:r>
+              <a:rPr lang="en-US" sz="600" dirty="0">
+                <a:solidFill>
+                  <a:srgbClr val="222222"/>
+                </a:solidFill>
+                <a:latin typeface="Arial" pitchFamily="34" charset="0"/>
+                <a:ea typeface="Arial" pitchFamily="34" charset="-122"/>
+                <a:cs typeface="Arial" pitchFamily="34" charset="-120"/>
+              </a:rPr>
+              <a:t>      · Ante la duda, NO revalorices: mantén la clasificación del Excel y menciónalo al usuario para que decida.</a:t>
+            </a:r>
+            <a:endParaRPr lang="en-US" sz="600" dirty="0"/>
+          </a:p>
+          <a:p>
+            <a:pPr marL="0" indent="0">
+              <a:buNone/>
+            </a:pPr>
+            <a:r>
+              <a:rPr lang="en-US" sz="600" dirty="0">
+                <a:solidFill>
+                  <a:srgbClr val="222222"/>
+                </a:solidFill>
+                <a:latin typeface="Arial" pitchFamily="34" charset="0"/>
+                <a:ea typeface="Arial" pitchFamily="34" charset="-122"/>
+                <a:cs typeface="Arial" pitchFamily="34" charset="-120"/>
+              </a:rPr>
               <a:t>  - Revaloraciones posibles: HBP → CBP, HAP o CA; CBP → CA; HAP → CA. Un CBP no pasa a HAP (es el mismo nivel y el CBP ya es más grave).</a:t>
             </a:r>
             <a:endParaRPr lang="en-US" sz="600" dirty="0"/>

</xml_diff>

<commit_message>
Assurance ITO v1.3: explicitar que los HBP nunca suben un foco a N1
Co-Authored-By: Claude Opus 5.5 <noreply@anthropic.com>
Claude-Session: https://claude.ai/code/session_017MaLNPnWzNhW9Tdfmjv67V
</commit_message>
<xml_diff>
--- a/FORMATO_ASSURANCE_ITO_v1.3.pptx
+++ b/FORMATO_ASSURANCE_ITO_v1.3.pptx
@@ -6997,7 +6997,92 @@
                 <a:ea typeface="Arial" pitchFamily="34" charset="-122"/>
                 <a:cs typeface="Arial" pitchFamily="34" charset="-120"/>
               </a:rPr>
-              <a:t>  - Los HBP nunca cuentan para definir el nivel.</a:t>
+              <a:t>  - Los HBP nunca cuentan para definir el nivel. La reiteración que sube a N1 es SOLO entre eventos N1/N2 (HAP, CBP, CAAP, ACC); los HBP, aunque sean muchos, tienen como techo N2.</a:t>
+            </a:r>
+            <a:endParaRPr lang="en-US" sz="600" dirty="0"/>
+          </a:p>
+          <a:p>
+            <a:pPr marL="0" indent="0">
+              <a:buNone/>
+            </a:pPr>
+            <a:r>
+              <a:rPr lang="en-US" sz="600" dirty="0">
+                <a:solidFill>
+                  <a:srgbClr val="222222"/>
+                </a:solidFill>
+                <a:latin typeface="Arial" pitchFamily="34" charset="0"/>
+                <a:ea typeface="Arial" pitchFamily="34" charset="-122"/>
+                <a:cs typeface="Arial" pitchFamily="34" charset="-120"/>
+              </a:rPr>
+              <a:t>  - Ejemplos de nivel:</a:t>
+            </a:r>
+            <a:endParaRPr lang="en-US" sz="600" dirty="0"/>
+          </a:p>
+          <a:p>
+            <a:pPr marL="0" indent="0">
+              <a:buNone/>
+            </a:pPr>
+            <a:r>
+              <a:rPr lang="en-US" sz="600" dirty="0">
+                <a:solidFill>
+                  <a:srgbClr val="222222"/>
+                </a:solidFill>
+                <a:latin typeface="Arial" pitchFamily="34" charset="0"/>
+                <a:ea typeface="Arial" pitchFamily="34" charset="-122"/>
+                <a:cs typeface="Arial" pitchFamily="34" charset="-120"/>
+              </a:rPr>
+              <a:t>      · 1 HAP + 1 HBP → N2.   · 1 HAP + 5 HBP → N2.   · 1 CBP + 3 HBP → N2.</a:t>
+            </a:r>
+            <a:endParaRPr lang="en-US" sz="600" dirty="0"/>
+          </a:p>
+          <a:p>
+            <a:pPr marL="0" indent="0">
+              <a:buNone/>
+            </a:pPr>
+            <a:r>
+              <a:rPr lang="en-US" sz="600" dirty="0">
+                <a:solidFill>
+                  <a:srgbClr val="222222"/>
+                </a:solidFill>
+                <a:latin typeface="Arial" pitchFamily="34" charset="0"/>
+                <a:ea typeface="Arial" pitchFamily="34" charset="-122"/>
+                <a:cs typeface="Arial" pitchFamily="34" charset="-120"/>
+              </a:rPr>
+              <a:t>      · 1 HAP + 1 HAP → N1.   · 1 HAP + 1 CBP → N1.   · 1 CAAP (solo) → N1.</a:t>
+            </a:r>
+            <a:endParaRPr lang="en-US" sz="600" dirty="0"/>
+          </a:p>
+          <a:p>
+            <a:pPr marL="0" indent="0">
+              <a:buNone/>
+            </a:pPr>
+            <a:r>
+              <a:rPr lang="en-US" sz="600" dirty="0">
+                <a:solidFill>
+                  <a:srgbClr val="222222"/>
+                </a:solidFill>
+                <a:latin typeface="Arial" pitchFamily="34" charset="0"/>
+                <a:ea typeface="Arial" pitchFamily="34" charset="-122"/>
+                <a:cs typeface="Arial" pitchFamily="34" charset="-120"/>
+              </a:rPr>
+              <a:t>      · Solo HBP (3 o más del mismo tema) → N2. Nunca N1, sin importar cuántos sean.</a:t>
+            </a:r>
+            <a:endParaRPr lang="en-US" sz="600" dirty="0"/>
+          </a:p>
+          <a:p>
+            <a:pPr marL="0" indent="0">
+              <a:buNone/>
+            </a:pPr>
+            <a:r>
+              <a:rPr lang="en-US" sz="600" dirty="0">
+                <a:solidFill>
+                  <a:srgbClr val="222222"/>
+                </a:solidFill>
+                <a:latin typeface="Arial" pitchFamily="34" charset="0"/>
+                <a:ea typeface="Arial" pitchFamily="34" charset="-122"/>
+                <a:cs typeface="Arial" pitchFamily="34" charset="-120"/>
+              </a:rPr>
+              <a:t>      · Un HBP solo cuenta como HAP/CBP si fue revalorizado con el criterio de este punto (excepción, con hechos en la descripción).</a:t>
             </a:r>
             <a:endParaRPr lang="en-US" sz="600" dirty="0"/>
           </a:p>
@@ -8391,7 +8476,7 @@
                 <a:ea typeface="Arial" pitchFamily="34" charset="-122"/>
                 <a:cs typeface="Arial" pitchFamily="34" charset="-120"/>
               </a:rPr>
-              <a:t>Antes de entregar, confirma que: el título dice "ASSURANCE TURNO 1-3" o "ASSURANCE TURNO 2-4" (sin corchetes); cada ID existe en el Excel; el nivel de cada foco sigue el punto 4 (2 o más eventos N1/N2 = N1); las áreas son nombres exactos de AREA_GEO; revisaste los eventos abiertos a la fecha de cierre; leíste la descripción de todos los eventos y aplicaste la revaloración del punto 4; cada foco nace de al menos un evento N1/N2, salvo los focos de solo HBP, que tienen 3 o más HBP del mismo tema; todos los focos N1 van antes que los N2; dentro de cada nivel, los focos con reiteración/evidencia van antes que los aislados y se ordenan como indica el punto 4; ningún tema se llama "Otro"; los eventos con riesgo "Otro" fueron asignados a un tema leyendo su descripción; cada foco contiene al menos un dato concreto de sus eventos; el NIVEL (color) y la PRIORIDAD (orden) de cada foco siguen el punto 4; ningún HBP definió un nivel; los conteos de indicadores y Recurrente cuadran; y no quedan textos guía.</a:t>
+              <a:t>Antes de entregar, confirma que: el título dice "ASSURANCE TURNO 1-3" o "ASSURANCE TURNO 2-4" (sin corchetes); cada ID existe en el Excel; el nivel de cada foco sigue el punto 4 (2 o más eventos N1/N2 = N1; los HBP nunca suben un foco a N1); las áreas son nombres exactos de AREA_GEO; revisaste los eventos abiertos a la fecha de cierre; leíste la descripción de todos los eventos y aplicaste la revaloración del punto 4; cada foco nace de al menos un evento N1/N2, salvo los focos de solo HBP, que tienen 3 o más HBP del mismo tema; todos los focos N1 van antes que los N2; dentro de cada nivel, los focos con reiteración/evidencia van antes que los aislados y se ordenan como indica el punto 4; ningún tema se llama "Otro"; los eventos con riesgo "Otro" fueron asignados a un tema leyendo su descripción; cada foco contiene al menos un dato concreto de sus eventos; el NIVEL (color) y la PRIORIDAD (orden) de cada foco siguen el punto 4; ningún HBP definió un nivel; los conteos de indicadores y Recurrente cuadran; y no quedan textos guía.</a:t>
             </a:r>
             <a:endParaRPr lang="en-US" sz="600" dirty="0"/>
           </a:p>
@@ -10610,15 +10695,15 @@
               <a:buNone/>
             </a:pPr>
             <a:r>
-              <a:rPr lang="en-US" sz="930" dirty="0">
-                <a:solidFill>
-                  <a:srgbClr val="222222"/>
-                </a:solidFill>
-                <a:latin typeface="Arial" pitchFamily="34" charset="0"/>
-                <a:ea typeface="Arial" pitchFamily="34" charset="-122"/>
-                <a:cs typeface="Arial" pitchFamily="34" charset="-120"/>
-              </a:rPr>
-              <a:t>Define el color. Leer la descripción: un HBP o CBP puede subir de criticidad. N1 · alta (roja): ACC, CAAP, CA, o 2 o más HAP/CBP del mismo tema. N2 · intermedia (naranja): un solo HAP o CBP, o foco de 3+ HBP. Los HBP no cuentan para el nivel.</a:t>
+              <a:rPr lang="en-US" sz="840" dirty="0">
+                <a:solidFill>
+                  <a:srgbClr val="222222"/>
+                </a:solidFill>
+                <a:latin typeface="Arial" pitchFamily="34" charset="0"/>
+                <a:ea typeface="Arial" pitchFamily="34" charset="-122"/>
+                <a:cs typeface="Arial" pitchFamily="34" charset="-120"/>
+              </a:rPr>
+              <a:t>Define el color. Leer la descripción: un HBP o CBP puede subir de criticidad. N1 · alta (roja): ACC, CAAP, CA, o 2 o más HAP/CBP del mismo tema. N2 · intermedia (naranja): un solo HAP o CBP (+ HBP), o foco de 3+ HBP. Ej.: HAP + HBP = N2; HAP + HAP = N1. Los HBP nunca suben a N1.</a:t>
             </a:r>
             <a:endParaRPr lang="en-US" sz="930" dirty="0"/>
           </a:p>

</xml_diff>

<commit_message>
Assurance ITO v1.3: ejemplos explícitos de N1 (2+ HAP, 2+ CBP, HAP + CBP, CAAP siempre N1)
Co-Authored-By: Claude Opus 5.5 <noreply@anthropic.com>
Claude-Session: https://claude.ai/code/session_017MaLNPnWzNhW9Tdfmjv67V
</commit_message>
<xml_diff>
--- a/FORMATO_ASSURANCE_ITO_v1.3.pptx
+++ b/FORMATO_ASSURANCE_ITO_v1.3.pptx
@@ -7048,7 +7048,24 @@
                 <a:ea typeface="Arial" pitchFamily="34" charset="-122"/>
                 <a:cs typeface="Arial" pitchFamily="34" charset="-120"/>
               </a:rPr>
-              <a:t>      · 1 HAP + 1 HAP → N1.   · 1 HAP + 1 CBP → N1.   · 1 CAAP (solo) → N1.</a:t>
+              <a:t>      · 2 o más HAP → N1.   · 2 o más CBP → N1.   · 1 CBP + 1 HAP → N1.</a:t>
+            </a:r>
+            <a:endParaRPr lang="en-US" sz="600" dirty="0"/>
+          </a:p>
+          <a:p>
+            <a:pPr marL="0" indent="0">
+              <a:buNone/>
+            </a:pPr>
+            <a:r>
+              <a:rPr lang="en-US" sz="600" dirty="0">
+                <a:solidFill>
+                  <a:srgbClr val="222222"/>
+                </a:solidFill>
+                <a:latin typeface="Arial" pitchFamily="34" charset="0"/>
+                <a:ea typeface="Arial" pitchFamily="34" charset="-122"/>
+                <a:cs typeface="Arial" pitchFamily="34" charset="-120"/>
+              </a:rPr>
+              <a:t>      · Un CAAP SIEMPRE es N1, vaya solo o acompañado de cualquier otro evento (CAAP solo → N1; CAAP + HBP → N1; CAAP + HAP → N1). Lo mismo aplica a un ACC y a un evento revalorizado a CA.</a:t>
             </a:r>
             <a:endParaRPr lang="en-US" sz="600" dirty="0"/>
           </a:p>
@@ -10703,7 +10720,7 @@
                 <a:ea typeface="Arial" pitchFamily="34" charset="-122"/>
                 <a:cs typeface="Arial" pitchFamily="34" charset="-120"/>
               </a:rPr>
-              <a:t>Define el color. Leer la descripción: un HBP o CBP puede subir de criticidad. N1 · alta (roja): ACC, CAAP, CA, o 2 o más HAP/CBP del mismo tema. N2 · intermedia (naranja): un solo HAP o CBP (+ HBP), o foco de 3+ HBP. Ej.: HAP + HBP = N2; HAP + HAP = N1. Los HBP nunca suben a N1.</a:t>
+              <a:t>Define el color. Leer la descripción: un HBP o CBP puede subir de criticidad. N1 · alta (roja): ACC, CAAP, CA, o 2 o más HAP/CBP del mismo tema. N2 · intermedia (naranja): un solo HAP o CBP (+ HBP), o foco de 3+ HBP. Ej.: 2+ HAP, 2+ CBP o HAP + CBP = N1; HAP + HBP = N2. Un CAAP siempre es N1. Los HBP nunca suben a N1.</a:t>
             </a:r>
             <a:endParaRPr lang="en-US" sz="930" dirty="0"/>
           </a:p>

</xml_diff>

<commit_message>
Assurance ITO v1.3: máximo 5 focos sin contar la fila SI PRO
Agrega la fila de foco 5 (SI PRO pasa a fila 6) y ajusta instructivo,
instrucciones IA y prompt.

Co-Authored-By: Claude Opus 5.5 <noreply@anthropic.com>
Claude-Session: https://claude.ai/code/session_017MaLNPnWzNhW9Tdfmjv67V
</commit_message>
<xml_diff>
--- a/FORMATO_ASSURANCE_ITO_v1.3.pptx
+++ b/FORMATO_ASSURANCE_ITO_v1.3.pptx
@@ -1883,7 +1883,7 @@
         </p:nvGraphicFramePr>
         <p:xfrm>
           <a:off x="365760" y="1645920"/>
-          <a:ext cx="11457432" cy="3673856"/>
+          <a:ext cx="11457432" cy="3858768"/>
         </p:xfrm>
         <a:graphic>
           <a:graphicData uri="http://schemas.openxmlformats.org/drawingml/2006/table">
@@ -2273,7 +2273,7 @@
                   </a:ext>
                 </a:extLst>
               </a:tr>
-              <a:tr h="640080">
+              <a:tr h="566928">
                 <a:tc>
                   <a:txBody>
                     <a:bodyPr/>
@@ -2283,7 +2283,7 @@
                         <a:buNone/>
                       </a:pPr>
                       <a:r>
-                        <a:rPr lang="en-US" sz="1400" b="1" dirty="0">
+                        <a:rPr lang="en-US" sz="1300" b="1" dirty="0">
                           <a:solidFill>
                             <a:srgbClr val="FFFFFF"/>
                           </a:solidFill>
@@ -2304,7 +2304,7 @@
                         <a:buNone/>
                       </a:pPr>
                       <a:r>
-                        <a:rPr lang="en-US" sz="800" b="1" dirty="0">
+                        <a:rPr lang="en-US" sz="750" b="1" dirty="0">
                           <a:solidFill>
                             <a:srgbClr val="FFFFFF"/>
                           </a:solidFill>
@@ -2727,7 +2727,7 @@
                   </a:ext>
                 </a:extLst>
               </a:tr>
-              <a:tr h="640080">
+              <a:tr h="566928">
                 <a:tc>
                   <a:txBody>
                     <a:bodyPr/>
@@ -2737,7 +2737,7 @@
                         <a:buNone/>
                       </a:pPr>
                       <a:r>
-                        <a:rPr lang="en-US" sz="1400" b="1" dirty="0">
+                        <a:rPr lang="en-US" sz="1300" b="1" dirty="0">
                           <a:solidFill>
                             <a:srgbClr val="FFFFFF"/>
                           </a:solidFill>
@@ -2758,7 +2758,7 @@
                         <a:buNone/>
                       </a:pPr>
                       <a:r>
-                        <a:rPr lang="en-US" sz="800" b="1" dirty="0">
+                        <a:rPr lang="en-US" sz="750" b="1" dirty="0">
                           <a:solidFill>
                             <a:srgbClr val="FFFFFF"/>
                           </a:solidFill>
@@ -3191,7 +3191,7 @@
                   </a:ext>
                 </a:extLst>
               </a:tr>
-              <a:tr h="640080">
+              <a:tr h="566928">
                 <a:tc>
                   <a:txBody>
                     <a:bodyPr/>
@@ -3201,7 +3201,7 @@
                         <a:buNone/>
                       </a:pPr>
                       <a:r>
-                        <a:rPr lang="en-US" sz="1400" b="1" dirty="0">
+                        <a:rPr lang="en-US" sz="1300" b="1" dirty="0">
                           <a:solidFill>
                             <a:srgbClr val="FFFFFF"/>
                           </a:solidFill>
@@ -3222,7 +3222,7 @@
                         <a:buNone/>
                       </a:pPr>
                       <a:r>
-                        <a:rPr lang="en-US" sz="800" b="1" dirty="0">
+                        <a:rPr lang="en-US" sz="750" b="1" dirty="0">
                           <a:solidFill>
                             <a:srgbClr val="FFFFFF"/>
                           </a:solidFill>
@@ -3655,7 +3655,7 @@
                   </a:ext>
                 </a:extLst>
               </a:tr>
-              <a:tr h="640080">
+              <a:tr h="566928">
                 <a:tc>
                   <a:txBody>
                     <a:bodyPr/>
@@ -3665,7 +3665,7 @@
                         <a:buNone/>
                       </a:pPr>
                       <a:r>
-                        <a:rPr lang="en-US" sz="1400" b="1" dirty="0">
+                        <a:rPr lang="en-US" sz="1300" b="1" dirty="0">
                           <a:solidFill>
                             <a:srgbClr val="FFFFFF"/>
                           </a:solidFill>
@@ -3686,7 +3686,7 @@
                         <a:buNone/>
                       </a:pPr>
                       <a:r>
-                        <a:rPr lang="en-US" sz="800" b="1" dirty="0">
+                        <a:rPr lang="en-US" sz="750" b="1" dirty="0">
                           <a:solidFill>
                             <a:srgbClr val="FFFFFF"/>
                           </a:solidFill>
@@ -4109,7 +4109,7 @@
                   </a:ext>
                 </a:extLst>
               </a:tr>
-              <a:tr h="640080">
+              <a:tr h="566928">
                 <a:tc>
                   <a:txBody>
                     <a:bodyPr/>
@@ -4119,7 +4119,7 @@
                         <a:buNone/>
                       </a:pPr>
                       <a:r>
-                        <a:rPr lang="en-US" sz="1400" b="1" dirty="0">
+                        <a:rPr lang="en-US" sz="1300" b="1" dirty="0">
                           <a:solidFill>
                             <a:srgbClr val="FFFFFF"/>
                           </a:solidFill>
@@ -4140,7 +4140,461 @@
                         <a:buNone/>
                       </a:pPr>
                       <a:r>
-                        <a:rPr lang="en-US" sz="800" b="1" dirty="0">
+                        <a:rPr lang="en-US" sz="750" b="1" dirty="0">
+                          <a:solidFill>
+                            <a:srgbClr val="FFFFFF"/>
+                          </a:solidFill>
+                          <a:latin typeface="Arial" pitchFamily="34" charset="0"/>
+                          <a:ea typeface="Arial" pitchFamily="34" charset="-122"/>
+                          <a:cs typeface="Arial" pitchFamily="34" charset="-120"/>
+                        </a:rPr>
+                        <a:t>N2 · CRITICIDAD INTERMEDIA</a:t>
+                      </a:r>
+                      <a:endParaRPr lang="en-US" sz="800" dirty="0">
+                        <a:latin typeface="Arial" charset="0"/>
+                        <a:ea typeface="Arial" charset="0"/>
+                        <a:cs typeface="Arial" charset="0"/>
+                      </a:endParaRPr>
+                    </a:p>
+                  </a:txBody>
+                  <a:tcPr marL="50800" marR="50800" marT="25400" marB="25400" anchor="ctr">
+                    <a:lnL w="9525" cap="flat" cmpd="sng" algn="ctr">
+                      <a:solidFill>
+                        <a:srgbClr val="C9D3E0"/>
+                      </a:solidFill>
+                      <a:prstDash val="solid"/>
+                      <a:round/>
+                      <a:headEnd type="none" w="med" len="med"/>
+                      <a:tailEnd type="none" w="med" len="med"/>
+                    </a:lnL>
+                    <a:lnR w="9525" cap="flat" cmpd="sng" algn="ctr">
+                      <a:solidFill>
+                        <a:srgbClr val="C9D3E0"/>
+                      </a:solidFill>
+                      <a:prstDash val="solid"/>
+                      <a:round/>
+                      <a:headEnd type="none" w="med" len="med"/>
+                      <a:tailEnd type="none" w="med" len="med"/>
+                    </a:lnR>
+                    <a:lnT w="9525" cap="flat" cmpd="sng" algn="ctr">
+                      <a:solidFill>
+                        <a:srgbClr val="C9D3E0"/>
+                      </a:solidFill>
+                      <a:prstDash val="solid"/>
+                      <a:round/>
+                      <a:headEnd type="none" w="med" len="med"/>
+                      <a:tailEnd type="none" w="med" len="med"/>
+                    </a:lnT>
+                    <a:lnB w="9525" cap="flat" cmpd="sng" algn="ctr">
+                      <a:solidFill>
+                        <a:srgbClr val="C9D3E0"/>
+                      </a:solidFill>
+                      <a:prstDash val="solid"/>
+                      <a:round/>
+                      <a:headEnd type="none" w="med" len="med"/>
+                      <a:tailEnd type="none" w="med" len="med"/>
+                    </a:lnB>
+                    <a:solidFill>
+                      <a:srgbClr val="E67E22"/>
+                    </a:solidFill>
+                  </a:tcPr>
+                </a:tc>
+                <a:tc>
+                  <a:txBody>
+                    <a:bodyPr/>
+                    <a:lstStyle/>
+                    <a:p>
+                      <a:pPr marL="0" indent="0">
+                        <a:buNone/>
+                      </a:pPr>
+                      <a:r>
+                        <a:rPr lang="en-US" sz="630" b="1" i="1" dirty="0">
+                          <a:solidFill>
+                            <a:srgbClr val="7A8594"/>
+                          </a:solidFill>
+                          <a:latin typeface="Arial" pitchFamily="34" charset="0"/>
+                          <a:ea typeface="Arial" pitchFamily="34" charset="-122"/>
+                          <a:cs typeface="Arial" pitchFamily="34" charset="-120"/>
+                        </a:rPr>
+                        <a:t>[Tema del foco]. </a:t>
+                      </a:r>
+                      <a:r>
+                        <a:rPr lang="en-US" sz="630" i="1" dirty="0">
+                          <a:solidFill>
+                            <a:srgbClr val="7A8594"/>
+                          </a:solidFill>
+                          <a:latin typeface="Arial" pitchFamily="34" charset="0"/>
+                          <a:ea typeface="Arial" pitchFamily="34" charset="-122"/>
+                          <a:cs typeface="Arial" pitchFamily="34" charset="-120"/>
+                        </a:rPr>
+                        <a:t>[Verificar… qué se revisa, dónde y bajo qué estándar. Máx. 3 líneas]</a:t>
+                      </a:r>
+                      <a:endParaRPr lang="en-US" sz="630" dirty="0">
+                        <a:latin typeface="Arial" charset="0"/>
+                        <a:ea typeface="Arial" charset="0"/>
+                        <a:cs typeface="Arial" charset="0"/>
+                      </a:endParaRPr>
+                    </a:p>
+                    <a:p>
+                      <a:pPr marL="0" indent="0">
+                        <a:buNone/>
+                      </a:pPr>
+                      <a:r>
+                        <a:rPr lang="en-US" sz="630" b="1" dirty="0">
+                          <a:solidFill>
+                            <a:srgbClr val="B35C00"/>
+                          </a:solidFill>
+                          <a:latin typeface="Arial" pitchFamily="34" charset="0"/>
+                          <a:ea typeface="Arial" pitchFamily="34" charset="-122"/>
+                          <a:cs typeface="Arial" pitchFamily="34" charset="-120"/>
+                        </a:rPr>
+                        <a:t>Criterio de restricción: </a:t>
+                      </a:r>
+                      <a:r>
+                        <a:rPr lang="en-US" sz="630" i="1" dirty="0">
+                          <a:solidFill>
+                            <a:srgbClr val="7A8594"/>
+                          </a:solidFill>
+                          <a:latin typeface="Arial" pitchFamily="34" charset="0"/>
+                          <a:ea typeface="Arial" pitchFamily="34" charset="-122"/>
+                          <a:cs typeface="Arial" pitchFamily="34" charset="-120"/>
+                        </a:rPr>
+                        <a:t>[Cuándo se prohíbe o se detiene la tarea. Máx. 2 líneas]</a:t>
+                      </a:r>
+                      <a:endParaRPr lang="en-US" sz="630" dirty="0">
+                        <a:latin typeface="Arial" charset="0"/>
+                        <a:ea typeface="Arial" charset="0"/>
+                        <a:cs typeface="Arial" charset="0"/>
+                      </a:endParaRPr>
+                    </a:p>
+                  </a:txBody>
+                  <a:tcPr marL="50800" marR="50800" marT="25400" marB="25400" anchor="ctr">
+                    <a:lnL w="9525" cap="flat" cmpd="sng" algn="ctr">
+                      <a:solidFill>
+                        <a:srgbClr val="C9D3E0"/>
+                      </a:solidFill>
+                      <a:prstDash val="solid"/>
+                      <a:round/>
+                      <a:headEnd type="none" w="med" len="med"/>
+                      <a:tailEnd type="none" w="med" len="med"/>
+                    </a:lnL>
+                    <a:lnR w="9525" cap="flat" cmpd="sng" algn="ctr">
+                      <a:solidFill>
+                        <a:srgbClr val="C9D3E0"/>
+                      </a:solidFill>
+                      <a:prstDash val="solid"/>
+                      <a:round/>
+                      <a:headEnd type="none" w="med" len="med"/>
+                      <a:tailEnd type="none" w="med" len="med"/>
+                    </a:lnR>
+                    <a:lnT w="9525" cap="flat" cmpd="sng" algn="ctr">
+                      <a:solidFill>
+                        <a:srgbClr val="C9D3E0"/>
+                      </a:solidFill>
+                      <a:prstDash val="solid"/>
+                      <a:round/>
+                      <a:headEnd type="none" w="med" len="med"/>
+                      <a:tailEnd type="none" w="med" len="med"/>
+                    </a:lnT>
+                    <a:lnB w="9525" cap="flat" cmpd="sng" algn="ctr">
+                      <a:solidFill>
+                        <a:srgbClr val="C9D3E0"/>
+                      </a:solidFill>
+                      <a:prstDash val="solid"/>
+                      <a:round/>
+                      <a:headEnd type="none" w="med" len="med"/>
+                      <a:tailEnd type="none" w="med" len="med"/>
+                    </a:lnB>
+                    <a:solidFill>
+                      <a:srgbClr val="FFFFFF"/>
+                    </a:solidFill>
+                  </a:tcPr>
+                </a:tc>
+                <a:tc>
+                  <a:txBody>
+                    <a:bodyPr/>
+                    <a:lstStyle/>
+                    <a:p>
+                      <a:pPr marL="0" indent="0">
+                        <a:buNone/>
+                      </a:pPr>
+                      <a:r>
+                        <a:rPr lang="en-US" sz="620" b="1" dirty="0">
+                          <a:solidFill>
+                            <a:srgbClr val="222222"/>
+                          </a:solidFill>
+                          <a:latin typeface="Arial" pitchFamily="34" charset="0"/>
+                          <a:ea typeface="Arial" pitchFamily="34" charset="-122"/>
+                          <a:cs typeface="Arial" pitchFamily="34" charset="-120"/>
+                        </a:rPr>
+                        <a:t>TIPO ID [N°] – EECC:</a:t>
+                      </a:r>
+                      <a:r>
+                        <a:rPr lang="en-US" sz="620" i="1" dirty="0">
+                          <a:solidFill>
+                            <a:srgbClr val="7A8594"/>
+                          </a:solidFill>
+                          <a:latin typeface="Arial" pitchFamily="34" charset="0"/>
+                          <a:ea typeface="Arial" pitchFamily="34" charset="-122"/>
+                          <a:cs typeface="Arial" pitchFamily="34" charset="-120"/>
+                        </a:rPr>
+                        <a:t> [qué ocurrió, 1 línea]</a:t>
+                      </a:r>
+                      <a:endParaRPr lang="en-US" sz="620" dirty="0">
+                        <a:latin typeface="Arial" charset="0"/>
+                        <a:ea typeface="Arial" charset="0"/>
+                        <a:cs typeface="Arial" charset="0"/>
+                      </a:endParaRPr>
+                    </a:p>
+                    <a:p>
+                      <a:pPr marL="0" indent="0">
+                        <a:buNone/>
+                      </a:pPr>
+                      <a:r>
+                        <a:rPr lang="en-US" sz="620" b="1" dirty="0">
+                          <a:solidFill>
+                            <a:srgbClr val="222222"/>
+                          </a:solidFill>
+                          <a:latin typeface="Arial" pitchFamily="34" charset="0"/>
+                          <a:ea typeface="Arial" pitchFamily="34" charset="-122"/>
+                          <a:cs typeface="Arial" pitchFamily="34" charset="-120"/>
+                        </a:rPr>
+                        <a:t>TIPO ID [N°] – EECC:</a:t>
+                      </a:r>
+                      <a:r>
+                        <a:rPr lang="en-US" sz="620" i="1" dirty="0">
+                          <a:solidFill>
+                            <a:srgbClr val="7A8594"/>
+                          </a:solidFill>
+                          <a:latin typeface="Arial" pitchFamily="34" charset="0"/>
+                          <a:ea typeface="Arial" pitchFamily="34" charset="-122"/>
+                          <a:cs typeface="Arial" pitchFamily="34" charset="-120"/>
+                        </a:rPr>
+                        <a:t> [qué ocurrió, 1 línea]</a:t>
+                      </a:r>
+                      <a:endParaRPr lang="en-US" sz="620" dirty="0">
+                        <a:latin typeface="Arial" charset="0"/>
+                        <a:ea typeface="Arial" charset="0"/>
+                        <a:cs typeface="Arial" charset="0"/>
+                      </a:endParaRPr>
+                    </a:p>
+                  </a:txBody>
+                  <a:tcPr marL="50800" marR="50800" marT="25400" marB="25400" anchor="ctr">
+                    <a:lnL w="9525" cap="flat" cmpd="sng" algn="ctr">
+                      <a:solidFill>
+                        <a:srgbClr val="C9D3E0"/>
+                      </a:solidFill>
+                      <a:prstDash val="solid"/>
+                      <a:round/>
+                      <a:headEnd type="none" w="med" len="med"/>
+                      <a:tailEnd type="none" w="med" len="med"/>
+                    </a:lnL>
+                    <a:lnR w="9525" cap="flat" cmpd="sng" algn="ctr">
+                      <a:solidFill>
+                        <a:srgbClr val="C9D3E0"/>
+                      </a:solidFill>
+                      <a:prstDash val="solid"/>
+                      <a:round/>
+                      <a:headEnd type="none" w="med" len="med"/>
+                      <a:tailEnd type="none" w="med" len="med"/>
+                    </a:lnR>
+                    <a:lnT w="9525" cap="flat" cmpd="sng" algn="ctr">
+                      <a:solidFill>
+                        <a:srgbClr val="C9D3E0"/>
+                      </a:solidFill>
+                      <a:prstDash val="solid"/>
+                      <a:round/>
+                      <a:headEnd type="none" w="med" len="med"/>
+                      <a:tailEnd type="none" w="med" len="med"/>
+                    </a:lnT>
+                    <a:lnB w="9525" cap="flat" cmpd="sng" algn="ctr">
+                      <a:solidFill>
+                        <a:srgbClr val="C9D3E0"/>
+                      </a:solidFill>
+                      <a:prstDash val="solid"/>
+                      <a:round/>
+                      <a:headEnd type="none" w="med" len="med"/>
+                      <a:tailEnd type="none" w="med" len="med"/>
+                    </a:lnB>
+                    <a:solidFill>
+                      <a:srgbClr val="FFFFFF"/>
+                    </a:solidFill>
+                  </a:tcPr>
+                </a:tc>
+                <a:tc>
+                  <a:txBody>
+                    <a:bodyPr/>
+                    <a:lstStyle/>
+                    <a:p>
+                      <a:pPr marL="0" indent="0">
+                        <a:buNone/>
+                      </a:pPr>
+                      <a:r>
+                        <a:rPr lang="en-US" sz="630" i="1" dirty="0">
+                          <a:solidFill>
+                            <a:srgbClr val="7A8594"/>
+                          </a:solidFill>
+                          <a:latin typeface="Arial" pitchFamily="34" charset="0"/>
+                          <a:ea typeface="Arial" pitchFamily="34" charset="-122"/>
+                          <a:cs typeface="Arial" pitchFamily="34" charset="-120"/>
+                        </a:rPr>
+                        <a:t>[Herramienta + herramienta + ASP]</a:t>
+                      </a:r>
+                      <a:endParaRPr lang="en-US" sz="630" dirty="0">
+                        <a:latin typeface="Arial" charset="0"/>
+                        <a:ea typeface="Arial" charset="0"/>
+                        <a:cs typeface="Arial" charset="0"/>
+                      </a:endParaRPr>
+                    </a:p>
+                  </a:txBody>
+                  <a:tcPr marL="50800" marR="50800" marT="25400" marB="25400" anchor="ctr">
+                    <a:lnL w="9525" cap="flat" cmpd="sng" algn="ctr">
+                      <a:solidFill>
+                        <a:srgbClr val="C9D3E0"/>
+                      </a:solidFill>
+                      <a:prstDash val="solid"/>
+                      <a:round/>
+                      <a:headEnd type="none" w="med" len="med"/>
+                      <a:tailEnd type="none" w="med" len="med"/>
+                    </a:lnL>
+                    <a:lnR w="9525" cap="flat" cmpd="sng" algn="ctr">
+                      <a:solidFill>
+                        <a:srgbClr val="C9D3E0"/>
+                      </a:solidFill>
+                      <a:prstDash val="solid"/>
+                      <a:round/>
+                      <a:headEnd type="none" w="med" len="med"/>
+                      <a:tailEnd type="none" w="med" len="med"/>
+                    </a:lnR>
+                    <a:lnT w="9525" cap="flat" cmpd="sng" algn="ctr">
+                      <a:solidFill>
+                        <a:srgbClr val="C9D3E0"/>
+                      </a:solidFill>
+                      <a:prstDash val="solid"/>
+                      <a:round/>
+                      <a:headEnd type="none" w="med" len="med"/>
+                      <a:tailEnd type="none" w="med" len="med"/>
+                    </a:lnT>
+                    <a:lnB w="9525" cap="flat" cmpd="sng" algn="ctr">
+                      <a:solidFill>
+                        <a:srgbClr val="C9D3E0"/>
+                      </a:solidFill>
+                      <a:prstDash val="solid"/>
+                      <a:round/>
+                      <a:headEnd type="none" w="med" len="med"/>
+                      <a:tailEnd type="none" w="med" len="med"/>
+                    </a:lnB>
+                    <a:solidFill>
+                      <a:srgbClr val="FFFFFF"/>
+                    </a:solidFill>
+                  </a:tcPr>
+                </a:tc>
+                <a:tc>
+                  <a:txBody>
+                    <a:bodyPr/>
+                    <a:lstStyle/>
+                    <a:p>
+                      <a:pPr marL="0" indent="0">
+                        <a:buNone/>
+                      </a:pPr>
+                      <a:r>
+                        <a:rPr lang="en-US" sz="630" i="1" dirty="0">
+                          <a:solidFill>
+                            <a:srgbClr val="7A8594"/>
+                          </a:solidFill>
+                          <a:latin typeface="Arial" pitchFamily="34" charset="0"/>
+                          <a:ea typeface="Arial" pitchFamily="34" charset="-122"/>
+                          <a:cs typeface="Arial" pitchFamily="34" charset="-120"/>
+                        </a:rPr>
+                        <a:t>[Registro verificable] / registro fotográfico</a:t>
+                      </a:r>
+                      <a:endParaRPr lang="en-US" sz="630" dirty="0">
+                        <a:latin typeface="Arial" charset="0"/>
+                        <a:ea typeface="Arial" charset="0"/>
+                        <a:cs typeface="Arial" charset="0"/>
+                      </a:endParaRPr>
+                    </a:p>
+                  </a:txBody>
+                  <a:tcPr marL="50800" marR="50800" marT="25400" marB="25400" anchor="ctr">
+                    <a:lnL w="9525" cap="flat" cmpd="sng" algn="ctr">
+                      <a:solidFill>
+                        <a:srgbClr val="C9D3E0"/>
+                      </a:solidFill>
+                      <a:prstDash val="solid"/>
+                      <a:round/>
+                      <a:headEnd type="none" w="med" len="med"/>
+                      <a:tailEnd type="none" w="med" len="med"/>
+                    </a:lnL>
+                    <a:lnR w="9525" cap="flat" cmpd="sng" algn="ctr">
+                      <a:solidFill>
+                        <a:srgbClr val="C9D3E0"/>
+                      </a:solidFill>
+                      <a:prstDash val="solid"/>
+                      <a:round/>
+                      <a:headEnd type="none" w="med" len="med"/>
+                      <a:tailEnd type="none" w="med" len="med"/>
+                    </a:lnR>
+                    <a:lnT w="9525" cap="flat" cmpd="sng" algn="ctr">
+                      <a:solidFill>
+                        <a:srgbClr val="C9D3E0"/>
+                      </a:solidFill>
+                      <a:prstDash val="solid"/>
+                      <a:round/>
+                      <a:headEnd type="none" w="med" len="med"/>
+                      <a:tailEnd type="none" w="med" len="med"/>
+                    </a:lnT>
+                    <a:lnB w="9525" cap="flat" cmpd="sng" algn="ctr">
+                      <a:solidFill>
+                        <a:srgbClr val="C9D3E0"/>
+                      </a:solidFill>
+                      <a:prstDash val="solid"/>
+                      <a:round/>
+                      <a:headEnd type="none" w="med" len="med"/>
+                      <a:tailEnd type="none" w="med" len="med"/>
+                    </a:lnB>
+                    <a:solidFill>
+                      <a:srgbClr val="FFFFFF"/>
+                    </a:solidFill>
+                  </a:tcPr>
+                </a:tc>
+                <a:extLst>
+                  <a:ext uri="{0D108BD9-81ED-4DB2-BD59-A6C34878D82A}">
+                    <a16:rowId xmlns:a16="http://schemas.microsoft.com/office/drawing/2014/main" val="10005"/>
+                  </a:ext>
+                </a:extLst>
+              </a:tr>
+              <a:tr h="713232">
+                <a:tc>
+                  <a:txBody>
+                    <a:bodyPr/>
+                    <a:lstStyle/>
+                    <a:p>
+                      <a:pPr marL="0" indent="0" algn="ctr">
+                        <a:buNone/>
+                      </a:pPr>
+                      <a:r>
+                        <a:rPr lang="en-US" sz="1400" b="1" dirty="0">
+                          <a:solidFill>
+                            <a:srgbClr val="FFFFFF"/>
+                          </a:solidFill>
+                          <a:latin typeface="Arial" pitchFamily="34" charset="0"/>
+                          <a:ea typeface="Arial" charset="0"/>
+                          <a:cs typeface="Arial" pitchFamily="34" charset="-120"/>
+                        </a:rPr>
+                        <a:t>6</a:t>
+                      </a:r>
+                      <a:endParaRPr lang="en-US" sz="800" dirty="0">
+                        <a:latin typeface="Arial" charset="0"/>
+                        <a:ea typeface="Arial" charset="0"/>
+                        <a:cs typeface="Arial" charset="0"/>
+                      </a:endParaRPr>
+                    </a:p>
+                    <a:p>
+                      <a:pPr marL="0" indent="0" algn="ctr">
+                        <a:buNone/>
+                      </a:pPr>
+                      <a:r>
+                        <a:rPr lang="en-US" sz="750" b="1" dirty="0">
                           <a:solidFill>
                             <a:srgbClr val="FFFFFF"/>
                           </a:solidFill>
@@ -4917,7 +5371,7 @@
         </p:nvSpPr>
         <p:spPr>
           <a:xfrm>
-            <a:off x="365760" y="5852160"/>
+            <a:off x="365760" y="5943600"/>
             <a:ext cx="960120" cy="292608"/>
           </a:xfrm>
           <a:prstGeom prst="rect">
@@ -4958,7 +5412,7 @@
         </p:nvSpPr>
         <p:spPr>
           <a:xfrm>
-            <a:off x="1325880" y="5852160"/>
+            <a:off x="1325880" y="5943600"/>
             <a:ext cx="10497312" cy="292608"/>
           </a:xfrm>
           <a:prstGeom prst="rect">
@@ -4990,7 +5444,7 @@
         </p:nvSpPr>
         <p:spPr>
           <a:xfrm>
-            <a:off x="1417320" y="5852160"/>
+            <a:off x="1417320" y="5943600"/>
             <a:ext cx="10314432" cy="292608"/>
           </a:xfrm>
           <a:prstGeom prst="rect">
@@ -5062,7 +5516,7 @@
         </p:nvSpPr>
         <p:spPr>
           <a:xfrm>
-            <a:off x="365760" y="6236208"/>
+            <a:off x="365760" y="6327648"/>
             <a:ext cx="6172200" cy="219456"/>
           </a:xfrm>
           <a:prstGeom prst="rect">
@@ -5094,7 +5548,7 @@
         </p:nvSpPr>
         <p:spPr>
           <a:xfrm>
-            <a:off x="457200" y="6236208"/>
+            <a:off x="457200" y="6327648"/>
             <a:ext cx="5989320" cy="219456"/>
           </a:xfrm>
           <a:prstGeom prst="rect">
@@ -5141,7 +5595,7 @@
         </p:blipFill>
         <p:spPr>
           <a:xfrm>
-            <a:off x="438912" y="6528816"/>
+            <a:off x="438912" y="6620256"/>
             <a:ext cx="219456" cy="219456"/>
           </a:xfrm>
           <a:prstGeom prst="rect">
@@ -5157,7 +5611,7 @@
         </p:nvSpPr>
         <p:spPr>
           <a:xfrm>
-            <a:off x="694944" y="6510528"/>
+            <a:off x="694944" y="6601968"/>
             <a:ext cx="1673352" cy="256032"/>
           </a:xfrm>
           <a:prstGeom prst="rect">
@@ -5196,7 +5650,7 @@
         </p:nvSpPr>
         <p:spPr>
           <a:xfrm>
-            <a:off x="438912" y="6784848"/>
+            <a:off x="438912" y="6876288"/>
             <a:ext cx="1911096" cy="274320"/>
           </a:xfrm>
           <a:prstGeom prst="rect">
@@ -5235,7 +5689,7 @@
         </p:nvSpPr>
         <p:spPr>
           <a:xfrm>
-            <a:off x="438912" y="7077456"/>
+            <a:off x="438912" y="7168896"/>
             <a:ext cx="1911096" cy="786384"/>
           </a:xfrm>
           <a:prstGeom prst="rect">
@@ -5317,7 +5771,7 @@
         </p:nvSpPr>
         <p:spPr>
           <a:xfrm>
-            <a:off x="2423160" y="6556248"/>
+            <a:off x="2423160" y="6647688"/>
             <a:ext cx="9144" cy="1280160"/>
           </a:xfrm>
           <a:prstGeom prst="rect">
@@ -5357,7 +5811,7 @@
         </p:blipFill>
         <p:spPr>
           <a:xfrm>
-            <a:off x="2496312" y="6528816"/>
+            <a:off x="2496312" y="6620256"/>
             <a:ext cx="219456" cy="219456"/>
           </a:xfrm>
           <a:prstGeom prst="rect">
@@ -5373,7 +5827,7 @@
         </p:nvSpPr>
         <p:spPr>
           <a:xfrm>
-            <a:off x="2752344" y="6510528"/>
+            <a:off x="2752344" y="6601968"/>
             <a:ext cx="1673352" cy="256032"/>
           </a:xfrm>
           <a:prstGeom prst="rect">
@@ -5412,7 +5866,7 @@
         </p:nvSpPr>
         <p:spPr>
           <a:xfrm>
-            <a:off x="2496312" y="6784848"/>
+            <a:off x="2496312" y="6876288"/>
             <a:ext cx="1911096" cy="274320"/>
           </a:xfrm>
           <a:prstGeom prst="rect">
@@ -5451,7 +5905,7 @@
         </p:nvSpPr>
         <p:spPr>
           <a:xfrm>
-            <a:off x="2496312" y="7077456"/>
+            <a:off x="2496312" y="7168896"/>
             <a:ext cx="1911096" cy="786384"/>
           </a:xfrm>
           <a:prstGeom prst="rect">
@@ -5533,7 +5987,7 @@
         </p:nvSpPr>
         <p:spPr>
           <a:xfrm>
-            <a:off x="4480560" y="6556248"/>
+            <a:off x="4480560" y="6647688"/>
             <a:ext cx="9144" cy="1280160"/>
           </a:xfrm>
           <a:prstGeom prst="rect">
@@ -5573,7 +6027,7 @@
         </p:blipFill>
         <p:spPr>
           <a:xfrm>
-            <a:off x="4553712" y="6528816"/>
+            <a:off x="4553712" y="6620256"/>
             <a:ext cx="219456" cy="219456"/>
           </a:xfrm>
           <a:prstGeom prst="rect">
@@ -5589,7 +6043,7 @@
         </p:nvSpPr>
         <p:spPr>
           <a:xfrm>
-            <a:off x="4809744" y="6510528"/>
+            <a:off x="4809744" y="6601968"/>
             <a:ext cx="1673352" cy="256032"/>
           </a:xfrm>
           <a:prstGeom prst="rect">
@@ -5628,7 +6082,7 @@
         </p:nvSpPr>
         <p:spPr>
           <a:xfrm>
-            <a:off x="4553712" y="6784848"/>
+            <a:off x="4553712" y="6876288"/>
             <a:ext cx="1911096" cy="274320"/>
           </a:xfrm>
           <a:prstGeom prst="rect">
@@ -5667,7 +6121,7 @@
         </p:nvSpPr>
         <p:spPr>
           <a:xfrm>
-            <a:off x="4553712" y="7077456"/>
+            <a:off x="4553712" y="7168896"/>
             <a:ext cx="1911096" cy="786384"/>
           </a:xfrm>
           <a:prstGeom prst="rect">
@@ -5749,7 +6203,7 @@
         </p:nvSpPr>
         <p:spPr>
           <a:xfrm>
-            <a:off x="6680200" y="6236208"/>
+            <a:off x="6680200" y="6327648"/>
             <a:ext cx="2527300" cy="1645920"/>
           </a:xfrm>
           <a:prstGeom prst="roundRect">
@@ -5783,7 +6237,7 @@
         </p:nvSpPr>
         <p:spPr>
           <a:xfrm>
-            <a:off x="6715760" y="6248579"/>
+            <a:off x="6715760" y="6340019"/>
             <a:ext cx="2387600" cy="310896"/>
           </a:xfrm>
           <a:prstGeom prst="rect">
@@ -5822,7 +6276,7 @@
         </p:nvSpPr>
         <p:spPr>
           <a:xfrm>
-            <a:off x="6743700" y="6620256"/>
+            <a:off x="6743700" y="6711696"/>
             <a:ext cx="2400300" cy="1207008"/>
           </a:xfrm>
           <a:prstGeom prst="rect">
@@ -5949,7 +6403,7 @@
         </p:nvSpPr>
         <p:spPr>
           <a:xfrm>
-            <a:off x="9296400" y="6236208"/>
+            <a:off x="9296400" y="6327648"/>
             <a:ext cx="2527300" cy="1645920"/>
           </a:xfrm>
           <a:prstGeom prst="roundRect">
@@ -5983,7 +6437,7 @@
         </p:nvSpPr>
         <p:spPr>
           <a:xfrm>
-            <a:off x="9372600" y="6272784"/>
+            <a:off x="9372600" y="6364224"/>
             <a:ext cx="2387600" cy="310896"/>
           </a:xfrm>
           <a:prstGeom prst="rect">
@@ -6022,7 +6476,7 @@
         </p:nvSpPr>
         <p:spPr>
           <a:xfrm>
-            <a:off x="9372600" y="6620256"/>
+            <a:off x="9372600" y="6711696"/>
             <a:ext cx="2400300" cy="1207008"/>
           </a:xfrm>
           <a:prstGeom prst="rect">
@@ -6776,7 +7230,7 @@
                 <a:ea typeface="Arial" pitchFamily="34" charset="-122"/>
                 <a:cs typeface="Arial" pitchFamily="34" charset="-120"/>
               </a:rPr>
-              <a:t>3. SELECCIÓN DE FOCOS (filas 1 a 4)</a:t>
+              <a:t>3. SELECCIÓN DE FOCOS (filas 1 a 5)</a:t>
             </a:r>
             <a:endParaRPr lang="en-US" sz="600" dirty="0"/>
           </a:p>
@@ -6878,24 +7332,24 @@
                 <a:ea typeface="Arial" pitchFamily="34" charset="-122"/>
                 <a:cs typeface="Arial" pitchFamily="34" charset="-120"/>
               </a:rPr>
-              <a:t>- FOCO DE SOLO HBP: solo si hay 3 o más HBP del período relacionados con la misma brecha y que no estén ya en otro foco. Con 1 o 2 HBP de un tema NUNCA se arma un foco (van como evidencia complementaria o en Recurrente). Estos focos son siempre N2, van después de todos los focos con eventos N1/N2 y solo entran si queda una fila libre (máx. 4 focos). Si hay varios temas HBP que califican, entra primero el de más HBP y, si empatan, el asociado a control crítico o emergencia. OJO: la gerencia al 08-09 puso un foco con solo 2 HBP (extintores); según esta regla ese foco NO va.</a:t>
-            </a:r>
-            <a:endParaRPr lang="en-US" sz="600" dirty="0"/>
-          </a:p>
-          <a:p>
-            <a:pPr marL="0" indent="0">
-              <a:buNone/>
-            </a:pPr>
-            <a:r>
-              <a:rPr lang="en-US" sz="600" dirty="0">
-                <a:solidFill>
-                  <a:srgbClr val="222222"/>
-                </a:solidFill>
-                <a:latin typeface="Arial" pitchFamily="34" charset="0"/>
-                <a:ea typeface="Arial" pitchFamily="34" charset="-122"/>
-                <a:cs typeface="Arial" pitchFamily="34" charset="-120"/>
-              </a:rPr>
-              <a:t>- Máximo 4 focos. Si hay más, se quedan los de mayor PRIORIDAD (punto 4) y se informa al usuario cuáles quedaron fuera. Si hay menos, elimina las filas sobrantes (nunca la fila 5).</a:t>
+              <a:t>- FOCO DE SOLO HBP: solo si hay 3 o más HBP del período relacionados con la misma brecha y que no estén ya en otro foco. Con 1 o 2 HBP de un tema NUNCA se arma un foco (van como evidencia complementaria o en Recurrente). Estos focos son siempre N2, van después de todos los focos con eventos N1/N2 y solo entran si queda una fila libre (máx. 5 focos). Si hay varios temas HBP que califican, entra primero el de más HBP y, si empatan, el asociado a control crítico o emergencia. OJO: la gerencia al 08-09 puso un foco con solo 2 HBP (extintores); según esta regla ese foco NO va.</a:t>
+            </a:r>
+            <a:endParaRPr lang="en-US" sz="600" dirty="0"/>
+          </a:p>
+          <a:p>
+            <a:pPr marL="0" indent="0">
+              <a:buNone/>
+            </a:pPr>
+            <a:r>
+              <a:rPr lang="en-US" sz="600" dirty="0">
+                <a:solidFill>
+                  <a:srgbClr val="222222"/>
+                </a:solidFill>
+                <a:latin typeface="Arial" pitchFamily="34" charset="0"/>
+                <a:ea typeface="Arial" pitchFamily="34" charset="-122"/>
+                <a:cs typeface="Arial" pitchFamily="34" charset="-120"/>
+              </a:rPr>
+              <a:t>- Máximo 5 focos, SIN contar la fila fija "FOCO – SI PRO – ESTRATEGIA DE CONTROLES" (es decir, hasta 5 focos + la fila SI PRO). Si hay más, se quedan los de mayor PRIORIDAD (punto 4) y se informa al usuario cuáles quedaron fuera. Si hay menos, elimina las filas sobrantes (nunca la fila SI PRO).</a:t>
             </a:r>
             <a:endParaRPr lang="en-US" sz="600" dirty="0"/>
           </a:p>
@@ -7524,7 +7978,7 @@
                 <a:ea typeface="Arial" pitchFamily="34" charset="-122"/>
                 <a:cs typeface="Arial" pitchFamily="34" charset="-120"/>
               </a:rPr>
-              <a:t>- Texto de la celda: número de prioridad + "N1 · CRITICIDAD ALTA" o "N2 · CRITICIDAD INTERMEDIA". Ajusta texto y color de cada fila al nivel real (la plantilla trae 3 filas N1 y 1 N2 solo como referencia).</a:t>
+              <a:t>- Texto de la celda: número de prioridad + "N1 · CRITICIDAD ALTA" o "N2 · CRITICIDAD INTERMEDIA". Ajusta texto y color de cada fila al nivel real (la plantilla trae 3 filas N1 y 2 N2 solo como referencia).</a:t>
             </a:r>
             <a:endParaRPr lang="en-US" sz="600" dirty="0"/>
           </a:p>
@@ -7558,7 +8012,7 @@
                 <a:ea typeface="Arial" pitchFamily="34" charset="-122"/>
                 <a:cs typeface="Arial" pitchFamily="34" charset="-120"/>
               </a:rPr>
-              <a:t>5. FILA 5 – FOCO SI PRO · ESTRATEGIA DE CONTROLES (fila fija, gris)</a:t>
+              <a:t>5. FILA SI PRO – FOCO SI PRO · ESTRATEGIA DE CONTROLES (última fila, N° 6, fija, gris; no cuenta dentro de los 5 focos)</a:t>
             </a:r>
             <a:endParaRPr lang="en-US" sz="600" dirty="0"/>
           </a:p>
@@ -8238,7 +8692,7 @@
                 <a:ea typeface="Arial" pitchFamily="34" charset="-122"/>
                 <a:cs typeface="Arial" pitchFamily="34" charset="-120"/>
               </a:rPr>
-              <a:t>- Reemplaza todo texto gris entre [corchetes] por contenido real en color de texto normal (negro, sin cursiva). No debe quedar ningún corchete, salvo [DATO FALTANTE] y la fila 5 (fija).</a:t>
+              <a:t>- Reemplaza todo texto gris entre [corchetes] por contenido real en color de texto normal (negro, sin cursiva). No debe quedar ningún corchete, salvo [DATO FALTANTE] y la fila SI PRO (fija).</a:t>
             </a:r>
             <a:endParaRPr lang="en-US" sz="600" dirty="0"/>
           </a:p>
@@ -8357,7 +8811,7 @@
                 <a:ea typeface="Arial" pitchFamily="34" charset="-122"/>
                 <a:cs typeface="Arial" pitchFamily="34" charset="-120"/>
               </a:rPr>
-              <a:t>- Si no puedes: entrega el contenido en texto, ordenado por sección y por fila de la plantilla (Encabezado; Indicadores 14 días; Focos 1 a 4 con sus 5 columnas; Fila 5 SI PRO; Recurrente; Bloques AM/Mediodía/PM; Tendencias no asociadas; Tendencias asociadas a controles críticos), listo para copiar y pegar en cada casilla.</a:t>
+              <a:t>- Si no puedes: entrega el contenido en texto, ordenado por sección y por fila de la plantilla (Encabezado; Indicadores 14 días; Focos 1 a 5 con sus 5 columnas; Fila SI PRO; Recurrente; Bloques AM/Mediodía/PM; Tendencias no asociadas; Tendencias asociadas a controles críticos), listo para copiar y pegar en cada casilla.</a:t>
             </a:r>
             <a:endParaRPr lang="en-US" sz="600" dirty="0"/>
           </a:p>
@@ -10537,7 +10991,7 @@
                 <a:ea typeface="Arial" pitchFamily="34" charset="-122"/>
                 <a:cs typeface="Arial" pitchFamily="34" charset="-120"/>
               </a:rPr>
-              <a:t>Foco = brecha específica con eventos N1/N2; HBP del mismo tema = evidencia. 3+ HBP del mismo tema = foco N2 si queda fila. Orden: todo N1 → todo N2. En N1: reiterados, luego más grave. En N2: con evento N1/N2, luego más eventos. Máx. 4.</a:t>
+              <a:t>Foco = brecha específica con eventos N1/N2; HBP del mismo tema = evidencia. 3+ HBP del mismo tema = foco N2 si queda fila. Orden: todo N1 → todo N2. En N1: reiterados, luego más grave. En N2: con evento N1/N2, luego más eventos. Máx. 5 focos, sin contar SI PRO.</a:t>
             </a:r>
             <a:endParaRPr lang="en-US" sz="930" dirty="0"/>
           </a:p>
@@ -12213,7 +12667,7 @@
                 <a:ea typeface="Arial" pitchFamily="34" charset="-122"/>
                 <a:cs typeface="Arial" pitchFamily="34" charset="-120"/>
               </a:rPr>
-              <a:t>FILA 5 · FOCO SI PRO</a:t>
+              <a:t>FILA SI PRO (ÚLTIMA FILA)</a:t>
             </a:r>
             <a:endParaRPr lang="en-US" sz="1050" dirty="0"/>
           </a:p>
@@ -12449,7 +12903,7 @@
                 <a:ea typeface="Arial" pitchFamily="34" charset="-122"/>
                 <a:cs typeface="Arial" pitchFamily="34" charset="-120"/>
               </a:rPr>
-              <a:t>Si el texto no cabe, resumir: letra mínima 6 pt. Si hay menos de 4 focos, eliminar la fila sobrante (clic derecho › Eliminar fila). La fila 5 SI PRO no se elimina.</a:t>
+              <a:t>Máximo 5 focos, sin contar la fila SI PRO. Si hay menos, eliminar las filas sobrantes (clic derecho › Eliminar fila); la fila SI PRO no se elimina. Letra mínima 6 pt: si no cabe, resumir.</a:t>
             </a:r>
             <a:endParaRPr lang="en-US" sz="930" dirty="0"/>
           </a:p>

</xml_diff>

<commit_message>
Assurance ITO v1.3: volver a 4 focos + SI PRO; niveles según eventos (plantilla sin N1/N2 predefinidos)
Co-Authored-By: Claude Opus 5.5 <noreply@anthropic.com>
Claude-Session: https://claude.ai/code/session_017MaLNPnWzNhW9Tdfmjv67V
</commit_message>
<xml_diff>
--- a/FORMATO_ASSURANCE_ITO_v1.3.pptx
+++ b/FORMATO_ASSURANCE_ITO_v1.3.pptx
@@ -1883,7 +1883,7 @@
         </p:nvGraphicFramePr>
         <p:xfrm>
           <a:off x="365760" y="1645920"/>
-          <a:ext cx="11457432" cy="3858768"/>
+          <a:ext cx="11457432" cy="3673856"/>
         </p:xfrm>
         <a:graphic>
           <a:graphicData uri="http://schemas.openxmlformats.org/drawingml/2006/table">
@@ -2273,7 +2273,7 @@
                   </a:ext>
                 </a:extLst>
               </a:tr>
-              <a:tr h="566928">
+              <a:tr h="640080">
                 <a:tc>
                   <a:txBody>
                     <a:bodyPr/>
@@ -2283,9 +2283,9 @@
                         <a:buNone/>
                       </a:pPr>
                       <a:r>
-                        <a:rPr lang="en-US" sz="1300" b="1" dirty="0">
+                        <a:rPr lang="en-US" sz="1400" b="1" dirty="0">
                           <a:solidFill>
-                            <a:srgbClr val="FFFFFF"/>
+                            <a:srgbClr val="1F3D6B"/>
                           </a:solidFill>
                           <a:latin typeface="Arial" pitchFamily="34" charset="0"/>
                           <a:ea typeface="Arial" pitchFamily="34" charset="-122"/>
@@ -2304,15 +2304,15 @@
                         <a:buNone/>
                       </a:pPr>
                       <a:r>
-                        <a:rPr lang="en-US" sz="750" b="1" dirty="0">
+                        <a:rPr lang="en-US" sz="800" b="1" dirty="0" i="1">
                           <a:solidFill>
-                            <a:srgbClr val="FFFFFF"/>
+                            <a:srgbClr val="5A6573"/>
                           </a:solidFill>
                           <a:latin typeface="Arial" pitchFamily="34" charset="0"/>
                           <a:ea typeface="Arial" pitchFamily="34" charset="-122"/>
                           <a:cs typeface="Arial" pitchFamily="34" charset="-120"/>
                         </a:rPr>
-                        <a:t>N1 · CRITICIDAD ALTA</a:t>
+                        <a:t>[N1 o N2]</a:t>
                       </a:r>
                       <a:endParaRPr lang="en-US" sz="800" dirty="0">
                         <a:latin typeface="Arial" charset="0"/>
@@ -2359,7 +2359,7 @@
                       <a:tailEnd type="none" w="med" len="med"/>
                     </a:lnB>
                     <a:solidFill>
-                      <a:srgbClr val="C62828"/>
+                      <a:srgbClr val="E4E8EE"/>
                     </a:solidFill>
                   </a:tcPr>
                 </a:tc>
@@ -2406,7 +2406,7 @@
                       <a:r>
                         <a:rPr lang="en-US" sz="630" b="1" dirty="0">
                           <a:solidFill>
-                            <a:srgbClr val="C62828"/>
+                            <a:srgbClr val="1F3D6B"/>
                           </a:solidFill>
                           <a:latin typeface="Arial" pitchFamily="34" charset="0"/>
                           <a:ea typeface="Arial" pitchFamily="34" charset="-122"/>
@@ -2727,7 +2727,7 @@
                   </a:ext>
                 </a:extLst>
               </a:tr>
-              <a:tr h="566928">
+              <a:tr h="640080">
                 <a:tc>
                   <a:txBody>
                     <a:bodyPr/>
@@ -2737,9 +2737,9 @@
                         <a:buNone/>
                       </a:pPr>
                       <a:r>
-                        <a:rPr lang="en-US" sz="1300" b="1" dirty="0">
+                        <a:rPr lang="en-US" sz="1400" b="1" dirty="0">
                           <a:solidFill>
-                            <a:srgbClr val="FFFFFF"/>
+                            <a:srgbClr val="1F3D6B"/>
                           </a:solidFill>
                           <a:latin typeface="Arial" pitchFamily="34" charset="0"/>
                           <a:ea typeface="Arial" charset="0"/>
@@ -2758,15 +2758,15 @@
                         <a:buNone/>
                       </a:pPr>
                       <a:r>
-                        <a:rPr lang="en-US" sz="750" b="1" dirty="0">
+                        <a:rPr lang="en-US" sz="800" b="1" dirty="0" i="1">
                           <a:solidFill>
-                            <a:srgbClr val="FFFFFF"/>
+                            <a:srgbClr val="5A6573"/>
                           </a:solidFill>
                           <a:latin typeface="Arial" pitchFamily="34" charset="0"/>
                           <a:ea typeface="Arial" pitchFamily="34" charset="-122"/>
                           <a:cs typeface="Arial" pitchFamily="34" charset="-120"/>
                         </a:rPr>
-                        <a:t>N1 · CRITICIDAD ALTA</a:t>
+                        <a:t>[N1 o N2]</a:t>
                       </a:r>
                       <a:endParaRPr lang="en-US" sz="800" dirty="0">
                         <a:latin typeface="Arial" charset="0"/>
@@ -2823,7 +2823,7 @@
                       <a:tailEnd type="none" w="med" len="med"/>
                     </a:lnB>
                     <a:solidFill>
-                      <a:srgbClr val="C62828"/>
+                      <a:srgbClr val="E4E8EE"/>
                     </a:solidFill>
                   </a:tcPr>
                 </a:tc>
@@ -2870,7 +2870,7 @@
                       <a:r>
                         <a:rPr lang="en-US" sz="630" b="1" dirty="0">
                           <a:solidFill>
-                            <a:srgbClr val="C62828"/>
+                            <a:srgbClr val="1F3D6B"/>
                           </a:solidFill>
                           <a:latin typeface="Arial" pitchFamily="34" charset="0"/>
                           <a:ea typeface="Arial" pitchFamily="34" charset="-122"/>
@@ -3191,7 +3191,7 @@
                   </a:ext>
                 </a:extLst>
               </a:tr>
-              <a:tr h="566928">
+              <a:tr h="640080">
                 <a:tc>
                   <a:txBody>
                     <a:bodyPr/>
@@ -3201,9 +3201,9 @@
                         <a:buNone/>
                       </a:pPr>
                       <a:r>
-                        <a:rPr lang="en-US" sz="1300" b="1" dirty="0">
+                        <a:rPr lang="en-US" sz="1400" b="1" dirty="0">
                           <a:solidFill>
-                            <a:srgbClr val="FFFFFF"/>
+                            <a:srgbClr val="1F3D6B"/>
                           </a:solidFill>
                           <a:latin typeface="Arial" pitchFamily="34" charset="0"/>
                           <a:ea typeface="Arial" charset="0"/>
@@ -3222,15 +3222,15 @@
                         <a:buNone/>
                       </a:pPr>
                       <a:r>
-                        <a:rPr lang="en-US" sz="750" b="1" dirty="0">
+                        <a:rPr lang="en-US" sz="800" b="1" dirty="0" i="1">
                           <a:solidFill>
-                            <a:srgbClr val="FFFFFF"/>
+                            <a:srgbClr val="5A6573"/>
                           </a:solidFill>
                           <a:latin typeface="Arial" pitchFamily="34" charset="0"/>
                           <a:ea typeface="Arial" pitchFamily="34" charset="-122"/>
                           <a:cs typeface="Arial" pitchFamily="34" charset="-120"/>
                         </a:rPr>
-                        <a:t>N1 · CRITICIDAD ALTA</a:t>
+                        <a:t>[N1 o N2]</a:t>
                       </a:r>
                       <a:endParaRPr lang="en-US" sz="800" dirty="0">
                         <a:latin typeface="Arial" charset="0"/>
@@ -3287,7 +3287,7 @@
                       <a:tailEnd type="none" w="med" len="med"/>
                     </a:lnB>
                     <a:solidFill>
-                      <a:srgbClr val="C62828"/>
+                      <a:srgbClr val="E4E8EE"/>
                     </a:solidFill>
                   </a:tcPr>
                 </a:tc>
@@ -3334,7 +3334,7 @@
                       <a:r>
                         <a:rPr lang="en-US" sz="630" b="1" dirty="0">
                           <a:solidFill>
-                            <a:srgbClr val="C62828"/>
+                            <a:srgbClr val="1F3D6B"/>
                           </a:solidFill>
                           <a:latin typeface="Arial" pitchFamily="34" charset="0"/>
                           <a:ea typeface="Arial" pitchFamily="34" charset="-122"/>
@@ -3655,7 +3655,7 @@
                   </a:ext>
                 </a:extLst>
               </a:tr>
-              <a:tr h="566928">
+              <a:tr h="640080">
                 <a:tc>
                   <a:txBody>
                     <a:bodyPr/>
@@ -3665,9 +3665,9 @@
                         <a:buNone/>
                       </a:pPr>
                       <a:r>
-                        <a:rPr lang="en-US" sz="1300" b="1" dirty="0">
+                        <a:rPr lang="en-US" sz="1400" b="1" dirty="0">
                           <a:solidFill>
-                            <a:srgbClr val="FFFFFF"/>
+                            <a:srgbClr val="1F3D6B"/>
                           </a:solidFill>
                           <a:latin typeface="Arial" pitchFamily="34" charset="0"/>
                           <a:ea typeface="Arial" charset="0"/>
@@ -3686,15 +3686,15 @@
                         <a:buNone/>
                       </a:pPr>
                       <a:r>
-                        <a:rPr lang="en-US" sz="750" b="1" dirty="0">
+                        <a:rPr lang="en-US" sz="800" b="1" dirty="0" i="1">
                           <a:solidFill>
-                            <a:srgbClr val="FFFFFF"/>
+                            <a:srgbClr val="5A6573"/>
                           </a:solidFill>
                           <a:latin typeface="Arial" pitchFamily="34" charset="0"/>
                           <a:ea typeface="Arial" pitchFamily="34" charset="-122"/>
                           <a:cs typeface="Arial" pitchFamily="34" charset="-120"/>
                         </a:rPr>
-                        <a:t>N2 · CRITICIDAD INTERMEDIA</a:t>
+                        <a:t>[N1 o N2]</a:t>
                       </a:r>
                       <a:endParaRPr lang="en-US" sz="800" dirty="0">
                         <a:latin typeface="Arial" charset="0"/>
@@ -3741,7 +3741,7 @@
                       <a:tailEnd type="none" w="med" len="med"/>
                     </a:lnB>
                     <a:solidFill>
-                      <a:srgbClr val="E67E22"/>
+                      <a:srgbClr val="E4E8EE"/>
                     </a:solidFill>
                   </a:tcPr>
                 </a:tc>
@@ -3788,7 +3788,7 @@
                       <a:r>
                         <a:rPr lang="en-US" sz="630" b="1" dirty="0">
                           <a:solidFill>
-                            <a:srgbClr val="B35C00"/>
+                            <a:srgbClr val="1F3D6B"/>
                           </a:solidFill>
                           <a:latin typeface="Arial" pitchFamily="34" charset="0"/>
                           <a:ea typeface="Arial" pitchFamily="34" charset="-122"/>
@@ -4109,7 +4109,7 @@
                   </a:ext>
                 </a:extLst>
               </a:tr>
-              <a:tr h="566928">
+              <a:tr h="640080">
                 <a:tc>
                   <a:txBody>
                     <a:bodyPr/>
@@ -4119,7 +4119,7 @@
                         <a:buNone/>
                       </a:pPr>
                       <a:r>
-                        <a:rPr lang="en-US" sz="1300" b="1" dirty="0">
+                        <a:rPr lang="en-US" sz="1400" b="1" dirty="0">
                           <a:solidFill>
                             <a:srgbClr val="FFFFFF"/>
                           </a:solidFill>
@@ -4140,461 +4140,7 @@
                         <a:buNone/>
                       </a:pPr>
                       <a:r>
-                        <a:rPr lang="en-US" sz="750" b="1" dirty="0">
-                          <a:solidFill>
-                            <a:srgbClr val="FFFFFF"/>
-                          </a:solidFill>
-                          <a:latin typeface="Arial" pitchFamily="34" charset="0"/>
-                          <a:ea typeface="Arial" pitchFamily="34" charset="-122"/>
-                          <a:cs typeface="Arial" pitchFamily="34" charset="-120"/>
-                        </a:rPr>
-                        <a:t>N2 · CRITICIDAD INTERMEDIA</a:t>
-                      </a:r>
-                      <a:endParaRPr lang="en-US" sz="800" dirty="0">
-                        <a:latin typeface="Arial" charset="0"/>
-                        <a:ea typeface="Arial" charset="0"/>
-                        <a:cs typeface="Arial" charset="0"/>
-                      </a:endParaRPr>
-                    </a:p>
-                  </a:txBody>
-                  <a:tcPr marL="50800" marR="50800" marT="25400" marB="25400" anchor="ctr">
-                    <a:lnL w="9525" cap="flat" cmpd="sng" algn="ctr">
-                      <a:solidFill>
-                        <a:srgbClr val="C9D3E0"/>
-                      </a:solidFill>
-                      <a:prstDash val="solid"/>
-                      <a:round/>
-                      <a:headEnd type="none" w="med" len="med"/>
-                      <a:tailEnd type="none" w="med" len="med"/>
-                    </a:lnL>
-                    <a:lnR w="9525" cap="flat" cmpd="sng" algn="ctr">
-                      <a:solidFill>
-                        <a:srgbClr val="C9D3E0"/>
-                      </a:solidFill>
-                      <a:prstDash val="solid"/>
-                      <a:round/>
-                      <a:headEnd type="none" w="med" len="med"/>
-                      <a:tailEnd type="none" w="med" len="med"/>
-                    </a:lnR>
-                    <a:lnT w="9525" cap="flat" cmpd="sng" algn="ctr">
-                      <a:solidFill>
-                        <a:srgbClr val="C9D3E0"/>
-                      </a:solidFill>
-                      <a:prstDash val="solid"/>
-                      <a:round/>
-                      <a:headEnd type="none" w="med" len="med"/>
-                      <a:tailEnd type="none" w="med" len="med"/>
-                    </a:lnT>
-                    <a:lnB w="9525" cap="flat" cmpd="sng" algn="ctr">
-                      <a:solidFill>
-                        <a:srgbClr val="C9D3E0"/>
-                      </a:solidFill>
-                      <a:prstDash val="solid"/>
-                      <a:round/>
-                      <a:headEnd type="none" w="med" len="med"/>
-                      <a:tailEnd type="none" w="med" len="med"/>
-                    </a:lnB>
-                    <a:solidFill>
-                      <a:srgbClr val="E67E22"/>
-                    </a:solidFill>
-                  </a:tcPr>
-                </a:tc>
-                <a:tc>
-                  <a:txBody>
-                    <a:bodyPr/>
-                    <a:lstStyle/>
-                    <a:p>
-                      <a:pPr marL="0" indent="0">
-                        <a:buNone/>
-                      </a:pPr>
-                      <a:r>
-                        <a:rPr lang="en-US" sz="630" b="1" i="1" dirty="0">
-                          <a:solidFill>
-                            <a:srgbClr val="7A8594"/>
-                          </a:solidFill>
-                          <a:latin typeface="Arial" pitchFamily="34" charset="0"/>
-                          <a:ea typeface="Arial" pitchFamily="34" charset="-122"/>
-                          <a:cs typeface="Arial" pitchFamily="34" charset="-120"/>
-                        </a:rPr>
-                        <a:t>[Tema del foco]. </a:t>
-                      </a:r>
-                      <a:r>
-                        <a:rPr lang="en-US" sz="630" i="1" dirty="0">
-                          <a:solidFill>
-                            <a:srgbClr val="7A8594"/>
-                          </a:solidFill>
-                          <a:latin typeface="Arial" pitchFamily="34" charset="0"/>
-                          <a:ea typeface="Arial" pitchFamily="34" charset="-122"/>
-                          <a:cs typeface="Arial" pitchFamily="34" charset="-120"/>
-                        </a:rPr>
-                        <a:t>[Verificar… qué se revisa, dónde y bajo qué estándar. Máx. 3 líneas]</a:t>
-                      </a:r>
-                      <a:endParaRPr lang="en-US" sz="630" dirty="0">
-                        <a:latin typeface="Arial" charset="0"/>
-                        <a:ea typeface="Arial" charset="0"/>
-                        <a:cs typeface="Arial" charset="0"/>
-                      </a:endParaRPr>
-                    </a:p>
-                    <a:p>
-                      <a:pPr marL="0" indent="0">
-                        <a:buNone/>
-                      </a:pPr>
-                      <a:r>
-                        <a:rPr lang="en-US" sz="630" b="1" dirty="0">
-                          <a:solidFill>
-                            <a:srgbClr val="B35C00"/>
-                          </a:solidFill>
-                          <a:latin typeface="Arial" pitchFamily="34" charset="0"/>
-                          <a:ea typeface="Arial" pitchFamily="34" charset="-122"/>
-                          <a:cs typeface="Arial" pitchFamily="34" charset="-120"/>
-                        </a:rPr>
-                        <a:t>Criterio de restricción: </a:t>
-                      </a:r>
-                      <a:r>
-                        <a:rPr lang="en-US" sz="630" i="1" dirty="0">
-                          <a:solidFill>
-                            <a:srgbClr val="7A8594"/>
-                          </a:solidFill>
-                          <a:latin typeface="Arial" pitchFamily="34" charset="0"/>
-                          <a:ea typeface="Arial" pitchFamily="34" charset="-122"/>
-                          <a:cs typeface="Arial" pitchFamily="34" charset="-120"/>
-                        </a:rPr>
-                        <a:t>[Cuándo se prohíbe o se detiene la tarea. Máx. 2 líneas]</a:t>
-                      </a:r>
-                      <a:endParaRPr lang="en-US" sz="630" dirty="0">
-                        <a:latin typeface="Arial" charset="0"/>
-                        <a:ea typeface="Arial" charset="0"/>
-                        <a:cs typeface="Arial" charset="0"/>
-                      </a:endParaRPr>
-                    </a:p>
-                  </a:txBody>
-                  <a:tcPr marL="50800" marR="50800" marT="25400" marB="25400" anchor="ctr">
-                    <a:lnL w="9525" cap="flat" cmpd="sng" algn="ctr">
-                      <a:solidFill>
-                        <a:srgbClr val="C9D3E0"/>
-                      </a:solidFill>
-                      <a:prstDash val="solid"/>
-                      <a:round/>
-                      <a:headEnd type="none" w="med" len="med"/>
-                      <a:tailEnd type="none" w="med" len="med"/>
-                    </a:lnL>
-                    <a:lnR w="9525" cap="flat" cmpd="sng" algn="ctr">
-                      <a:solidFill>
-                        <a:srgbClr val="C9D3E0"/>
-                      </a:solidFill>
-                      <a:prstDash val="solid"/>
-                      <a:round/>
-                      <a:headEnd type="none" w="med" len="med"/>
-                      <a:tailEnd type="none" w="med" len="med"/>
-                    </a:lnR>
-                    <a:lnT w="9525" cap="flat" cmpd="sng" algn="ctr">
-                      <a:solidFill>
-                        <a:srgbClr val="C9D3E0"/>
-                      </a:solidFill>
-                      <a:prstDash val="solid"/>
-                      <a:round/>
-                      <a:headEnd type="none" w="med" len="med"/>
-                      <a:tailEnd type="none" w="med" len="med"/>
-                    </a:lnT>
-                    <a:lnB w="9525" cap="flat" cmpd="sng" algn="ctr">
-                      <a:solidFill>
-                        <a:srgbClr val="C9D3E0"/>
-                      </a:solidFill>
-                      <a:prstDash val="solid"/>
-                      <a:round/>
-                      <a:headEnd type="none" w="med" len="med"/>
-                      <a:tailEnd type="none" w="med" len="med"/>
-                    </a:lnB>
-                    <a:solidFill>
-                      <a:srgbClr val="FFFFFF"/>
-                    </a:solidFill>
-                  </a:tcPr>
-                </a:tc>
-                <a:tc>
-                  <a:txBody>
-                    <a:bodyPr/>
-                    <a:lstStyle/>
-                    <a:p>
-                      <a:pPr marL="0" indent="0">
-                        <a:buNone/>
-                      </a:pPr>
-                      <a:r>
-                        <a:rPr lang="en-US" sz="620" b="1" dirty="0">
-                          <a:solidFill>
-                            <a:srgbClr val="222222"/>
-                          </a:solidFill>
-                          <a:latin typeface="Arial" pitchFamily="34" charset="0"/>
-                          <a:ea typeface="Arial" pitchFamily="34" charset="-122"/>
-                          <a:cs typeface="Arial" pitchFamily="34" charset="-120"/>
-                        </a:rPr>
-                        <a:t>TIPO ID [N°] – EECC:</a:t>
-                      </a:r>
-                      <a:r>
-                        <a:rPr lang="en-US" sz="620" i="1" dirty="0">
-                          <a:solidFill>
-                            <a:srgbClr val="7A8594"/>
-                          </a:solidFill>
-                          <a:latin typeface="Arial" pitchFamily="34" charset="0"/>
-                          <a:ea typeface="Arial" pitchFamily="34" charset="-122"/>
-                          <a:cs typeface="Arial" pitchFamily="34" charset="-120"/>
-                        </a:rPr>
-                        <a:t> [qué ocurrió, 1 línea]</a:t>
-                      </a:r>
-                      <a:endParaRPr lang="en-US" sz="620" dirty="0">
-                        <a:latin typeface="Arial" charset="0"/>
-                        <a:ea typeface="Arial" charset="0"/>
-                        <a:cs typeface="Arial" charset="0"/>
-                      </a:endParaRPr>
-                    </a:p>
-                    <a:p>
-                      <a:pPr marL="0" indent="0">
-                        <a:buNone/>
-                      </a:pPr>
-                      <a:r>
-                        <a:rPr lang="en-US" sz="620" b="1" dirty="0">
-                          <a:solidFill>
-                            <a:srgbClr val="222222"/>
-                          </a:solidFill>
-                          <a:latin typeface="Arial" pitchFamily="34" charset="0"/>
-                          <a:ea typeface="Arial" pitchFamily="34" charset="-122"/>
-                          <a:cs typeface="Arial" pitchFamily="34" charset="-120"/>
-                        </a:rPr>
-                        <a:t>TIPO ID [N°] – EECC:</a:t>
-                      </a:r>
-                      <a:r>
-                        <a:rPr lang="en-US" sz="620" i="1" dirty="0">
-                          <a:solidFill>
-                            <a:srgbClr val="7A8594"/>
-                          </a:solidFill>
-                          <a:latin typeface="Arial" pitchFamily="34" charset="0"/>
-                          <a:ea typeface="Arial" pitchFamily="34" charset="-122"/>
-                          <a:cs typeface="Arial" pitchFamily="34" charset="-120"/>
-                        </a:rPr>
-                        <a:t> [qué ocurrió, 1 línea]</a:t>
-                      </a:r>
-                      <a:endParaRPr lang="en-US" sz="620" dirty="0">
-                        <a:latin typeface="Arial" charset="0"/>
-                        <a:ea typeface="Arial" charset="0"/>
-                        <a:cs typeface="Arial" charset="0"/>
-                      </a:endParaRPr>
-                    </a:p>
-                  </a:txBody>
-                  <a:tcPr marL="50800" marR="50800" marT="25400" marB="25400" anchor="ctr">
-                    <a:lnL w="9525" cap="flat" cmpd="sng" algn="ctr">
-                      <a:solidFill>
-                        <a:srgbClr val="C9D3E0"/>
-                      </a:solidFill>
-                      <a:prstDash val="solid"/>
-                      <a:round/>
-                      <a:headEnd type="none" w="med" len="med"/>
-                      <a:tailEnd type="none" w="med" len="med"/>
-                    </a:lnL>
-                    <a:lnR w="9525" cap="flat" cmpd="sng" algn="ctr">
-                      <a:solidFill>
-                        <a:srgbClr val="C9D3E0"/>
-                      </a:solidFill>
-                      <a:prstDash val="solid"/>
-                      <a:round/>
-                      <a:headEnd type="none" w="med" len="med"/>
-                      <a:tailEnd type="none" w="med" len="med"/>
-                    </a:lnR>
-                    <a:lnT w="9525" cap="flat" cmpd="sng" algn="ctr">
-                      <a:solidFill>
-                        <a:srgbClr val="C9D3E0"/>
-                      </a:solidFill>
-                      <a:prstDash val="solid"/>
-                      <a:round/>
-                      <a:headEnd type="none" w="med" len="med"/>
-                      <a:tailEnd type="none" w="med" len="med"/>
-                    </a:lnT>
-                    <a:lnB w="9525" cap="flat" cmpd="sng" algn="ctr">
-                      <a:solidFill>
-                        <a:srgbClr val="C9D3E0"/>
-                      </a:solidFill>
-                      <a:prstDash val="solid"/>
-                      <a:round/>
-                      <a:headEnd type="none" w="med" len="med"/>
-                      <a:tailEnd type="none" w="med" len="med"/>
-                    </a:lnB>
-                    <a:solidFill>
-                      <a:srgbClr val="FFFFFF"/>
-                    </a:solidFill>
-                  </a:tcPr>
-                </a:tc>
-                <a:tc>
-                  <a:txBody>
-                    <a:bodyPr/>
-                    <a:lstStyle/>
-                    <a:p>
-                      <a:pPr marL="0" indent="0">
-                        <a:buNone/>
-                      </a:pPr>
-                      <a:r>
-                        <a:rPr lang="en-US" sz="630" i="1" dirty="0">
-                          <a:solidFill>
-                            <a:srgbClr val="7A8594"/>
-                          </a:solidFill>
-                          <a:latin typeface="Arial" pitchFamily="34" charset="0"/>
-                          <a:ea typeface="Arial" pitchFamily="34" charset="-122"/>
-                          <a:cs typeface="Arial" pitchFamily="34" charset="-120"/>
-                        </a:rPr>
-                        <a:t>[Herramienta + herramienta + ASP]</a:t>
-                      </a:r>
-                      <a:endParaRPr lang="en-US" sz="630" dirty="0">
-                        <a:latin typeface="Arial" charset="0"/>
-                        <a:ea typeface="Arial" charset="0"/>
-                        <a:cs typeface="Arial" charset="0"/>
-                      </a:endParaRPr>
-                    </a:p>
-                  </a:txBody>
-                  <a:tcPr marL="50800" marR="50800" marT="25400" marB="25400" anchor="ctr">
-                    <a:lnL w="9525" cap="flat" cmpd="sng" algn="ctr">
-                      <a:solidFill>
-                        <a:srgbClr val="C9D3E0"/>
-                      </a:solidFill>
-                      <a:prstDash val="solid"/>
-                      <a:round/>
-                      <a:headEnd type="none" w="med" len="med"/>
-                      <a:tailEnd type="none" w="med" len="med"/>
-                    </a:lnL>
-                    <a:lnR w="9525" cap="flat" cmpd="sng" algn="ctr">
-                      <a:solidFill>
-                        <a:srgbClr val="C9D3E0"/>
-                      </a:solidFill>
-                      <a:prstDash val="solid"/>
-                      <a:round/>
-                      <a:headEnd type="none" w="med" len="med"/>
-                      <a:tailEnd type="none" w="med" len="med"/>
-                    </a:lnR>
-                    <a:lnT w="9525" cap="flat" cmpd="sng" algn="ctr">
-                      <a:solidFill>
-                        <a:srgbClr val="C9D3E0"/>
-                      </a:solidFill>
-                      <a:prstDash val="solid"/>
-                      <a:round/>
-                      <a:headEnd type="none" w="med" len="med"/>
-                      <a:tailEnd type="none" w="med" len="med"/>
-                    </a:lnT>
-                    <a:lnB w="9525" cap="flat" cmpd="sng" algn="ctr">
-                      <a:solidFill>
-                        <a:srgbClr val="C9D3E0"/>
-                      </a:solidFill>
-                      <a:prstDash val="solid"/>
-                      <a:round/>
-                      <a:headEnd type="none" w="med" len="med"/>
-                      <a:tailEnd type="none" w="med" len="med"/>
-                    </a:lnB>
-                    <a:solidFill>
-                      <a:srgbClr val="FFFFFF"/>
-                    </a:solidFill>
-                  </a:tcPr>
-                </a:tc>
-                <a:tc>
-                  <a:txBody>
-                    <a:bodyPr/>
-                    <a:lstStyle/>
-                    <a:p>
-                      <a:pPr marL="0" indent="0">
-                        <a:buNone/>
-                      </a:pPr>
-                      <a:r>
-                        <a:rPr lang="en-US" sz="630" i="1" dirty="0">
-                          <a:solidFill>
-                            <a:srgbClr val="7A8594"/>
-                          </a:solidFill>
-                          <a:latin typeface="Arial" pitchFamily="34" charset="0"/>
-                          <a:ea typeface="Arial" pitchFamily="34" charset="-122"/>
-                          <a:cs typeface="Arial" pitchFamily="34" charset="-120"/>
-                        </a:rPr>
-                        <a:t>[Registro verificable] / registro fotográfico</a:t>
-                      </a:r>
-                      <a:endParaRPr lang="en-US" sz="630" dirty="0">
-                        <a:latin typeface="Arial" charset="0"/>
-                        <a:ea typeface="Arial" charset="0"/>
-                        <a:cs typeface="Arial" charset="0"/>
-                      </a:endParaRPr>
-                    </a:p>
-                  </a:txBody>
-                  <a:tcPr marL="50800" marR="50800" marT="25400" marB="25400" anchor="ctr">
-                    <a:lnL w="9525" cap="flat" cmpd="sng" algn="ctr">
-                      <a:solidFill>
-                        <a:srgbClr val="C9D3E0"/>
-                      </a:solidFill>
-                      <a:prstDash val="solid"/>
-                      <a:round/>
-                      <a:headEnd type="none" w="med" len="med"/>
-                      <a:tailEnd type="none" w="med" len="med"/>
-                    </a:lnL>
-                    <a:lnR w="9525" cap="flat" cmpd="sng" algn="ctr">
-                      <a:solidFill>
-                        <a:srgbClr val="C9D3E0"/>
-                      </a:solidFill>
-                      <a:prstDash val="solid"/>
-                      <a:round/>
-                      <a:headEnd type="none" w="med" len="med"/>
-                      <a:tailEnd type="none" w="med" len="med"/>
-                    </a:lnR>
-                    <a:lnT w="9525" cap="flat" cmpd="sng" algn="ctr">
-                      <a:solidFill>
-                        <a:srgbClr val="C9D3E0"/>
-                      </a:solidFill>
-                      <a:prstDash val="solid"/>
-                      <a:round/>
-                      <a:headEnd type="none" w="med" len="med"/>
-                      <a:tailEnd type="none" w="med" len="med"/>
-                    </a:lnT>
-                    <a:lnB w="9525" cap="flat" cmpd="sng" algn="ctr">
-                      <a:solidFill>
-                        <a:srgbClr val="C9D3E0"/>
-                      </a:solidFill>
-                      <a:prstDash val="solid"/>
-                      <a:round/>
-                      <a:headEnd type="none" w="med" len="med"/>
-                      <a:tailEnd type="none" w="med" len="med"/>
-                    </a:lnB>
-                    <a:solidFill>
-                      <a:srgbClr val="FFFFFF"/>
-                    </a:solidFill>
-                  </a:tcPr>
-                </a:tc>
-                <a:extLst>
-                  <a:ext uri="{0D108BD9-81ED-4DB2-BD59-A6C34878D82A}">
-                    <a16:rowId xmlns:a16="http://schemas.microsoft.com/office/drawing/2014/main" val="10005"/>
-                  </a:ext>
-                </a:extLst>
-              </a:tr>
-              <a:tr h="713232">
-                <a:tc>
-                  <a:txBody>
-                    <a:bodyPr/>
-                    <a:lstStyle/>
-                    <a:p>
-                      <a:pPr marL="0" indent="0" algn="ctr">
-                        <a:buNone/>
-                      </a:pPr>
-                      <a:r>
-                        <a:rPr lang="en-US" sz="1400" b="1" dirty="0">
-                          <a:solidFill>
-                            <a:srgbClr val="FFFFFF"/>
-                          </a:solidFill>
-                          <a:latin typeface="Arial" pitchFamily="34" charset="0"/>
-                          <a:ea typeface="Arial" charset="0"/>
-                          <a:cs typeface="Arial" pitchFamily="34" charset="-120"/>
-                        </a:rPr>
-                        <a:t>6</a:t>
-                      </a:r>
-                      <a:endParaRPr lang="en-US" sz="800" dirty="0">
-                        <a:latin typeface="Arial" charset="0"/>
-                        <a:ea typeface="Arial" charset="0"/>
-                        <a:cs typeface="Arial" charset="0"/>
-                      </a:endParaRPr>
-                    </a:p>
-                    <a:p>
-                      <a:pPr marL="0" indent="0" algn="ctr">
-                        <a:buNone/>
-                      </a:pPr>
-                      <a:r>
-                        <a:rPr lang="en-US" sz="750" b="1" dirty="0">
+                        <a:rPr lang="en-US" sz="800" b="1" dirty="0">
                           <a:solidFill>
                             <a:srgbClr val="FFFFFF"/>
                           </a:solidFill>
@@ -5371,7 +4917,7 @@
         </p:nvSpPr>
         <p:spPr>
           <a:xfrm>
-            <a:off x="365760" y="5943600"/>
+            <a:off x="365760" y="5852160"/>
             <a:ext cx="960120" cy="292608"/>
           </a:xfrm>
           <a:prstGeom prst="rect">
@@ -5412,7 +4958,7 @@
         </p:nvSpPr>
         <p:spPr>
           <a:xfrm>
-            <a:off x="1325880" y="5943600"/>
+            <a:off x="1325880" y="5852160"/>
             <a:ext cx="10497312" cy="292608"/>
           </a:xfrm>
           <a:prstGeom prst="rect">
@@ -5444,7 +4990,7 @@
         </p:nvSpPr>
         <p:spPr>
           <a:xfrm>
-            <a:off x="1417320" y="5943600"/>
+            <a:off x="1417320" y="5852160"/>
             <a:ext cx="10314432" cy="292608"/>
           </a:xfrm>
           <a:prstGeom prst="rect">
@@ -5516,7 +5062,7 @@
         </p:nvSpPr>
         <p:spPr>
           <a:xfrm>
-            <a:off x="365760" y="6327648"/>
+            <a:off x="365760" y="6236208"/>
             <a:ext cx="6172200" cy="219456"/>
           </a:xfrm>
           <a:prstGeom prst="rect">
@@ -5548,7 +5094,7 @@
         </p:nvSpPr>
         <p:spPr>
           <a:xfrm>
-            <a:off x="457200" y="6327648"/>
+            <a:off x="457200" y="6236208"/>
             <a:ext cx="5989320" cy="219456"/>
           </a:xfrm>
           <a:prstGeom prst="rect">
@@ -5595,7 +5141,7 @@
         </p:blipFill>
         <p:spPr>
           <a:xfrm>
-            <a:off x="438912" y="6620256"/>
+            <a:off x="438912" y="6528816"/>
             <a:ext cx="219456" cy="219456"/>
           </a:xfrm>
           <a:prstGeom prst="rect">
@@ -5611,7 +5157,7 @@
         </p:nvSpPr>
         <p:spPr>
           <a:xfrm>
-            <a:off x="694944" y="6601968"/>
+            <a:off x="694944" y="6510528"/>
             <a:ext cx="1673352" cy="256032"/>
           </a:xfrm>
           <a:prstGeom prst="rect">
@@ -5650,7 +5196,7 @@
         </p:nvSpPr>
         <p:spPr>
           <a:xfrm>
-            <a:off x="438912" y="6876288"/>
+            <a:off x="438912" y="6784848"/>
             <a:ext cx="1911096" cy="274320"/>
           </a:xfrm>
           <a:prstGeom prst="rect">
@@ -5689,7 +5235,7 @@
         </p:nvSpPr>
         <p:spPr>
           <a:xfrm>
-            <a:off x="438912" y="7168896"/>
+            <a:off x="438912" y="7077456"/>
             <a:ext cx="1911096" cy="786384"/>
           </a:xfrm>
           <a:prstGeom prst="rect">
@@ -5771,7 +5317,7 @@
         </p:nvSpPr>
         <p:spPr>
           <a:xfrm>
-            <a:off x="2423160" y="6647688"/>
+            <a:off x="2423160" y="6556248"/>
             <a:ext cx="9144" cy="1280160"/>
           </a:xfrm>
           <a:prstGeom prst="rect">
@@ -5811,7 +5357,7 @@
         </p:blipFill>
         <p:spPr>
           <a:xfrm>
-            <a:off x="2496312" y="6620256"/>
+            <a:off x="2496312" y="6528816"/>
             <a:ext cx="219456" cy="219456"/>
           </a:xfrm>
           <a:prstGeom prst="rect">
@@ -5827,7 +5373,7 @@
         </p:nvSpPr>
         <p:spPr>
           <a:xfrm>
-            <a:off x="2752344" y="6601968"/>
+            <a:off x="2752344" y="6510528"/>
             <a:ext cx="1673352" cy="256032"/>
           </a:xfrm>
           <a:prstGeom prst="rect">
@@ -5866,7 +5412,7 @@
         </p:nvSpPr>
         <p:spPr>
           <a:xfrm>
-            <a:off x="2496312" y="6876288"/>
+            <a:off x="2496312" y="6784848"/>
             <a:ext cx="1911096" cy="274320"/>
           </a:xfrm>
           <a:prstGeom prst="rect">
@@ -5905,7 +5451,7 @@
         </p:nvSpPr>
         <p:spPr>
           <a:xfrm>
-            <a:off x="2496312" y="7168896"/>
+            <a:off x="2496312" y="7077456"/>
             <a:ext cx="1911096" cy="786384"/>
           </a:xfrm>
           <a:prstGeom prst="rect">
@@ -5987,7 +5533,7 @@
         </p:nvSpPr>
         <p:spPr>
           <a:xfrm>
-            <a:off x="4480560" y="6647688"/>
+            <a:off x="4480560" y="6556248"/>
             <a:ext cx="9144" cy="1280160"/>
           </a:xfrm>
           <a:prstGeom prst="rect">
@@ -6027,7 +5573,7 @@
         </p:blipFill>
         <p:spPr>
           <a:xfrm>
-            <a:off x="4553712" y="6620256"/>
+            <a:off x="4553712" y="6528816"/>
             <a:ext cx="219456" cy="219456"/>
           </a:xfrm>
           <a:prstGeom prst="rect">
@@ -6043,7 +5589,7 @@
         </p:nvSpPr>
         <p:spPr>
           <a:xfrm>
-            <a:off x="4809744" y="6601968"/>
+            <a:off x="4809744" y="6510528"/>
             <a:ext cx="1673352" cy="256032"/>
           </a:xfrm>
           <a:prstGeom prst="rect">
@@ -6082,7 +5628,7 @@
         </p:nvSpPr>
         <p:spPr>
           <a:xfrm>
-            <a:off x="4553712" y="6876288"/>
+            <a:off x="4553712" y="6784848"/>
             <a:ext cx="1911096" cy="274320"/>
           </a:xfrm>
           <a:prstGeom prst="rect">
@@ -6121,7 +5667,7 @@
         </p:nvSpPr>
         <p:spPr>
           <a:xfrm>
-            <a:off x="4553712" y="7168896"/>
+            <a:off x="4553712" y="7077456"/>
             <a:ext cx="1911096" cy="786384"/>
           </a:xfrm>
           <a:prstGeom prst="rect">
@@ -6203,7 +5749,7 @@
         </p:nvSpPr>
         <p:spPr>
           <a:xfrm>
-            <a:off x="6680200" y="6327648"/>
+            <a:off x="6680200" y="6236208"/>
             <a:ext cx="2527300" cy="1645920"/>
           </a:xfrm>
           <a:prstGeom prst="roundRect">
@@ -6237,7 +5783,7 @@
         </p:nvSpPr>
         <p:spPr>
           <a:xfrm>
-            <a:off x="6715760" y="6340019"/>
+            <a:off x="6715760" y="6248579"/>
             <a:ext cx="2387600" cy="310896"/>
           </a:xfrm>
           <a:prstGeom prst="rect">
@@ -6276,7 +5822,7 @@
         </p:nvSpPr>
         <p:spPr>
           <a:xfrm>
-            <a:off x="6743700" y="6711696"/>
+            <a:off x="6743700" y="6620256"/>
             <a:ext cx="2400300" cy="1207008"/>
           </a:xfrm>
           <a:prstGeom prst="rect">
@@ -6403,7 +5949,7 @@
         </p:nvSpPr>
         <p:spPr>
           <a:xfrm>
-            <a:off x="9296400" y="6327648"/>
+            <a:off x="9296400" y="6236208"/>
             <a:ext cx="2527300" cy="1645920"/>
           </a:xfrm>
           <a:prstGeom prst="roundRect">
@@ -6437,7 +5983,7 @@
         </p:nvSpPr>
         <p:spPr>
           <a:xfrm>
-            <a:off x="9372600" y="6364224"/>
+            <a:off x="9372600" y="6272784"/>
             <a:ext cx="2387600" cy="310896"/>
           </a:xfrm>
           <a:prstGeom prst="rect">
@@ -6476,7 +6022,7 @@
         </p:nvSpPr>
         <p:spPr>
           <a:xfrm>
-            <a:off x="9372600" y="6711696"/>
+            <a:off x="9372600" y="6620256"/>
             <a:ext cx="2400300" cy="1207008"/>
           </a:xfrm>
           <a:prstGeom prst="rect">
@@ -7230,7 +6776,7 @@
                 <a:ea typeface="Arial" pitchFamily="34" charset="-122"/>
                 <a:cs typeface="Arial" pitchFamily="34" charset="-120"/>
               </a:rPr>
-              <a:t>3. SELECCIÓN DE FOCOS (filas 1 a 5)</a:t>
+              <a:t>3. SELECCIÓN DE FOCOS (filas 1 a 4)</a:t>
             </a:r>
             <a:endParaRPr lang="en-US" sz="600" dirty="0"/>
           </a:p>
@@ -7332,24 +6878,24 @@
                 <a:ea typeface="Arial" pitchFamily="34" charset="-122"/>
                 <a:cs typeface="Arial" pitchFamily="34" charset="-120"/>
               </a:rPr>
-              <a:t>- FOCO DE SOLO HBP: solo si hay 3 o más HBP del período relacionados con la misma brecha y que no estén ya en otro foco. Con 1 o 2 HBP de un tema NUNCA se arma un foco (van como evidencia complementaria o en Recurrente). Estos focos son siempre N2, van después de todos los focos con eventos N1/N2 y solo entran si queda una fila libre (máx. 5 focos). Si hay varios temas HBP que califican, entra primero el de más HBP y, si empatan, el asociado a control crítico o emergencia. OJO: la gerencia al 08-09 puso un foco con solo 2 HBP (extintores); según esta regla ese foco NO va.</a:t>
-            </a:r>
-            <a:endParaRPr lang="en-US" sz="600" dirty="0"/>
-          </a:p>
-          <a:p>
-            <a:pPr marL="0" indent="0">
-              <a:buNone/>
-            </a:pPr>
-            <a:r>
-              <a:rPr lang="en-US" sz="600" dirty="0">
-                <a:solidFill>
-                  <a:srgbClr val="222222"/>
-                </a:solidFill>
-                <a:latin typeface="Arial" pitchFamily="34" charset="0"/>
-                <a:ea typeface="Arial" pitchFamily="34" charset="-122"/>
-                <a:cs typeface="Arial" pitchFamily="34" charset="-120"/>
-              </a:rPr>
-              <a:t>- Máximo 5 focos, SIN contar la fila fija "FOCO – SI PRO – ESTRATEGIA DE CONTROLES" (es decir, hasta 5 focos + la fila SI PRO). Si hay más, se quedan los de mayor PRIORIDAD (punto 4) y se informa al usuario cuáles quedaron fuera. Si hay menos, elimina las filas sobrantes (nunca la fila SI PRO).</a:t>
+              <a:t>- FOCO DE SOLO HBP: solo si hay 3 o más HBP del período relacionados con la misma brecha y que no estén ya en otro foco. Con 1 o 2 HBP de un tema NUNCA se arma un foco (van como evidencia complementaria o en Recurrente). Estos focos son siempre N2, van después de todos los focos con eventos N1/N2 y solo entran si queda una fila libre (máx. 4 focos). Si hay varios temas HBP que califican, entra primero el de más HBP y, si empatan, el asociado a control crítico o emergencia. OJO: la gerencia al 08-09 puso un foco con solo 2 HBP (extintores); según esta regla ese foco NO va.</a:t>
+            </a:r>
+            <a:endParaRPr lang="en-US" sz="600" dirty="0"/>
+          </a:p>
+          <a:p>
+            <a:pPr marL="0" indent="0">
+              <a:buNone/>
+            </a:pPr>
+            <a:r>
+              <a:rPr lang="en-US" sz="600" dirty="0">
+                <a:solidFill>
+                  <a:srgbClr val="222222"/>
+                </a:solidFill>
+                <a:latin typeface="Arial" pitchFamily="34" charset="0"/>
+                <a:ea typeface="Arial" pitchFamily="34" charset="-122"/>
+                <a:cs typeface="Arial" pitchFamily="34" charset="-120"/>
+              </a:rPr>
+              <a:t>- Máximo 4 focos + la fila fija "FOCO – SI PRO – ESTRATEGIA DE CONTROLES" (5 filas en total). Si hay más, se quedan los de mayor PRIORIDAD (punto 4) y se informa al usuario cuáles quedaron fuera. Si hay menos, elimina las filas sobrantes (nunca la fila SI PRO).</a:t>
             </a:r>
             <a:endParaRPr lang="en-US" sz="600" dirty="0"/>
           </a:p>
@@ -7978,7 +7524,41 @@
                 <a:ea typeface="Arial" pitchFamily="34" charset="-122"/>
                 <a:cs typeface="Arial" pitchFamily="34" charset="-120"/>
               </a:rPr>
-              <a:t>- Texto de la celda: número de prioridad + "N1 · CRITICIDAD ALTA" o "N2 · CRITICIDAD INTERMEDIA". Ajusta texto y color de cada fila al nivel real (la plantilla trae 3 filas N1 y 2 N2 solo como referencia).</a:t>
+              <a:t>- LA PLANTILLA NO PREDEFINE NIVELES: las 4 filas de focos vienen en gris neutro. El nivel y el color de cada fila salen SOLO de los eventos de su foco. La cantidad de N1 y N2 es la que resulte de los datos, sin importar cuántas filas haya (p. ej.: 4 N1 y 0 N2; 3 N1 y 1 N2; 1 N1 y 3 N2; 0 N1 y 2 N2).</a:t>
+            </a:r>
+            <a:endParaRPr lang="en-US" sz="600" dirty="0"/>
+          </a:p>
+          <a:p>
+            <a:pPr marL="0" indent="0">
+              <a:buNone/>
+            </a:pPr>
+            <a:r>
+              <a:rPr lang="en-US" sz="600" dirty="0">
+                <a:solidFill>
+                  <a:srgbClr val="222222"/>
+                </a:solidFill>
+                <a:latin typeface="Arial" pitchFamily="34" charset="0"/>
+                <a:ea typeface="Arial" pitchFamily="34" charset="-122"/>
+                <a:cs typeface="Arial" pitchFamily="34" charset="-120"/>
+              </a:rPr>
+              <a:t>- Nunca bajes un foco a N2 ni subas uno a N1 para llenar filas o "equilibrar" la lámina. Si hay más de 4 focos, entran los 4 de mayor prioridad (todo N1 antes que N2): si existen 5 focos N1, las 4 filas serán N1 y se informa al usuario el N1 que quedó fuera.</a:t>
+            </a:r>
+            <a:endParaRPr lang="en-US" sz="600" dirty="0"/>
+          </a:p>
+          <a:p>
+            <a:pPr marL="0" indent="0">
+              <a:buNone/>
+            </a:pPr>
+            <a:r>
+              <a:rPr lang="en-US" sz="600" dirty="0">
+                <a:solidFill>
+                  <a:srgbClr val="222222"/>
+                </a:solidFill>
+                <a:latin typeface="Arial" pitchFamily="34" charset="0"/>
+                <a:ea typeface="Arial" pitchFamily="34" charset="-122"/>
+                <a:cs typeface="Arial" pitchFamily="34" charset="-120"/>
+              </a:rPr>
+              <a:t>- Celda de nivel: número de prioridad + "N1 · CRITICIDAD ALTA" (relleno rojo C62828, texto blanco) o "N2 · CRITICIDAD INTERMEDIA" (relleno naranja E67E22, texto blanco). Reemplaza el gris y el texto guía de la plantilla.</a:t>
             </a:r>
             <a:endParaRPr lang="en-US" sz="600" dirty="0"/>
           </a:p>
@@ -8012,7 +7592,7 @@
                 <a:ea typeface="Arial" pitchFamily="34" charset="-122"/>
                 <a:cs typeface="Arial" pitchFamily="34" charset="-120"/>
               </a:rPr>
-              <a:t>5. FILA SI PRO – FOCO SI PRO · ESTRATEGIA DE CONTROLES (última fila, N° 6, fija, gris; no cuenta dentro de los 5 focos)</a:t>
+              <a:t>5. FILA SI PRO – FOCO SI PRO · ESTRATEGIA DE CONTROLES (última fila, N° 5, fija, gris; no cuenta dentro de los 4 focos)</a:t>
             </a:r>
             <a:endParaRPr lang="en-US" sz="600" dirty="0"/>
           </a:p>
@@ -8811,7 +8391,7 @@
                 <a:ea typeface="Arial" pitchFamily="34" charset="-122"/>
                 <a:cs typeface="Arial" pitchFamily="34" charset="-120"/>
               </a:rPr>
-              <a:t>- Si no puedes: entrega el contenido en texto, ordenado por sección y por fila de la plantilla (Encabezado; Indicadores 14 días; Focos 1 a 5 con sus 5 columnas; Fila SI PRO; Recurrente; Bloques AM/Mediodía/PM; Tendencias no asociadas; Tendencias asociadas a controles críticos), listo para copiar y pegar en cada casilla.</a:t>
+              <a:t>- Si no puedes: entrega el contenido en texto, ordenado por sección y por fila de la plantilla (Encabezado; Indicadores 14 días; Focos 1 a 4 con sus 5 columnas; Fila SI PRO; Recurrente; Bloques AM/Mediodía/PM; Tendencias no asociadas; Tendencias asociadas a controles críticos), listo para copiar y pegar en cada casilla.</a:t>
             </a:r>
             <a:endParaRPr lang="en-US" sz="600" dirty="0"/>
           </a:p>
@@ -8947,7 +8527,7 @@
                 <a:ea typeface="Arial" pitchFamily="34" charset="-122"/>
                 <a:cs typeface="Arial" pitchFamily="34" charset="-120"/>
               </a:rPr>
-              <a:t>Antes de entregar, confirma que: el título dice "ASSURANCE TURNO 1-3" o "ASSURANCE TURNO 2-4" (sin corchetes); cada ID existe en el Excel; el nivel de cada foco sigue el punto 4 (2 o más eventos N1/N2 = N1; los HBP nunca suben un foco a N1); las áreas son nombres exactos de AREA_GEO; revisaste los eventos abiertos a la fecha de cierre; leíste la descripción de todos los eventos y aplicaste la revaloración del punto 4; cada foco nace de al menos un evento N1/N2, salvo los focos de solo HBP, que tienen 3 o más HBP del mismo tema; todos los focos N1 van antes que los N2; dentro de cada nivel, los focos con reiteración/evidencia van antes que los aislados y se ordenan como indica el punto 4; ningún tema se llama "Otro"; los eventos con riesgo "Otro" fueron asignados a un tema leyendo su descripción; cada foco contiene al menos un dato concreto de sus eventos; el NIVEL (color) y la PRIORIDAD (orden) de cada foco siguen el punto 4; ningún HBP definió un nivel; los conteos de indicadores y Recurrente cuadran; y no quedan textos guía.</a:t>
+              <a:t>Antes de entregar, confirma que: el título dice "ASSURANCE TURNO 1-3" o "ASSURANCE TURNO 2-4" (sin corchetes); cada ID existe en el Excel; el nivel de cada foco sigue el punto 4 (2 o más eventos N1/N2 = N1; los HBP nunca suben un foco a N1); la cantidad de N1 y N2 salió de los eventos y no de la plantilla; ninguna celda de nivel quedó en gris; las áreas son nombres exactos de AREA_GEO; revisaste los eventos abiertos a la fecha de cierre; leíste la descripción de todos los eventos y aplicaste la revaloración del punto 4; cada foco nace de al menos un evento N1/N2, salvo los focos de solo HBP, que tienen 3 o más HBP del mismo tema; todos los focos N1 van antes que los N2; dentro de cada nivel, los focos con reiteración/evidencia van antes que los aislados y se ordenan como indica el punto 4; ningún tema se llama "Otro"; los eventos con riesgo "Otro" fueron asignados a un tema leyendo su descripción; cada foco contiene al menos un dato concreto de sus eventos; el NIVEL (color) y la PRIORIDAD (orden) de cada foco siguen el punto 4; ningún HBP definió un nivel; los conteos de indicadores y Recurrente cuadran; y no quedan textos guía.</a:t>
             </a:r>
             <a:endParaRPr lang="en-US" sz="600" dirty="0"/>
           </a:p>
@@ -10991,7 +10571,7 @@
                 <a:ea typeface="Arial" pitchFamily="34" charset="-122"/>
                 <a:cs typeface="Arial" pitchFamily="34" charset="-120"/>
               </a:rPr>
-              <a:t>Foco = brecha específica con eventos N1/N2; HBP del mismo tema = evidencia. 3+ HBP del mismo tema = foco N2 si queda fila. Orden: todo N1 → todo N2. En N1: reiterados, luego más grave. En N2: con evento N1/N2, luego más eventos. Máx. 5 focos, sin contar SI PRO.</a:t>
+              <a:t>Foco = brecha específica con eventos N1/N2; HBP del mismo tema = evidencia. 3+ HBP del mismo tema = foco N2 si queda fila. Orden: todo N1 → todo N2. En N1: reiterados, luego más grave. En N2: con evento N1/N2, luego más eventos. Máx. 4 focos + fila SI PRO (5 filas).</a:t>
             </a:r>
             <a:endParaRPr lang="en-US" sz="930" dirty="0"/>
           </a:p>
@@ -11174,7 +10754,7 @@
                 <a:ea typeface="Arial" pitchFamily="34" charset="-122"/>
                 <a:cs typeface="Arial" pitchFamily="34" charset="-120"/>
               </a:rPr>
-              <a:t>Define el color. Leer la descripción: un HBP o CBP puede subir de criticidad. N1 · alta (roja): ACC, CAAP, CA, o 2 o más HAP/CBP del mismo tema. N2 · intermedia (naranja): un solo HAP o CBP (+ HBP), o foco de 3+ HBP. Ej.: 2+ HAP, 2+ CBP o HAP + CBP = N1; HAP + HBP = N2. Un CAAP siempre es N1. Los HBP nunca suben a N1.</a:t>
+              <a:t>La plantilla no trae niveles: cada fila toma el color de su foco según sus eventos. N1 · alta (roja): ACC, CAAP, CA, o 2 o más HAP/CBP del mismo tema. N2 · intermedia (naranja): un solo HAP o CBP (+ HBP), o foco de 3+ HBP. Ej.: 2+ HAP, 2+ CBP o HAP + CBP = N1; HAP + HBP = N2. Un CAAP siempre es N1. Los HBP nunca suben a N1.</a:t>
             </a:r>
             <a:endParaRPr lang="en-US" sz="930" dirty="0"/>
           </a:p>
@@ -12903,7 +12483,7 @@
                 <a:ea typeface="Arial" pitchFamily="34" charset="-122"/>
                 <a:cs typeface="Arial" pitchFamily="34" charset="-120"/>
               </a:rPr>
-              <a:t>Máximo 5 focos, sin contar la fila SI PRO. Si hay menos, eliminar las filas sobrantes (clic derecho › Eliminar fila); la fila SI PRO no se elimina. Letra mínima 6 pt: si no cabe, resumir.</a:t>
+              <a:t>Si el texto no cabe, resumir: letra mínima 6 pt. Si hay menos de 4 focos, eliminar la fila sobrante (clic derecho › Eliminar fila). La fila 5 SI PRO no se elimina.</a:t>
             </a:r>
             <a:endParaRPr lang="en-US" sz="930" dirty="0"/>
           </a:p>

</xml_diff>

<commit_message>
Assurance ITO v1.3: filas de ejemplo 2 N1 + 2 N2; la IA define la cantidad real según los eventos
Co-Authored-By: Claude Opus 5.5 <noreply@anthropic.com>
Claude-Session: https://claude.ai/code/session_017MaLNPnWzNhW9Tdfmjv67V
</commit_message>
<xml_diff>
--- a/FORMATO_ASSURANCE_ITO_v1.3.pptx
+++ b/FORMATO_ASSURANCE_ITO_v1.3.pptx
@@ -2285,7 +2285,7 @@
                       <a:r>
                         <a:rPr lang="en-US" sz="1400" b="1" dirty="0">
                           <a:solidFill>
-                            <a:srgbClr val="1F3D6B"/>
+                            <a:srgbClr val="FFFFFF"/>
                           </a:solidFill>
                           <a:latin typeface="Arial" pitchFamily="34" charset="0"/>
                           <a:ea typeface="Arial" pitchFamily="34" charset="-122"/>
@@ -2304,15 +2304,15 @@
                         <a:buNone/>
                       </a:pPr>
                       <a:r>
-                        <a:rPr lang="en-US" sz="800" b="1" dirty="0" i="1">
+                        <a:rPr lang="en-US" sz="800" b="1" dirty="0" i="0">
                           <a:solidFill>
-                            <a:srgbClr val="5A6573"/>
+                            <a:srgbClr val="FFFFFF"/>
                           </a:solidFill>
                           <a:latin typeface="Arial" pitchFamily="34" charset="0"/>
                           <a:ea typeface="Arial" pitchFamily="34" charset="-122"/>
                           <a:cs typeface="Arial" pitchFamily="34" charset="-120"/>
                         </a:rPr>
-                        <a:t>[N1 o N2]</a:t>
+                        <a:t>N1 · CRITICIDAD ALTA</a:t>
                       </a:r>
                       <a:endParaRPr lang="en-US" sz="800" dirty="0">
                         <a:latin typeface="Arial" charset="0"/>
@@ -2359,7 +2359,7 @@
                       <a:tailEnd type="none" w="med" len="med"/>
                     </a:lnB>
                     <a:solidFill>
-                      <a:srgbClr val="E4E8EE"/>
+                      <a:srgbClr val="C62828"/>
                     </a:solidFill>
                   </a:tcPr>
                 </a:tc>
@@ -2406,7 +2406,7 @@
                       <a:r>
                         <a:rPr lang="en-US" sz="630" b="1" dirty="0">
                           <a:solidFill>
-                            <a:srgbClr val="1F3D6B"/>
+                            <a:srgbClr val="C62828"/>
                           </a:solidFill>
                           <a:latin typeface="Arial" pitchFamily="34" charset="0"/>
                           <a:ea typeface="Arial" pitchFamily="34" charset="-122"/>
@@ -2739,7 +2739,7 @@
                       <a:r>
                         <a:rPr lang="en-US" sz="1400" b="1" dirty="0">
                           <a:solidFill>
-                            <a:srgbClr val="1F3D6B"/>
+                            <a:srgbClr val="FFFFFF"/>
                           </a:solidFill>
                           <a:latin typeface="Arial" pitchFamily="34" charset="0"/>
                           <a:ea typeface="Arial" charset="0"/>
@@ -2758,15 +2758,15 @@
                         <a:buNone/>
                       </a:pPr>
                       <a:r>
-                        <a:rPr lang="en-US" sz="800" b="1" dirty="0" i="1">
+                        <a:rPr lang="en-US" sz="800" b="1" dirty="0" i="0">
                           <a:solidFill>
-                            <a:srgbClr val="5A6573"/>
+                            <a:srgbClr val="FFFFFF"/>
                           </a:solidFill>
                           <a:latin typeface="Arial" pitchFamily="34" charset="0"/>
                           <a:ea typeface="Arial" pitchFamily="34" charset="-122"/>
                           <a:cs typeface="Arial" pitchFamily="34" charset="-120"/>
                         </a:rPr>
-                        <a:t>[N1 o N2]</a:t>
+                        <a:t>N1 · CRITICIDAD ALTA</a:t>
                       </a:r>
                       <a:endParaRPr lang="en-US" sz="800" dirty="0">
                         <a:latin typeface="Arial" charset="0"/>
@@ -2823,7 +2823,7 @@
                       <a:tailEnd type="none" w="med" len="med"/>
                     </a:lnB>
                     <a:solidFill>
-                      <a:srgbClr val="E4E8EE"/>
+                      <a:srgbClr val="C62828"/>
                     </a:solidFill>
                   </a:tcPr>
                 </a:tc>
@@ -2870,7 +2870,7 @@
                       <a:r>
                         <a:rPr lang="en-US" sz="630" b="1" dirty="0">
                           <a:solidFill>
-                            <a:srgbClr val="1F3D6B"/>
+                            <a:srgbClr val="C62828"/>
                           </a:solidFill>
                           <a:latin typeface="Arial" pitchFamily="34" charset="0"/>
                           <a:ea typeface="Arial" pitchFamily="34" charset="-122"/>
@@ -3203,7 +3203,7 @@
                       <a:r>
                         <a:rPr lang="en-US" sz="1400" b="1" dirty="0">
                           <a:solidFill>
-                            <a:srgbClr val="1F3D6B"/>
+                            <a:srgbClr val="FFFFFF"/>
                           </a:solidFill>
                           <a:latin typeface="Arial" pitchFamily="34" charset="0"/>
                           <a:ea typeface="Arial" charset="0"/>
@@ -3222,15 +3222,15 @@
                         <a:buNone/>
                       </a:pPr>
                       <a:r>
-                        <a:rPr lang="en-US" sz="800" b="1" dirty="0" i="1">
+                        <a:rPr lang="en-US" sz="800" b="1" dirty="0" i="0">
                           <a:solidFill>
-                            <a:srgbClr val="5A6573"/>
+                            <a:srgbClr val="FFFFFF"/>
                           </a:solidFill>
                           <a:latin typeface="Arial" pitchFamily="34" charset="0"/>
                           <a:ea typeface="Arial" pitchFamily="34" charset="-122"/>
                           <a:cs typeface="Arial" pitchFamily="34" charset="-120"/>
                         </a:rPr>
-                        <a:t>[N1 o N2]</a:t>
+                        <a:t>N2 · CRITICIDAD INTERMEDIA</a:t>
                       </a:r>
                       <a:endParaRPr lang="en-US" sz="800" dirty="0">
                         <a:latin typeface="Arial" charset="0"/>
@@ -3287,7 +3287,7 @@
                       <a:tailEnd type="none" w="med" len="med"/>
                     </a:lnB>
                     <a:solidFill>
-                      <a:srgbClr val="E4E8EE"/>
+                      <a:srgbClr val="E67E22"/>
                     </a:solidFill>
                   </a:tcPr>
                 </a:tc>
@@ -3334,7 +3334,7 @@
                       <a:r>
                         <a:rPr lang="en-US" sz="630" b="1" dirty="0">
                           <a:solidFill>
-                            <a:srgbClr val="1F3D6B"/>
+                            <a:srgbClr val="B35C00"/>
                           </a:solidFill>
                           <a:latin typeface="Arial" pitchFamily="34" charset="0"/>
                           <a:ea typeface="Arial" pitchFamily="34" charset="-122"/>
@@ -3667,7 +3667,7 @@
                       <a:r>
                         <a:rPr lang="en-US" sz="1400" b="1" dirty="0">
                           <a:solidFill>
-                            <a:srgbClr val="1F3D6B"/>
+                            <a:srgbClr val="FFFFFF"/>
                           </a:solidFill>
                           <a:latin typeface="Arial" pitchFamily="34" charset="0"/>
                           <a:ea typeface="Arial" charset="0"/>
@@ -3686,15 +3686,15 @@
                         <a:buNone/>
                       </a:pPr>
                       <a:r>
-                        <a:rPr lang="en-US" sz="800" b="1" dirty="0" i="1">
+                        <a:rPr lang="en-US" sz="800" b="1" dirty="0" i="0">
                           <a:solidFill>
-                            <a:srgbClr val="5A6573"/>
+                            <a:srgbClr val="FFFFFF"/>
                           </a:solidFill>
                           <a:latin typeface="Arial" pitchFamily="34" charset="0"/>
                           <a:ea typeface="Arial" pitchFamily="34" charset="-122"/>
                           <a:cs typeface="Arial" pitchFamily="34" charset="-120"/>
                         </a:rPr>
-                        <a:t>[N1 o N2]</a:t>
+                        <a:t>N2 · CRITICIDAD INTERMEDIA</a:t>
                       </a:r>
                       <a:endParaRPr lang="en-US" sz="800" dirty="0">
                         <a:latin typeface="Arial" charset="0"/>
@@ -3741,7 +3741,7 @@
                       <a:tailEnd type="none" w="med" len="med"/>
                     </a:lnB>
                     <a:solidFill>
-                      <a:srgbClr val="E4E8EE"/>
+                      <a:srgbClr val="E67E22"/>
                     </a:solidFill>
                   </a:tcPr>
                 </a:tc>
@@ -3788,7 +3788,7 @@
                       <a:r>
                         <a:rPr lang="en-US" sz="630" b="1" dirty="0">
                           <a:solidFill>
-                            <a:srgbClr val="1F3D6B"/>
+                            <a:srgbClr val="B35C00"/>
                           </a:solidFill>
                           <a:latin typeface="Arial" pitchFamily="34" charset="0"/>
                           <a:ea typeface="Arial" pitchFamily="34" charset="-122"/>
@@ -7524,7 +7524,7 @@
                 <a:ea typeface="Arial" pitchFamily="34" charset="-122"/>
                 <a:cs typeface="Arial" pitchFamily="34" charset="-120"/>
               </a:rPr>
-              <a:t>- LA PLANTILLA NO PREDEFINE NIVELES: las 4 filas de focos vienen en gris neutro. El nivel y el color de cada fila salen SOLO de los eventos de su foco. La cantidad de N1 y N2 es la que resulte de los datos, sin importar cuántas filas haya (p. ej.: 4 N1 y 0 N2; 3 N1 y 1 N2; 1 N1 y 3 N2; 0 N1 y 2 N2).</a:t>
+              <a:t>- NO TE DEJES LLEVAR POR LA ESTRUCTURA DE LA PLANTILLA: las filas 1 y 2 vienen en rojo (N1) y las filas 3 y 4 en naranja (N2) SOLO como ejemplo visual de los colores. NO es una cantidad a respetar ni un cupo por nivel. Tú determinas cuántos N1 y cuántos N2 hay, y el nivel y el color de cada fila salen SOLO de los eventos de su foco. La cantidad de N1 y N2 es la que resulte de los datos, sin importar cuántas filas haya (p. ej.: 4 N1 y 0 N2; 3 N1 y 1 N2; 1 N1 y 3 N2; 0 N1 y 2 N2).</a:t>
             </a:r>
             <a:endParaRPr lang="en-US" sz="600" dirty="0"/>
           </a:p>
@@ -7558,7 +7558,7 @@
                 <a:ea typeface="Arial" pitchFamily="34" charset="-122"/>
                 <a:cs typeface="Arial" pitchFamily="34" charset="-120"/>
               </a:rPr>
-              <a:t>- Celda de nivel: número de prioridad + "N1 · CRITICIDAD ALTA" (relleno rojo C62828, texto blanco) o "N2 · CRITICIDAD INTERMEDIA" (relleno naranja E67E22, texto blanco). Reemplaza el gris y el texto guía de la plantilla.</a:t>
+              <a:t>- Celda de nivel: número de prioridad + "N1 · CRITICIDAD ALTA" (relleno rojo C62828, texto blanco) o "N2 · CRITICIDAD INTERMEDIA" (relleno naranja E67E22, texto blanco). Cambia el texto y el color de cada celda según corresponda, aunque eso modifique la distribución de ejemplo (2 N1 + 2 N2).</a:t>
             </a:r>
             <a:endParaRPr lang="en-US" sz="600" dirty="0"/>
           </a:p>
@@ -8527,7 +8527,7 @@
                 <a:ea typeface="Arial" pitchFamily="34" charset="-122"/>
                 <a:cs typeface="Arial" pitchFamily="34" charset="-120"/>
               </a:rPr>
-              <a:t>Antes de entregar, confirma que: el título dice "ASSURANCE TURNO 1-3" o "ASSURANCE TURNO 2-4" (sin corchetes); cada ID existe en el Excel; el nivel de cada foco sigue el punto 4 (2 o más eventos N1/N2 = N1; los HBP nunca suben un foco a N1); la cantidad de N1 y N2 salió de los eventos y no de la plantilla; ninguna celda de nivel quedó en gris; las áreas son nombres exactos de AREA_GEO; revisaste los eventos abiertos a la fecha de cierre; leíste la descripción de todos los eventos y aplicaste la revaloración del punto 4; cada foco nace de al menos un evento N1/N2, salvo los focos de solo HBP, que tienen 3 o más HBP del mismo tema; todos los focos N1 van antes que los N2; dentro de cada nivel, los focos con reiteración/evidencia van antes que los aislados y se ordenan como indica el punto 4; ningún tema se llama "Otro"; los eventos con riesgo "Otro" fueron asignados a un tema leyendo su descripción; cada foco contiene al menos un dato concreto de sus eventos; el NIVEL (color) y la PRIORIDAD (orden) de cada foco siguen el punto 4; ningún HBP definió un nivel; los conteos de indicadores y Recurrente cuadran; y no quedan textos guía.</a:t>
+              <a:t>Antes de entregar, confirma que: el título dice "ASSURANCE TURNO 1-3" o "ASSURANCE TURNO 2-4" (sin corchetes); cada ID existe en el Excel; el nivel de cada foco sigue el punto 4 (2 o más eventos N1/N2 = N1; los HBP nunca suben un foco a N1); la cantidad de N1 y N2 salió de los eventos y no de la distribución de ejemplo de la plantilla (2 N1 + 2 N2); las áreas son nombres exactos de AREA_GEO; revisaste los eventos abiertos a la fecha de cierre; leíste la descripción de todos los eventos y aplicaste la revaloración del punto 4; cada foco nace de al menos un evento N1/N2, salvo los focos de solo HBP, que tienen 3 o más HBP del mismo tema; todos los focos N1 van antes que los N2; dentro de cada nivel, los focos con reiteración/evidencia van antes que los aislados y se ordenan como indica el punto 4; ningún tema se llama "Otro"; los eventos con riesgo "Otro" fueron asignados a un tema leyendo su descripción; cada foco contiene al menos un dato concreto de sus eventos; el NIVEL (color) y la PRIORIDAD (orden) de cada foco siguen el punto 4; ningún HBP definió un nivel; los conteos de indicadores y Recurrente cuadran; y no quedan textos guía.</a:t>
             </a:r>
             <a:endParaRPr lang="en-US" sz="600" dirty="0"/>
           </a:p>
@@ -10754,7 +10754,7 @@
                 <a:ea typeface="Arial" pitchFamily="34" charset="-122"/>
                 <a:cs typeface="Arial" pitchFamily="34" charset="-120"/>
               </a:rPr>
-              <a:t>La plantilla no trae niveles: cada fila toma el color de su foco según sus eventos. N1 · alta (roja): ACC, CAAP, CA, o 2 o más HAP/CBP del mismo tema. N2 · intermedia (naranja): un solo HAP o CBP (+ HBP), o foco de 3+ HBP. Ej.: 2+ HAP, 2+ CBP o HAP + CBP = N1; HAP + HBP = N2. Un CAAP siempre es N1. Los HBP nunca suben a N1.</a:t>
+              <a:t>Las 2 filas N1 y 2 N2 son solo ejemplo: la cantidad la definen los eventos. N1 (roja): ACC, CAAP, CA o 2+ HAP/CBP del mismo tema. N2 (naranja): 1 HAP o CBP (+ HBP) o 3+ HBP. Un CAAP siempre es N1; los HBP nunca suben a N1.</a:t>
             </a:r>
             <a:endParaRPr lang="en-US" sz="930" dirty="0"/>
           </a:p>

</xml_diff>

<commit_message>
Assurance ITO v1.3: máximo 5 focos sin contar SI PRO (plantilla, instrucciones, prompt y correo)
Co-Authored-By: Claude Opus 5.5 <noreply@anthropic.com>
Claude-Session: https://claude.ai/code/session_017MaLNPnWzNhW9Tdfmjv67V
</commit_message>
<xml_diff>
--- a/FORMATO_ASSURANCE_ITO_v1.3.pptx
+++ b/FORMATO_ASSURANCE_ITO_v1.3.pptx
@@ -1883,7 +1883,7 @@
         </p:nvGraphicFramePr>
         <p:xfrm>
           <a:off x="365760" y="1645920"/>
-          <a:ext cx="11457432" cy="3673856"/>
+          <a:ext cx="11457432" cy="3858768"/>
         </p:xfrm>
         <a:graphic>
           <a:graphicData uri="http://schemas.openxmlformats.org/drawingml/2006/table">
@@ -2273,7 +2273,7 @@
                   </a:ext>
                 </a:extLst>
               </a:tr>
-              <a:tr h="640080">
+              <a:tr h="566928">
                 <a:tc>
                   <a:txBody>
                     <a:bodyPr/>
@@ -2283,7 +2283,7 @@
                         <a:buNone/>
                       </a:pPr>
                       <a:r>
-                        <a:rPr lang="en-US" sz="1400" b="1" dirty="0">
+                        <a:rPr lang="en-US" sz="1300" b="1" dirty="0">
                           <a:solidFill>
                             <a:srgbClr val="FFFFFF"/>
                           </a:solidFill>
@@ -2304,7 +2304,7 @@
                         <a:buNone/>
                       </a:pPr>
                       <a:r>
-                        <a:rPr lang="en-US" sz="800" b="1" dirty="0" i="0">
+                        <a:rPr lang="en-US" sz="750" b="1" dirty="0" i="0">
                           <a:solidFill>
                             <a:srgbClr val="FFFFFF"/>
                           </a:solidFill>
@@ -2727,7 +2727,7 @@
                   </a:ext>
                 </a:extLst>
               </a:tr>
-              <a:tr h="640080">
+              <a:tr h="566928">
                 <a:tc>
                   <a:txBody>
                     <a:bodyPr/>
@@ -2737,7 +2737,7 @@
                         <a:buNone/>
                       </a:pPr>
                       <a:r>
-                        <a:rPr lang="en-US" sz="1400" b="1" dirty="0">
+                        <a:rPr lang="en-US" sz="1300" b="1" dirty="0">
                           <a:solidFill>
                             <a:srgbClr val="FFFFFF"/>
                           </a:solidFill>
@@ -2758,7 +2758,7 @@
                         <a:buNone/>
                       </a:pPr>
                       <a:r>
-                        <a:rPr lang="en-US" sz="800" b="1" dirty="0" i="0">
+                        <a:rPr lang="en-US" sz="750" b="1" dirty="0" i="0">
                           <a:solidFill>
                             <a:srgbClr val="FFFFFF"/>
                           </a:solidFill>
@@ -3191,7 +3191,7 @@
                   </a:ext>
                 </a:extLst>
               </a:tr>
-              <a:tr h="640080">
+              <a:tr h="566928">
                 <a:tc>
                   <a:txBody>
                     <a:bodyPr/>
@@ -3201,7 +3201,7 @@
                         <a:buNone/>
                       </a:pPr>
                       <a:r>
-                        <a:rPr lang="en-US" sz="1400" b="1" dirty="0">
+                        <a:rPr lang="en-US" sz="1300" b="1" dirty="0">
                           <a:solidFill>
                             <a:srgbClr val="FFFFFF"/>
                           </a:solidFill>
@@ -3222,7 +3222,7 @@
                         <a:buNone/>
                       </a:pPr>
                       <a:r>
-                        <a:rPr lang="en-US" sz="800" b="1" dirty="0" i="0">
+                        <a:rPr lang="en-US" sz="750" b="1" dirty="0" i="0">
                           <a:solidFill>
                             <a:srgbClr val="FFFFFF"/>
                           </a:solidFill>
@@ -3655,7 +3655,7 @@
                   </a:ext>
                 </a:extLst>
               </a:tr>
-              <a:tr h="640080">
+              <a:tr h="566928">
                 <a:tc>
                   <a:txBody>
                     <a:bodyPr/>
@@ -3665,7 +3665,7 @@
                         <a:buNone/>
                       </a:pPr>
                       <a:r>
-                        <a:rPr lang="en-US" sz="1400" b="1" dirty="0">
+                        <a:rPr lang="en-US" sz="1300" b="1" dirty="0">
                           <a:solidFill>
                             <a:srgbClr val="FFFFFF"/>
                           </a:solidFill>
@@ -3686,7 +3686,7 @@
                         <a:buNone/>
                       </a:pPr>
                       <a:r>
-                        <a:rPr lang="en-US" sz="800" b="1" dirty="0" i="0">
+                        <a:rPr lang="en-US" sz="750" b="1" dirty="0" i="0">
                           <a:solidFill>
                             <a:srgbClr val="FFFFFF"/>
                           </a:solidFill>
@@ -4109,7 +4109,461 @@
                   </a:ext>
                 </a:extLst>
               </a:tr>
-              <a:tr h="640080">
+              <a:tr h="566928">
+                <a:tc>
+                  <a:txBody>
+                    <a:bodyPr/>
+                    <a:lstStyle/>
+                    <a:p>
+                      <a:pPr marL="0" indent="0" algn="ctr">
+                        <a:buNone/>
+                      </a:pPr>
+                      <a:r>
+                        <a:rPr lang="en-US" sz="1300" b="1" dirty="0">
+                          <a:solidFill>
+                            <a:srgbClr val="FFFFFF"/>
+                          </a:solidFill>
+                          <a:latin typeface="Arial" pitchFamily="34" charset="0"/>
+                          <a:ea typeface="Arial" charset="0"/>
+                          <a:cs typeface="Arial" pitchFamily="34" charset="-120"/>
+                        </a:rPr>
+                        <a:t>5</a:t>
+                      </a:r>
+                      <a:endParaRPr lang="en-US" sz="800" dirty="0">
+                        <a:latin typeface="Arial" charset="0"/>
+                        <a:ea typeface="Arial" charset="0"/>
+                        <a:cs typeface="Arial" charset="0"/>
+                      </a:endParaRPr>
+                    </a:p>
+                    <a:p>
+                      <a:pPr marL="0" indent="0" algn="ctr">
+                        <a:buNone/>
+                      </a:pPr>
+                      <a:r>
+                        <a:rPr lang="en-US" sz="750" b="1" dirty="0" i="0">
+                          <a:solidFill>
+                            <a:srgbClr val="FFFFFF"/>
+                          </a:solidFill>
+                          <a:latin typeface="Arial" pitchFamily="34" charset="0"/>
+                          <a:ea typeface="Arial" pitchFamily="34" charset="-122"/>
+                          <a:cs typeface="Arial" pitchFamily="34" charset="-120"/>
+                        </a:rPr>
+                        <a:t>N2 · CRITICIDAD INTERMEDIA</a:t>
+                      </a:r>
+                      <a:endParaRPr lang="en-US" sz="800" dirty="0">
+                        <a:latin typeface="Arial" charset="0"/>
+                        <a:ea typeface="Arial" charset="0"/>
+                        <a:cs typeface="Arial" charset="0"/>
+                      </a:endParaRPr>
+                    </a:p>
+                  </a:txBody>
+                  <a:tcPr marL="50800" marR="50800" marT="25400" marB="25400" anchor="ctr">
+                    <a:lnL w="9525" cap="flat" cmpd="sng" algn="ctr">
+                      <a:solidFill>
+                        <a:srgbClr val="C9D3E0"/>
+                      </a:solidFill>
+                      <a:prstDash val="solid"/>
+                      <a:round/>
+                      <a:headEnd type="none" w="med" len="med"/>
+                      <a:tailEnd type="none" w="med" len="med"/>
+                    </a:lnL>
+                    <a:lnR w="9525" cap="flat" cmpd="sng" algn="ctr">
+                      <a:solidFill>
+                        <a:srgbClr val="C9D3E0"/>
+                      </a:solidFill>
+                      <a:prstDash val="solid"/>
+                      <a:round/>
+                      <a:headEnd type="none" w="med" len="med"/>
+                      <a:tailEnd type="none" w="med" len="med"/>
+                    </a:lnR>
+                    <a:lnT w="9525" cap="flat" cmpd="sng" algn="ctr">
+                      <a:solidFill>
+                        <a:srgbClr val="C9D3E0"/>
+                      </a:solidFill>
+                      <a:prstDash val="solid"/>
+                      <a:round/>
+                      <a:headEnd type="none" w="med" len="med"/>
+                      <a:tailEnd type="none" w="med" len="med"/>
+                    </a:lnT>
+                    <a:lnB w="9525" cap="flat" cmpd="sng" algn="ctr">
+                      <a:solidFill>
+                        <a:srgbClr val="C9D3E0"/>
+                      </a:solidFill>
+                      <a:prstDash val="solid"/>
+                      <a:round/>
+                      <a:headEnd type="none" w="med" len="med"/>
+                      <a:tailEnd type="none" w="med" len="med"/>
+                    </a:lnB>
+                    <a:solidFill>
+                      <a:srgbClr val="E67E22"/>
+                    </a:solidFill>
+                  </a:tcPr>
+                </a:tc>
+                <a:tc>
+                  <a:txBody>
+                    <a:bodyPr/>
+                    <a:lstStyle/>
+                    <a:p>
+                      <a:pPr marL="0" indent="0">
+                        <a:buNone/>
+                      </a:pPr>
+                      <a:r>
+                        <a:rPr lang="en-US" sz="630" b="1" i="1" dirty="0">
+                          <a:solidFill>
+                            <a:srgbClr val="7A8594"/>
+                          </a:solidFill>
+                          <a:latin typeface="Arial" pitchFamily="34" charset="0"/>
+                          <a:ea typeface="Arial" pitchFamily="34" charset="-122"/>
+                          <a:cs typeface="Arial" pitchFamily="34" charset="-120"/>
+                        </a:rPr>
+                        <a:t>[Tema del foco]. </a:t>
+                      </a:r>
+                      <a:r>
+                        <a:rPr lang="en-US" sz="630" i="1" dirty="0">
+                          <a:solidFill>
+                            <a:srgbClr val="7A8594"/>
+                          </a:solidFill>
+                          <a:latin typeface="Arial" pitchFamily="34" charset="0"/>
+                          <a:ea typeface="Arial" pitchFamily="34" charset="-122"/>
+                          <a:cs typeface="Arial" pitchFamily="34" charset="-120"/>
+                        </a:rPr>
+                        <a:t>[Verificar… qué se revisa, dónde y bajo qué estándar. Máx. 3 líneas]</a:t>
+                      </a:r>
+                      <a:endParaRPr lang="en-US" sz="630" dirty="0">
+                        <a:latin typeface="Arial" charset="0"/>
+                        <a:ea typeface="Arial" charset="0"/>
+                        <a:cs typeface="Arial" charset="0"/>
+                      </a:endParaRPr>
+                    </a:p>
+                    <a:p>
+                      <a:pPr marL="0" indent="0">
+                        <a:buNone/>
+                      </a:pPr>
+                      <a:r>
+                        <a:rPr lang="en-US" sz="630" b="1" dirty="0">
+                          <a:solidFill>
+                            <a:srgbClr val="B35C00"/>
+                          </a:solidFill>
+                          <a:latin typeface="Arial" pitchFamily="34" charset="0"/>
+                          <a:ea typeface="Arial" pitchFamily="34" charset="-122"/>
+                          <a:cs typeface="Arial" pitchFamily="34" charset="-120"/>
+                        </a:rPr>
+                        <a:t>Criterio de restricción: </a:t>
+                      </a:r>
+                      <a:r>
+                        <a:rPr lang="en-US" sz="630" i="1" dirty="0">
+                          <a:solidFill>
+                            <a:srgbClr val="7A8594"/>
+                          </a:solidFill>
+                          <a:latin typeface="Arial" pitchFamily="34" charset="0"/>
+                          <a:ea typeface="Arial" pitchFamily="34" charset="-122"/>
+                          <a:cs typeface="Arial" pitchFamily="34" charset="-120"/>
+                        </a:rPr>
+                        <a:t>[Cuándo se prohíbe o se detiene la tarea. Máx. 2 líneas]</a:t>
+                      </a:r>
+                      <a:endParaRPr lang="en-US" sz="630" dirty="0">
+                        <a:latin typeface="Arial" charset="0"/>
+                        <a:ea typeface="Arial" charset="0"/>
+                        <a:cs typeface="Arial" charset="0"/>
+                      </a:endParaRPr>
+                    </a:p>
+                  </a:txBody>
+                  <a:tcPr marL="50800" marR="50800" marT="25400" marB="25400" anchor="ctr">
+                    <a:lnL w="9525" cap="flat" cmpd="sng" algn="ctr">
+                      <a:solidFill>
+                        <a:srgbClr val="C9D3E0"/>
+                      </a:solidFill>
+                      <a:prstDash val="solid"/>
+                      <a:round/>
+                      <a:headEnd type="none" w="med" len="med"/>
+                      <a:tailEnd type="none" w="med" len="med"/>
+                    </a:lnL>
+                    <a:lnR w="9525" cap="flat" cmpd="sng" algn="ctr">
+                      <a:solidFill>
+                        <a:srgbClr val="C9D3E0"/>
+                      </a:solidFill>
+                      <a:prstDash val="solid"/>
+                      <a:round/>
+                      <a:headEnd type="none" w="med" len="med"/>
+                      <a:tailEnd type="none" w="med" len="med"/>
+                    </a:lnR>
+                    <a:lnT w="9525" cap="flat" cmpd="sng" algn="ctr">
+                      <a:solidFill>
+                        <a:srgbClr val="C9D3E0"/>
+                      </a:solidFill>
+                      <a:prstDash val="solid"/>
+                      <a:round/>
+                      <a:headEnd type="none" w="med" len="med"/>
+                      <a:tailEnd type="none" w="med" len="med"/>
+                    </a:lnT>
+                    <a:lnB w="9525" cap="flat" cmpd="sng" algn="ctr">
+                      <a:solidFill>
+                        <a:srgbClr val="C9D3E0"/>
+                      </a:solidFill>
+                      <a:prstDash val="solid"/>
+                      <a:round/>
+                      <a:headEnd type="none" w="med" len="med"/>
+                      <a:tailEnd type="none" w="med" len="med"/>
+                    </a:lnB>
+                    <a:solidFill>
+                      <a:srgbClr val="FFFFFF"/>
+                    </a:solidFill>
+                  </a:tcPr>
+                </a:tc>
+                <a:tc>
+                  <a:txBody>
+                    <a:bodyPr/>
+                    <a:lstStyle/>
+                    <a:p>
+                      <a:pPr marL="0" indent="0">
+                        <a:buNone/>
+                      </a:pPr>
+                      <a:r>
+                        <a:rPr lang="en-US" sz="620" b="1" dirty="0">
+                          <a:solidFill>
+                            <a:srgbClr val="222222"/>
+                          </a:solidFill>
+                          <a:latin typeface="Arial" pitchFamily="34" charset="0"/>
+                          <a:ea typeface="Arial" pitchFamily="34" charset="-122"/>
+                          <a:cs typeface="Arial" pitchFamily="34" charset="-120"/>
+                        </a:rPr>
+                        <a:t>TIPO ID [N°] – EECC:</a:t>
+                      </a:r>
+                      <a:r>
+                        <a:rPr lang="en-US" sz="620" i="1" dirty="0">
+                          <a:solidFill>
+                            <a:srgbClr val="7A8594"/>
+                          </a:solidFill>
+                          <a:latin typeface="Arial" pitchFamily="34" charset="0"/>
+                          <a:ea typeface="Arial" pitchFamily="34" charset="-122"/>
+                          <a:cs typeface="Arial" pitchFamily="34" charset="-120"/>
+                        </a:rPr>
+                        <a:t> [qué ocurrió, 1 línea]</a:t>
+                      </a:r>
+                      <a:endParaRPr lang="en-US" sz="620" dirty="0">
+                        <a:latin typeface="Arial" charset="0"/>
+                        <a:ea typeface="Arial" charset="0"/>
+                        <a:cs typeface="Arial" charset="0"/>
+                      </a:endParaRPr>
+                    </a:p>
+                    <a:p>
+                      <a:pPr marL="0" indent="0">
+                        <a:buNone/>
+                      </a:pPr>
+                      <a:r>
+                        <a:rPr lang="en-US" sz="620" b="1" dirty="0">
+                          <a:solidFill>
+                            <a:srgbClr val="222222"/>
+                          </a:solidFill>
+                          <a:latin typeface="Arial" pitchFamily="34" charset="0"/>
+                          <a:ea typeface="Arial" pitchFamily="34" charset="-122"/>
+                          <a:cs typeface="Arial" pitchFamily="34" charset="-120"/>
+                        </a:rPr>
+                        <a:t>TIPO ID [N°] – EECC:</a:t>
+                      </a:r>
+                      <a:r>
+                        <a:rPr lang="en-US" sz="620" i="1" dirty="0">
+                          <a:solidFill>
+                            <a:srgbClr val="7A8594"/>
+                          </a:solidFill>
+                          <a:latin typeface="Arial" pitchFamily="34" charset="0"/>
+                          <a:ea typeface="Arial" pitchFamily="34" charset="-122"/>
+                          <a:cs typeface="Arial" pitchFamily="34" charset="-120"/>
+                        </a:rPr>
+                        <a:t> [qué ocurrió, 1 línea]</a:t>
+                      </a:r>
+                      <a:endParaRPr lang="en-US" sz="620" dirty="0">
+                        <a:latin typeface="Arial" charset="0"/>
+                        <a:ea typeface="Arial" charset="0"/>
+                        <a:cs typeface="Arial" charset="0"/>
+                      </a:endParaRPr>
+                    </a:p>
+                  </a:txBody>
+                  <a:tcPr marL="50800" marR="50800" marT="25400" marB="25400" anchor="ctr">
+                    <a:lnL w="9525" cap="flat" cmpd="sng" algn="ctr">
+                      <a:solidFill>
+                        <a:srgbClr val="C9D3E0"/>
+                      </a:solidFill>
+                      <a:prstDash val="solid"/>
+                      <a:round/>
+                      <a:headEnd type="none" w="med" len="med"/>
+                      <a:tailEnd type="none" w="med" len="med"/>
+                    </a:lnL>
+                    <a:lnR w="9525" cap="flat" cmpd="sng" algn="ctr">
+                      <a:solidFill>
+                        <a:srgbClr val="C9D3E0"/>
+                      </a:solidFill>
+                      <a:prstDash val="solid"/>
+                      <a:round/>
+                      <a:headEnd type="none" w="med" len="med"/>
+                      <a:tailEnd type="none" w="med" len="med"/>
+                    </a:lnR>
+                    <a:lnT w="9525" cap="flat" cmpd="sng" algn="ctr">
+                      <a:solidFill>
+                        <a:srgbClr val="C9D3E0"/>
+                      </a:solidFill>
+                      <a:prstDash val="solid"/>
+                      <a:round/>
+                      <a:headEnd type="none" w="med" len="med"/>
+                      <a:tailEnd type="none" w="med" len="med"/>
+                    </a:lnT>
+                    <a:lnB w="9525" cap="flat" cmpd="sng" algn="ctr">
+                      <a:solidFill>
+                        <a:srgbClr val="C9D3E0"/>
+                      </a:solidFill>
+                      <a:prstDash val="solid"/>
+                      <a:round/>
+                      <a:headEnd type="none" w="med" len="med"/>
+                      <a:tailEnd type="none" w="med" len="med"/>
+                    </a:lnB>
+                    <a:solidFill>
+                      <a:srgbClr val="FFFFFF"/>
+                    </a:solidFill>
+                  </a:tcPr>
+                </a:tc>
+                <a:tc>
+                  <a:txBody>
+                    <a:bodyPr/>
+                    <a:lstStyle/>
+                    <a:p>
+                      <a:pPr marL="0" indent="0">
+                        <a:buNone/>
+                      </a:pPr>
+                      <a:r>
+                        <a:rPr lang="en-US" sz="630" i="1" dirty="0">
+                          <a:solidFill>
+                            <a:srgbClr val="7A8594"/>
+                          </a:solidFill>
+                          <a:latin typeface="Arial" pitchFamily="34" charset="0"/>
+                          <a:ea typeface="Arial" pitchFamily="34" charset="-122"/>
+                          <a:cs typeface="Arial" pitchFamily="34" charset="-120"/>
+                        </a:rPr>
+                        <a:t>[Herramienta + herramienta + ASP]</a:t>
+                      </a:r>
+                      <a:endParaRPr lang="en-US" sz="630" dirty="0">
+                        <a:latin typeface="Arial" charset="0"/>
+                        <a:ea typeface="Arial" charset="0"/>
+                        <a:cs typeface="Arial" charset="0"/>
+                      </a:endParaRPr>
+                    </a:p>
+                  </a:txBody>
+                  <a:tcPr marL="50800" marR="50800" marT="25400" marB="25400" anchor="ctr">
+                    <a:lnL w="9525" cap="flat" cmpd="sng" algn="ctr">
+                      <a:solidFill>
+                        <a:srgbClr val="C9D3E0"/>
+                      </a:solidFill>
+                      <a:prstDash val="solid"/>
+                      <a:round/>
+                      <a:headEnd type="none" w="med" len="med"/>
+                      <a:tailEnd type="none" w="med" len="med"/>
+                    </a:lnL>
+                    <a:lnR w="9525" cap="flat" cmpd="sng" algn="ctr">
+                      <a:solidFill>
+                        <a:srgbClr val="C9D3E0"/>
+                      </a:solidFill>
+                      <a:prstDash val="solid"/>
+                      <a:round/>
+                      <a:headEnd type="none" w="med" len="med"/>
+                      <a:tailEnd type="none" w="med" len="med"/>
+                    </a:lnR>
+                    <a:lnT w="9525" cap="flat" cmpd="sng" algn="ctr">
+                      <a:solidFill>
+                        <a:srgbClr val="C9D3E0"/>
+                      </a:solidFill>
+                      <a:prstDash val="solid"/>
+                      <a:round/>
+                      <a:headEnd type="none" w="med" len="med"/>
+                      <a:tailEnd type="none" w="med" len="med"/>
+                    </a:lnT>
+                    <a:lnB w="9525" cap="flat" cmpd="sng" algn="ctr">
+                      <a:solidFill>
+                        <a:srgbClr val="C9D3E0"/>
+                      </a:solidFill>
+                      <a:prstDash val="solid"/>
+                      <a:round/>
+                      <a:headEnd type="none" w="med" len="med"/>
+                      <a:tailEnd type="none" w="med" len="med"/>
+                    </a:lnB>
+                    <a:solidFill>
+                      <a:srgbClr val="FFFFFF"/>
+                    </a:solidFill>
+                  </a:tcPr>
+                </a:tc>
+                <a:tc>
+                  <a:txBody>
+                    <a:bodyPr/>
+                    <a:lstStyle/>
+                    <a:p>
+                      <a:pPr marL="0" indent="0">
+                        <a:buNone/>
+                      </a:pPr>
+                      <a:r>
+                        <a:rPr lang="en-US" sz="630" i="1" dirty="0">
+                          <a:solidFill>
+                            <a:srgbClr val="7A8594"/>
+                          </a:solidFill>
+                          <a:latin typeface="Arial" pitchFamily="34" charset="0"/>
+                          <a:ea typeface="Arial" pitchFamily="34" charset="-122"/>
+                          <a:cs typeface="Arial" pitchFamily="34" charset="-120"/>
+                        </a:rPr>
+                        <a:t>[Registro verificable] / registro fotográfico</a:t>
+                      </a:r>
+                      <a:endParaRPr lang="en-US" sz="630" dirty="0">
+                        <a:latin typeface="Arial" charset="0"/>
+                        <a:ea typeface="Arial" charset="0"/>
+                        <a:cs typeface="Arial" charset="0"/>
+                      </a:endParaRPr>
+                    </a:p>
+                  </a:txBody>
+                  <a:tcPr marL="50800" marR="50800" marT="25400" marB="25400" anchor="ctr">
+                    <a:lnL w="9525" cap="flat" cmpd="sng" algn="ctr">
+                      <a:solidFill>
+                        <a:srgbClr val="C9D3E0"/>
+                      </a:solidFill>
+                      <a:prstDash val="solid"/>
+                      <a:round/>
+                      <a:headEnd type="none" w="med" len="med"/>
+                      <a:tailEnd type="none" w="med" len="med"/>
+                    </a:lnL>
+                    <a:lnR w="9525" cap="flat" cmpd="sng" algn="ctr">
+                      <a:solidFill>
+                        <a:srgbClr val="C9D3E0"/>
+                      </a:solidFill>
+                      <a:prstDash val="solid"/>
+                      <a:round/>
+                      <a:headEnd type="none" w="med" len="med"/>
+                      <a:tailEnd type="none" w="med" len="med"/>
+                    </a:lnR>
+                    <a:lnT w="9525" cap="flat" cmpd="sng" algn="ctr">
+                      <a:solidFill>
+                        <a:srgbClr val="C9D3E0"/>
+                      </a:solidFill>
+                      <a:prstDash val="solid"/>
+                      <a:round/>
+                      <a:headEnd type="none" w="med" len="med"/>
+                      <a:tailEnd type="none" w="med" len="med"/>
+                    </a:lnT>
+                    <a:lnB w="9525" cap="flat" cmpd="sng" algn="ctr">
+                      <a:solidFill>
+                        <a:srgbClr val="C9D3E0"/>
+                      </a:solidFill>
+                      <a:prstDash val="solid"/>
+                      <a:round/>
+                      <a:headEnd type="none" w="med" len="med"/>
+                      <a:tailEnd type="none" w="med" len="med"/>
+                    </a:lnB>
+                    <a:solidFill>
+                      <a:srgbClr val="FFFFFF"/>
+                    </a:solidFill>
+                  </a:tcPr>
+                </a:tc>
+                <a:extLst>
+                  <a:ext uri="{0D108BD9-81ED-4DB2-BD59-A6C34878D82A}">
+                    <a16:rowId xmlns:a16="http://schemas.microsoft.com/office/drawing/2014/main" val="10005"/>
+                  </a:ext>
+                </a:extLst>
+              </a:tr>
+              <a:tr h="713232">
                 <a:tc>
                   <a:txBody>
                     <a:bodyPr/>
@@ -4127,7 +4581,7 @@
                           <a:ea typeface="Arial" charset="0"/>
                           <a:cs typeface="Arial" pitchFamily="34" charset="-120"/>
                         </a:rPr>
-                        <a:t>5</a:t>
+                        <a:t>6</a:t>
                       </a:r>
                       <a:endParaRPr lang="en-US" sz="800" dirty="0">
                         <a:latin typeface="Arial" charset="0"/>
@@ -4917,7 +5371,7 @@
         </p:nvSpPr>
         <p:spPr>
           <a:xfrm>
-            <a:off x="365760" y="5852160"/>
+            <a:off x="365760" y="5943600"/>
             <a:ext cx="960120" cy="292608"/>
           </a:xfrm>
           <a:prstGeom prst="rect">
@@ -4958,7 +5412,7 @@
         </p:nvSpPr>
         <p:spPr>
           <a:xfrm>
-            <a:off x="1325880" y="5852160"/>
+            <a:off x="1325880" y="5943600"/>
             <a:ext cx="10497312" cy="292608"/>
           </a:xfrm>
           <a:prstGeom prst="rect">
@@ -4990,7 +5444,7 @@
         </p:nvSpPr>
         <p:spPr>
           <a:xfrm>
-            <a:off x="1417320" y="5852160"/>
+            <a:off x="1417320" y="5943600"/>
             <a:ext cx="10314432" cy="292608"/>
           </a:xfrm>
           <a:prstGeom prst="rect">
@@ -5062,7 +5516,7 @@
         </p:nvSpPr>
         <p:spPr>
           <a:xfrm>
-            <a:off x="365760" y="6236208"/>
+            <a:off x="365760" y="6327648"/>
             <a:ext cx="6172200" cy="219456"/>
           </a:xfrm>
           <a:prstGeom prst="rect">
@@ -5094,7 +5548,7 @@
         </p:nvSpPr>
         <p:spPr>
           <a:xfrm>
-            <a:off x="457200" y="6236208"/>
+            <a:off x="457200" y="6327648"/>
             <a:ext cx="5989320" cy="219456"/>
           </a:xfrm>
           <a:prstGeom prst="rect">
@@ -5141,7 +5595,7 @@
         </p:blipFill>
         <p:spPr>
           <a:xfrm>
-            <a:off x="438912" y="6528816"/>
+            <a:off x="438912" y="6620256"/>
             <a:ext cx="219456" cy="219456"/>
           </a:xfrm>
           <a:prstGeom prst="rect">
@@ -5157,7 +5611,7 @@
         </p:nvSpPr>
         <p:spPr>
           <a:xfrm>
-            <a:off x="694944" y="6510528"/>
+            <a:off x="694944" y="6601968"/>
             <a:ext cx="1673352" cy="256032"/>
           </a:xfrm>
           <a:prstGeom prst="rect">
@@ -5196,7 +5650,7 @@
         </p:nvSpPr>
         <p:spPr>
           <a:xfrm>
-            <a:off x="438912" y="6784848"/>
+            <a:off x="438912" y="6876288"/>
             <a:ext cx="1911096" cy="274320"/>
           </a:xfrm>
           <a:prstGeom prst="rect">
@@ -5235,7 +5689,7 @@
         </p:nvSpPr>
         <p:spPr>
           <a:xfrm>
-            <a:off x="438912" y="7077456"/>
+            <a:off x="438912" y="7168896"/>
             <a:ext cx="1911096" cy="786384"/>
           </a:xfrm>
           <a:prstGeom prst="rect">
@@ -5317,7 +5771,7 @@
         </p:nvSpPr>
         <p:spPr>
           <a:xfrm>
-            <a:off x="2423160" y="6556248"/>
+            <a:off x="2423160" y="6647688"/>
             <a:ext cx="9144" cy="1280160"/>
           </a:xfrm>
           <a:prstGeom prst="rect">
@@ -5357,7 +5811,7 @@
         </p:blipFill>
         <p:spPr>
           <a:xfrm>
-            <a:off x="2496312" y="6528816"/>
+            <a:off x="2496312" y="6620256"/>
             <a:ext cx="219456" cy="219456"/>
           </a:xfrm>
           <a:prstGeom prst="rect">
@@ -5373,7 +5827,7 @@
         </p:nvSpPr>
         <p:spPr>
           <a:xfrm>
-            <a:off x="2752344" y="6510528"/>
+            <a:off x="2752344" y="6601968"/>
             <a:ext cx="1673352" cy="256032"/>
           </a:xfrm>
           <a:prstGeom prst="rect">
@@ -5412,7 +5866,7 @@
         </p:nvSpPr>
         <p:spPr>
           <a:xfrm>
-            <a:off x="2496312" y="6784848"/>
+            <a:off x="2496312" y="6876288"/>
             <a:ext cx="1911096" cy="274320"/>
           </a:xfrm>
           <a:prstGeom prst="rect">
@@ -5451,7 +5905,7 @@
         </p:nvSpPr>
         <p:spPr>
           <a:xfrm>
-            <a:off x="2496312" y="7077456"/>
+            <a:off x="2496312" y="7168896"/>
             <a:ext cx="1911096" cy="786384"/>
           </a:xfrm>
           <a:prstGeom prst="rect">
@@ -5533,7 +5987,7 @@
         </p:nvSpPr>
         <p:spPr>
           <a:xfrm>
-            <a:off x="4480560" y="6556248"/>
+            <a:off x="4480560" y="6647688"/>
             <a:ext cx="9144" cy="1280160"/>
           </a:xfrm>
           <a:prstGeom prst="rect">
@@ -5573,7 +6027,7 @@
         </p:blipFill>
         <p:spPr>
           <a:xfrm>
-            <a:off x="4553712" y="6528816"/>
+            <a:off x="4553712" y="6620256"/>
             <a:ext cx="219456" cy="219456"/>
           </a:xfrm>
           <a:prstGeom prst="rect">
@@ -5589,7 +6043,7 @@
         </p:nvSpPr>
         <p:spPr>
           <a:xfrm>
-            <a:off x="4809744" y="6510528"/>
+            <a:off x="4809744" y="6601968"/>
             <a:ext cx="1673352" cy="256032"/>
           </a:xfrm>
           <a:prstGeom prst="rect">
@@ -5628,7 +6082,7 @@
         </p:nvSpPr>
         <p:spPr>
           <a:xfrm>
-            <a:off x="4553712" y="6784848"/>
+            <a:off x="4553712" y="6876288"/>
             <a:ext cx="1911096" cy="274320"/>
           </a:xfrm>
           <a:prstGeom prst="rect">
@@ -5667,7 +6121,7 @@
         </p:nvSpPr>
         <p:spPr>
           <a:xfrm>
-            <a:off x="4553712" y="7077456"/>
+            <a:off x="4553712" y="7168896"/>
             <a:ext cx="1911096" cy="786384"/>
           </a:xfrm>
           <a:prstGeom prst="rect">
@@ -5749,7 +6203,7 @@
         </p:nvSpPr>
         <p:spPr>
           <a:xfrm>
-            <a:off x="6680200" y="6236208"/>
+            <a:off x="6680200" y="6327648"/>
             <a:ext cx="2527300" cy="1645920"/>
           </a:xfrm>
           <a:prstGeom prst="roundRect">
@@ -5783,7 +6237,7 @@
         </p:nvSpPr>
         <p:spPr>
           <a:xfrm>
-            <a:off x="6715760" y="6248579"/>
+            <a:off x="6715760" y="6340019"/>
             <a:ext cx="2387600" cy="310896"/>
           </a:xfrm>
           <a:prstGeom prst="rect">
@@ -5822,7 +6276,7 @@
         </p:nvSpPr>
         <p:spPr>
           <a:xfrm>
-            <a:off x="6743700" y="6620256"/>
+            <a:off x="6743700" y="6711696"/>
             <a:ext cx="2400300" cy="1207008"/>
           </a:xfrm>
           <a:prstGeom prst="rect">
@@ -5949,7 +6403,7 @@
         </p:nvSpPr>
         <p:spPr>
           <a:xfrm>
-            <a:off x="9296400" y="6236208"/>
+            <a:off x="9296400" y="6327648"/>
             <a:ext cx="2527300" cy="1645920"/>
           </a:xfrm>
           <a:prstGeom prst="roundRect">
@@ -5983,7 +6437,7 @@
         </p:nvSpPr>
         <p:spPr>
           <a:xfrm>
-            <a:off x="9372600" y="6272784"/>
+            <a:off x="9372600" y="6364224"/>
             <a:ext cx="2387600" cy="310896"/>
           </a:xfrm>
           <a:prstGeom prst="rect">
@@ -6022,7 +6476,7 @@
         </p:nvSpPr>
         <p:spPr>
           <a:xfrm>
-            <a:off x="9372600" y="6620256"/>
+            <a:off x="9372600" y="6711696"/>
             <a:ext cx="2400300" cy="1207008"/>
           </a:xfrm>
           <a:prstGeom prst="rect">
@@ -6776,7 +7230,7 @@
                 <a:ea typeface="Arial" pitchFamily="34" charset="-122"/>
                 <a:cs typeface="Arial" pitchFamily="34" charset="-120"/>
               </a:rPr>
-              <a:t>3. SELECCIÓN DE FOCOS (filas 1 a 4)</a:t>
+              <a:t>3. SELECCIÓN DE FOCOS (filas 1 a 5)</a:t>
             </a:r>
             <a:endParaRPr lang="en-US" sz="600" dirty="0"/>
           </a:p>
@@ -6878,24 +7332,24 @@
                 <a:ea typeface="Arial" pitchFamily="34" charset="-122"/>
                 <a:cs typeface="Arial" pitchFamily="34" charset="-120"/>
               </a:rPr>
-              <a:t>- FOCO DE SOLO HBP: solo si hay 3 o más HBP del período relacionados con la misma brecha y que no estén ya en otro foco. Con 1 o 2 HBP de un tema NUNCA se arma un foco (van como evidencia complementaria o en Recurrente). Estos focos son siempre N2, van después de todos los focos con eventos N1/N2 y solo entran si queda una fila libre (máx. 4 focos). Si hay varios temas HBP que califican, entra primero el de más HBP y, si empatan, el asociado a control crítico o emergencia. OJO: la gerencia al 08-09 puso un foco con solo 2 HBP (extintores); según esta regla ese foco NO va.</a:t>
-            </a:r>
-            <a:endParaRPr lang="en-US" sz="600" dirty="0"/>
-          </a:p>
-          <a:p>
-            <a:pPr marL="0" indent="0">
-              <a:buNone/>
-            </a:pPr>
-            <a:r>
-              <a:rPr lang="en-US" sz="600" dirty="0">
-                <a:solidFill>
-                  <a:srgbClr val="222222"/>
-                </a:solidFill>
-                <a:latin typeface="Arial" pitchFamily="34" charset="0"/>
-                <a:ea typeface="Arial" pitchFamily="34" charset="-122"/>
-                <a:cs typeface="Arial" pitchFamily="34" charset="-120"/>
-              </a:rPr>
-              <a:t>- Máximo 4 focos + la fila fija "FOCO – SI PRO – ESTRATEGIA DE CONTROLES" (5 filas en total). Si hay más, se quedan los de mayor PRIORIDAD (punto 4) y se informa al usuario cuáles quedaron fuera. Si hay menos, elimina las filas sobrantes (nunca la fila SI PRO).</a:t>
+              <a:t>- FOCO DE SOLO HBP: solo si hay 3 o más HBP del período relacionados con la misma brecha y que no estén ya en otro foco. Con 1 o 2 HBP de un tema NUNCA se arma un foco (van como evidencia complementaria o en Recurrente). Estos focos son siempre N2, van después de todos los focos con eventos N1/N2 y solo entran si queda una fila libre (máx. 5 focos). Si hay varios temas HBP que califican, entra primero el de más HBP y, si empatan, el asociado a control crítico o emergencia. OJO: la gerencia al 08-09 puso un foco con solo 2 HBP (extintores); según esta regla ese foco NO va.</a:t>
+            </a:r>
+            <a:endParaRPr lang="en-US" sz="600" dirty="0"/>
+          </a:p>
+          <a:p>
+            <a:pPr marL="0" indent="0">
+              <a:buNone/>
+            </a:pPr>
+            <a:r>
+              <a:rPr lang="en-US" sz="600" dirty="0">
+                <a:solidFill>
+                  <a:srgbClr val="222222"/>
+                </a:solidFill>
+                <a:latin typeface="Arial" pitchFamily="34" charset="0"/>
+                <a:ea typeface="Arial" pitchFamily="34" charset="-122"/>
+                <a:cs typeface="Arial" pitchFamily="34" charset="-120"/>
+              </a:rPr>
+              <a:t>- Máximo 5 focos, SIN contar la fila fija "FOCO – SI PRO – ESTRATEGIA DE CONTROLES" (hasta 5 focos + la fila SI PRO = 6 filas en total). Si hay más, se quedan los de mayor PRIORIDAD (punto 4) y se informa al usuario cuáles quedaron fuera. Si hay menos, elimina las filas sobrantes (nunca la fila SI PRO).</a:t>
             </a:r>
             <a:endParaRPr lang="en-US" sz="600" dirty="0"/>
           </a:p>
@@ -7524,41 +7978,41 @@
                 <a:ea typeface="Arial" pitchFamily="34" charset="-122"/>
                 <a:cs typeface="Arial" pitchFamily="34" charset="-120"/>
               </a:rPr>
-              <a:t>- NO TE DEJES LLEVAR POR LA ESTRUCTURA DE LA PLANTILLA: las filas 1 y 2 vienen en rojo (N1) y las filas 3 y 4 en naranja (N2) SOLO como ejemplo visual de los colores. NO es una cantidad a respetar ni un cupo por nivel. Tú determinas cuántos N1 y cuántos N2 hay, y el nivel y el color de cada fila salen SOLO de los eventos de su foco. La cantidad de N1 y N2 es la que resulte de los datos, sin importar cuántas filas haya (p. ej.: 4 N1 y 0 N2; 3 N1 y 1 N2; 1 N1 y 3 N2; 0 N1 y 2 N2).</a:t>
-            </a:r>
-            <a:endParaRPr lang="en-US" sz="600" dirty="0"/>
-          </a:p>
-          <a:p>
-            <a:pPr marL="0" indent="0">
-              <a:buNone/>
-            </a:pPr>
-            <a:r>
-              <a:rPr lang="en-US" sz="600" dirty="0">
-                <a:solidFill>
-                  <a:srgbClr val="222222"/>
-                </a:solidFill>
-                <a:latin typeface="Arial" pitchFamily="34" charset="0"/>
-                <a:ea typeface="Arial" pitchFamily="34" charset="-122"/>
-                <a:cs typeface="Arial" pitchFamily="34" charset="-120"/>
-              </a:rPr>
-              <a:t>- Nunca bajes un foco a N2 ni subas uno a N1 para llenar filas o "equilibrar" la lámina. Si hay más de 4 focos, entran los 4 de mayor prioridad (todo N1 antes que N2): si existen 5 focos N1, las 4 filas serán N1 y se informa al usuario el N1 que quedó fuera.</a:t>
-            </a:r>
-            <a:endParaRPr lang="en-US" sz="600" dirty="0"/>
-          </a:p>
-          <a:p>
-            <a:pPr marL="0" indent="0">
-              <a:buNone/>
-            </a:pPr>
-            <a:r>
-              <a:rPr lang="en-US" sz="600" dirty="0">
-                <a:solidFill>
-                  <a:srgbClr val="222222"/>
-                </a:solidFill>
-                <a:latin typeface="Arial" pitchFamily="34" charset="0"/>
-                <a:ea typeface="Arial" pitchFamily="34" charset="-122"/>
-                <a:cs typeface="Arial" pitchFamily="34" charset="-120"/>
-              </a:rPr>
-              <a:t>- Celda de nivel: número de prioridad + "N1 · CRITICIDAD ALTA" (relleno rojo C62828, texto blanco) o "N2 · CRITICIDAD INTERMEDIA" (relleno naranja E67E22, texto blanco). Cambia el texto y el color de cada celda según corresponda, aunque eso modifique la distribución de ejemplo (2 N1 + 2 N2).</a:t>
+              <a:t>- NO TE DEJES LLEVAR POR LA ESTRUCTURA DE LA PLANTILLA: las filas 1 y 2 vienen en rojo (N1) y las filas 3, 4 y 5 en naranja (N2) SOLO como ejemplo visual de los colores. NO es una cantidad a respetar ni un cupo por nivel. Tú determinas cuántos N1 y cuántos N2 hay, y el nivel y el color de cada fila salen SOLO de los eventos de su foco. La cantidad de N1 y N2 es la que resulte de los datos, sin importar cuántas filas haya (p. ej.: 4 N1 y 0 N2; 3 N1 y 1 N2; 1 N1 y 3 N2; 0 N1 y 2 N2).</a:t>
+            </a:r>
+            <a:endParaRPr lang="en-US" sz="600" dirty="0"/>
+          </a:p>
+          <a:p>
+            <a:pPr marL="0" indent="0">
+              <a:buNone/>
+            </a:pPr>
+            <a:r>
+              <a:rPr lang="en-US" sz="600" dirty="0">
+                <a:solidFill>
+                  <a:srgbClr val="222222"/>
+                </a:solidFill>
+                <a:latin typeface="Arial" pitchFamily="34" charset="0"/>
+                <a:ea typeface="Arial" pitchFamily="34" charset="-122"/>
+                <a:cs typeface="Arial" pitchFamily="34" charset="-120"/>
+              </a:rPr>
+              <a:t>- Nunca bajes un foco a N2 ni subas uno a N1 para llenar filas o "equilibrar" la lámina. Si hay más de 5 focos, entran los 5 de mayor prioridad (todo N1 antes que N2): si existen 6 focos N1, las 5 filas serán N1 y se informa al usuario el N1 que quedó fuera.</a:t>
+            </a:r>
+            <a:endParaRPr lang="en-US" sz="600" dirty="0"/>
+          </a:p>
+          <a:p>
+            <a:pPr marL="0" indent="0">
+              <a:buNone/>
+            </a:pPr>
+            <a:r>
+              <a:rPr lang="en-US" sz="600" dirty="0">
+                <a:solidFill>
+                  <a:srgbClr val="222222"/>
+                </a:solidFill>
+                <a:latin typeface="Arial" pitchFamily="34" charset="0"/>
+                <a:ea typeface="Arial" pitchFamily="34" charset="-122"/>
+                <a:cs typeface="Arial" pitchFamily="34" charset="-120"/>
+              </a:rPr>
+              <a:t>- Celda de nivel: número de prioridad + "N1 · CRITICIDAD ALTA" (relleno rojo C62828, texto blanco) o "N2 · CRITICIDAD INTERMEDIA" (relleno naranja E67E22, texto blanco). Cambia el texto y el color de cada celda según corresponda, aunque eso modifique la distribución de ejemplo (2 N1 + 3 N2).</a:t>
             </a:r>
             <a:endParaRPr lang="en-US" sz="600" dirty="0"/>
           </a:p>
@@ -7592,7 +8046,7 @@
                 <a:ea typeface="Arial" pitchFamily="34" charset="-122"/>
                 <a:cs typeface="Arial" pitchFamily="34" charset="-120"/>
               </a:rPr>
-              <a:t>5. FILA SI PRO – FOCO SI PRO · ESTRATEGIA DE CONTROLES (última fila, N° 5, fija, gris; no cuenta dentro de los 4 focos)</a:t>
+              <a:t>5. FILA SI PRO – FOCO SI PRO · ESTRATEGIA DE CONTROLES (última fila, N° 6, fija, gris; no cuenta dentro de los 5 focos)</a:t>
             </a:r>
             <a:endParaRPr lang="en-US" sz="600" dirty="0"/>
           </a:p>
@@ -8391,7 +8845,7 @@
                 <a:ea typeface="Arial" pitchFamily="34" charset="-122"/>
                 <a:cs typeface="Arial" pitchFamily="34" charset="-120"/>
               </a:rPr>
-              <a:t>- Si no puedes: entrega el contenido en texto, ordenado por sección y por fila de la plantilla (Encabezado; Indicadores 14 días; Focos 1 a 4 con sus 5 columnas; Fila SI PRO; Recurrente; Bloques AM/Mediodía/PM; Tendencias no asociadas; Tendencias asociadas a controles críticos), listo para copiar y pegar en cada casilla.</a:t>
+              <a:t>- Si no puedes: entrega el contenido en texto, ordenado por sección y por fila de la plantilla (Encabezado; Indicadores 14 días; Focos 1 a 5 con sus 5 columnas; Fila SI PRO; Recurrente; Bloques AM/Mediodía/PM; Tendencias no asociadas; Tendencias asociadas a controles críticos), listo para copiar y pegar en cada casilla.</a:t>
             </a:r>
             <a:endParaRPr lang="en-US" sz="600" dirty="0"/>
           </a:p>
@@ -8527,7 +8981,7 @@
                 <a:ea typeface="Arial" pitchFamily="34" charset="-122"/>
                 <a:cs typeface="Arial" pitchFamily="34" charset="-120"/>
               </a:rPr>
-              <a:t>Antes de entregar, confirma que: el título dice "ASSURANCE TURNO 1-3" o "ASSURANCE TURNO 2-4" (sin corchetes); cada ID existe en el Excel; el nivel de cada foco sigue el punto 4 (2 o más eventos N1/N2 = N1; los HBP nunca suben un foco a N1); la cantidad de N1 y N2 salió de los eventos y no de la distribución de ejemplo de la plantilla (2 N1 + 2 N2); las áreas son nombres exactos de AREA_GEO; revisaste los eventos abiertos a la fecha de cierre; leíste la descripción de todos los eventos y aplicaste la revaloración del punto 4; cada foco nace de al menos un evento N1/N2, salvo los focos de solo HBP, que tienen 3 o más HBP del mismo tema; todos los focos N1 van antes que los N2; dentro de cada nivel, los focos con reiteración/evidencia van antes que los aislados y se ordenan como indica el punto 4; ningún tema se llama "Otro"; los eventos con riesgo "Otro" fueron asignados a un tema leyendo su descripción; cada foco contiene al menos un dato concreto de sus eventos; el NIVEL (color) y la PRIORIDAD (orden) de cada foco siguen el punto 4; ningún HBP definió un nivel; los conteos de indicadores y Recurrente cuadran; y no quedan textos guía.</a:t>
+              <a:t>Antes de entregar, confirma que: el título dice "ASSURANCE TURNO 1-3" o "ASSURANCE TURNO 2-4" (sin corchetes); cada ID existe en el Excel; el nivel de cada foco sigue el punto 4 (2 o más eventos N1/N2 = N1; los HBP nunca suben un foco a N1); la cantidad de N1 y N2 salió de los eventos y no de la distribución de ejemplo de la plantilla (2 N1 + 3 N2); las áreas son nombres exactos de AREA_GEO; revisaste los eventos abiertos a la fecha de cierre; leíste la descripción de todos los eventos y aplicaste la revaloración del punto 4; cada foco nace de al menos un evento N1/N2, salvo los focos de solo HBP, que tienen 3 o más HBP del mismo tema; todos los focos N1 van antes que los N2; dentro de cada nivel, los focos con reiteración/evidencia van antes que los aislados y se ordenan como indica el punto 4; ningún tema se llama "Otro"; los eventos con riesgo "Otro" fueron asignados a un tema leyendo su descripción; cada foco contiene al menos un dato concreto de sus eventos; el NIVEL (color) y la PRIORIDAD (orden) de cada foco siguen el punto 4; ningún HBP definió un nivel; los conteos de indicadores y Recurrente cuadran; y no quedan textos guía.</a:t>
             </a:r>
             <a:endParaRPr lang="en-US" sz="600" dirty="0"/>
           </a:p>
@@ -10571,7 +11025,7 @@
                 <a:ea typeface="Arial" pitchFamily="34" charset="-122"/>
                 <a:cs typeface="Arial" pitchFamily="34" charset="-120"/>
               </a:rPr>
-              <a:t>Foco = brecha específica con eventos N1/N2; HBP del mismo tema = evidencia. 3+ HBP del mismo tema = foco N2 si queda fila. Orden: todo N1 → todo N2. En N1: reiterados, luego más grave. En N2: con evento N1/N2, luego más eventos. Máx. 4 focos + fila SI PRO (5 filas).</a:t>
+              <a:t>Foco = brecha específica con eventos N1/N2; HBP del mismo tema = evidencia. 3+ HBP del mismo tema = foco N2 si queda fila. Orden: todo N1 → todo N2. En N1: reiterados, luego más grave. En N2: con evento N1/N2, luego más eventos. Máx. 5 focos, sin contar SI PRO.</a:t>
             </a:r>
             <a:endParaRPr lang="en-US" sz="930" dirty="0"/>
           </a:p>
@@ -10754,7 +11208,7 @@
                 <a:ea typeface="Arial" pitchFamily="34" charset="-122"/>
                 <a:cs typeface="Arial" pitchFamily="34" charset="-120"/>
               </a:rPr>
-              <a:t>Las 2 filas N1 y 2 N2 son solo ejemplo: la cantidad la definen los eventos. N1 (roja): ACC, CAAP, CA o 2+ HAP/CBP del mismo tema. N2 (naranja): 1 HAP o CBP (+ HBP) o 3+ HBP. Un CAAP siempre es N1; los HBP nunca suben a N1.</a:t>
+              <a:t>Las 2 filas N1 y 3 N2 son solo ejemplo: la cantidad la definen los eventos. N1 (roja): ACC, CAAP, CA o 2+ HAP/CBP del mismo tema. N2 (naranja): 1 HAP o CBP (+ HBP) o 3+ HBP. Un CAAP siempre es N1; los HBP nunca suben a N1.</a:t>
             </a:r>
             <a:endParaRPr lang="en-US" sz="930" dirty="0"/>
           </a:p>
@@ -12483,7 +12937,7 @@
                 <a:ea typeface="Arial" pitchFamily="34" charset="-122"/>
                 <a:cs typeface="Arial" pitchFamily="34" charset="-120"/>
               </a:rPr>
-              <a:t>Si el texto no cabe, resumir: letra mínima 6 pt. Si hay menos de 4 focos, eliminar la fila sobrante (clic derecho › Eliminar fila). La fila 5 SI PRO no se elimina.</a:t>
+              <a:t>Máximo 5 focos, sin contar la fila SI PRO. Si hay menos, eliminar las filas sobrantes (clic derecho › Eliminar fila); la fila SI PRO no se elimina. Letra mínima 6 pt: si no cabe, resumir.</a:t>
             </a:r>
             <a:endParaRPr lang="en-US" sz="930" dirty="0"/>
           </a:p>

</xml_diff>